<commit_message>
fix: polish TrustRoom submission deck
</commit_message>
<xml_diff>
--- a/docs/submission-assets/rfp-trustroom-submission-deck.pptx
+++ b/docs/submission-assets/rfp-trustroom-submission-deck.pptx
@@ -2,20 +2,20 @@
 <file path=ppt/presentation.xml><?xml version="1.0" encoding="utf-8"?>
 <p:presentation xmlns:p="http://schemas.openxmlformats.org/presentationml/2006/main">
   <p:sldMasterIdLst>
-    <p:sldMasterId xmlns:r="http://schemas.openxmlformats.org/officeDocument/2006/relationships" id="2147483648" r:id="R066f10bf210d40b1"/>
+    <p:sldMasterId xmlns:r="http://schemas.openxmlformats.org/officeDocument/2006/relationships" id="2147483648" r:id="R000b3215d9e34abc"/>
   </p:sldMasterIdLst>
   <p:notesMasterIdLst>
-    <p:notesMasterId xmlns:r="http://schemas.openxmlformats.org/officeDocument/2006/relationships" r:id="Ref5cd71f8cdc4c14"/>
+    <p:notesMasterId xmlns:r="http://schemas.openxmlformats.org/officeDocument/2006/relationships" r:id="R085c06d36dfd4ba5"/>
   </p:notesMasterIdLst>
   <p:sldIdLst>
-    <p:sldId xmlns:r="http://schemas.openxmlformats.org/officeDocument/2006/relationships" id="256" r:id="R381cb47f5fdf4ba3"/>
-    <p:sldId xmlns:r="http://schemas.openxmlformats.org/officeDocument/2006/relationships" id="257" r:id="Re3ed4c9ec47a4fd3"/>
-    <p:sldId xmlns:r="http://schemas.openxmlformats.org/officeDocument/2006/relationships" id="258" r:id="Rdb922a9dd93e48d9"/>
-    <p:sldId xmlns:r="http://schemas.openxmlformats.org/officeDocument/2006/relationships" id="259" r:id="R79cbd9ca22814afe"/>
-    <p:sldId xmlns:r="http://schemas.openxmlformats.org/officeDocument/2006/relationships" id="260" r:id="R2c6e39e11e064d62"/>
-    <p:sldId xmlns:r="http://schemas.openxmlformats.org/officeDocument/2006/relationships" id="261" r:id="Rd818eac22d094640"/>
-    <p:sldId xmlns:r="http://schemas.openxmlformats.org/officeDocument/2006/relationships" id="262" r:id="R9c87d43040f54a7b"/>
-    <p:sldId xmlns:r="http://schemas.openxmlformats.org/officeDocument/2006/relationships" id="263" r:id="R53f5a1cd0c444903"/>
+    <p:sldId xmlns:r="http://schemas.openxmlformats.org/officeDocument/2006/relationships" id="256" r:id="R15040264448047b3"/>
+    <p:sldId xmlns:r="http://schemas.openxmlformats.org/officeDocument/2006/relationships" id="257" r:id="Raf6399b4864948b9"/>
+    <p:sldId xmlns:r="http://schemas.openxmlformats.org/officeDocument/2006/relationships" id="258" r:id="Re427276330a04204"/>
+    <p:sldId xmlns:r="http://schemas.openxmlformats.org/officeDocument/2006/relationships" id="259" r:id="Rbc282be1721e4478"/>
+    <p:sldId xmlns:r="http://schemas.openxmlformats.org/officeDocument/2006/relationships" id="260" r:id="R0362062d69264da3"/>
+    <p:sldId xmlns:r="http://schemas.openxmlformats.org/officeDocument/2006/relationships" id="261" r:id="Reccb6d19679c45f4"/>
+    <p:sldId xmlns:r="http://schemas.openxmlformats.org/officeDocument/2006/relationships" id="262" r:id="R5e51aa1470cb4edb"/>
+    <p:sldId xmlns:r="http://schemas.openxmlformats.org/officeDocument/2006/relationships" id="263" r:id="R95bc52fe1fbd4534"/>
   </p:sldIdLst>
   <p:sldSz cx="12192000" cy="6858000"/>
   <p:notesSz cx="6858000" cy="9144000"/>
@@ -1024,7 +1024,7 @@
   </p:cSld>
   <p:clrMap bg1="lt1" tx1="dk1" bg2="lt2" tx2="dk2" accent1="accent1" accent2="accent2" accent3="accent3" accent4="accent4" accent5="accent5" accent6="accent6" hlink="hlink" folHlink="folHlink"/>
   <p:sldLayoutIdLst>
-    <p:sldLayoutId xmlns:r="http://schemas.openxmlformats.org/officeDocument/2006/relationships" id="2147483649" r:id="R337ff1a018ef40f1"/>
+    <p:sldLayoutId xmlns:r="http://schemas.openxmlformats.org/officeDocument/2006/relationships" id="2147483649" r:id="Rb53f7b2c3f9b4889"/>
   </p:sldLayoutIdLst>
   <p:txStyles>
     <p:titleStyle>
@@ -1522,7 +1522,7 @@
           <p:cNvPr id="1" name="">
             <a:extLst xmlns:a="http://schemas.openxmlformats.org/drawingml/2006/main">
               <a:ext uri="{FF2B5EF4-FFF2-40B4-BE49-F238E27FC236}">
-                <a16:creationId xmlns:a16="http://schemas.microsoft.com/office/drawing/2014/main" id="{212852CC-CA87-468C-954F-65BC8CC6EE2A}"/>
+                <a16:creationId xmlns:a16="http://schemas.microsoft.com/office/drawing/2014/main" id="{533A0C27-CEF4-4F6B-904F-A8E2A2A889ED}"/>
               </a:ext>
             </a:extLst>
           </p:cNvPr>
@@ -1557,7 +1557,7 @@
           <p:cNvPr id="2" name="">
             <a:extLst xmlns:a="http://schemas.openxmlformats.org/drawingml/2006/main">
               <a:ext uri="{FF2B5EF4-FFF2-40B4-BE49-F238E27FC236}">
-                <a16:creationId xmlns:a16="http://schemas.microsoft.com/office/drawing/2014/main" id="{E901239B-7F62-44DE-9646-45C104CEF6A3}"/>
+                <a16:creationId xmlns:a16="http://schemas.microsoft.com/office/drawing/2014/main" id="{7DD07C8E-346D-482D-82B2-3F386FEC6050}"/>
               </a:ext>
             </a:extLst>
           </p:cNvPr>
@@ -1621,7 +1621,7 @@
           <p:cNvPr id="3" name="">
             <a:extLst xmlns:a="http://schemas.openxmlformats.org/drawingml/2006/main">
               <a:ext uri="{FF2B5EF4-FFF2-40B4-BE49-F238E27FC236}">
-                <a16:creationId xmlns:a16="http://schemas.microsoft.com/office/drawing/2014/main" id="{6120C844-4DD3-443C-BC9A-E645B88F401F}"/>
+                <a16:creationId xmlns:a16="http://schemas.microsoft.com/office/drawing/2014/main" id="{B31A47B1-D7D7-40E8-B1E6-E718378A5BD9}"/>
               </a:ext>
             </a:extLst>
           </p:cNvPr>
@@ -1685,7 +1685,7 @@
           <p:cNvPr id="4" name="">
             <a:extLst xmlns:a="http://schemas.openxmlformats.org/drawingml/2006/main">
               <a:ext uri="{FF2B5EF4-FFF2-40B4-BE49-F238E27FC236}">
-                <a16:creationId xmlns:a16="http://schemas.microsoft.com/office/drawing/2014/main" id="{603EF24D-FA19-47A8-94BB-B5B59B11B024}"/>
+                <a16:creationId xmlns:a16="http://schemas.microsoft.com/office/drawing/2014/main" id="{5EE90F65-F158-450C-9C99-C3830FF87F50}"/>
               </a:ext>
             </a:extLst>
           </p:cNvPr>
@@ -1749,7 +1749,7 @@
           <p:cNvPr id="5" name="">
             <a:extLst xmlns:a="http://schemas.openxmlformats.org/drawingml/2006/main">
               <a:ext uri="{FF2B5EF4-FFF2-40B4-BE49-F238E27FC236}">
-                <a16:creationId xmlns:a16="http://schemas.microsoft.com/office/drawing/2014/main" id="{3566F650-73F7-4FA5-808F-C442D96175D3}"/>
+                <a16:creationId xmlns:a16="http://schemas.microsoft.com/office/drawing/2014/main" id="{EA5B547C-2BF1-4985-8EC3-C8385F9DDC25}"/>
               </a:ext>
             </a:extLst>
           </p:cNvPr>
@@ -1782,7 +1782,7 @@
           <p:cNvPr id="6" name="">
             <a:extLst xmlns:a="http://schemas.openxmlformats.org/drawingml/2006/main">
               <a:ext uri="{FF2B5EF4-FFF2-40B4-BE49-F238E27FC236}">
-                <a16:creationId xmlns:a16="http://schemas.microsoft.com/office/drawing/2014/main" id="{AC92DF0F-F0D9-4FE5-B1B3-EE165FDC989F}"/>
+                <a16:creationId xmlns:a16="http://schemas.microsoft.com/office/drawing/2014/main" id="{7C4B2E26-01F1-42AE-8AB1-59DB66871473}"/>
               </a:ext>
             </a:extLst>
           </p:cNvPr>
@@ -1846,7 +1846,7 @@
           <p:cNvPr id="7" name="">
             <a:extLst xmlns:a="http://schemas.openxmlformats.org/drawingml/2006/main">
               <a:ext uri="{FF2B5EF4-FFF2-40B4-BE49-F238E27FC236}">
-                <a16:creationId xmlns:a16="http://schemas.microsoft.com/office/drawing/2014/main" id="{141A0D79-6E7B-4E06-BF8C-E05FE6A9BD99}"/>
+                <a16:creationId xmlns:a16="http://schemas.microsoft.com/office/drawing/2014/main" id="{4F38272B-A9F1-45C3-8563-E6A14CAC66DB}"/>
               </a:ext>
             </a:extLst>
           </p:cNvPr>
@@ -1914,7 +1914,7 @@
           <p:nvPr/>
         </p:nvPicPr>
         <p:blipFill>
-          <a:blip xmlns:r="http://schemas.openxmlformats.org/officeDocument/2006/relationships" xmlns:a="http://schemas.openxmlformats.org/drawingml/2006/main" r:embed="Rccdba927f81142c2"/>
+          <a:blip xmlns:r="http://schemas.openxmlformats.org/officeDocument/2006/relationships" xmlns:a="http://schemas.openxmlformats.org/drawingml/2006/main" r:embed="R96560140b03e4713"/>
           <a:stretch xmlns:a="http://schemas.openxmlformats.org/drawingml/2006/main"/>
         </p:blipFill>
         <p:spPr>
@@ -1932,7 +1932,7 @@
           <p:cNvPr id="9" name="">
             <a:extLst xmlns:a="http://schemas.openxmlformats.org/drawingml/2006/main">
               <a:ext uri="{FF2B5EF4-FFF2-40B4-BE49-F238E27FC236}">
-                <a16:creationId xmlns:a16="http://schemas.microsoft.com/office/drawing/2014/main" id="{F254317E-E2BA-44C7-A8BC-B385AA43A45C}"/>
+                <a16:creationId xmlns:a16="http://schemas.microsoft.com/office/drawing/2014/main" id="{8FFDE335-88FB-4373-B9AA-C84615D5DC82}"/>
               </a:ext>
             </a:extLst>
           </p:cNvPr>
@@ -1996,7 +1996,7 @@
           <p:cNvPr id="10" name="">
             <a:extLst xmlns:a="http://schemas.openxmlformats.org/drawingml/2006/main">
               <a:ext uri="{FF2B5EF4-FFF2-40B4-BE49-F238E27FC236}">
-                <a16:creationId xmlns:a16="http://schemas.microsoft.com/office/drawing/2014/main" id="{A7C58F64-8122-4367-B259-962746410169}"/>
+                <a16:creationId xmlns:a16="http://schemas.microsoft.com/office/drawing/2014/main" id="{BEB9E026-1504-44B6-8622-8DE2BC7C1A3E}"/>
               </a:ext>
             </a:extLst>
           </p:cNvPr>
@@ -2058,7 +2058,7 @@
     </p:spTree>
     <p:extLst>
       <p:ext uri="{BB962C8B-B14F-4D97-AF65-F5344CB8AC3E}">
-        <p14:creationId xmlns:p14="http://schemas.microsoft.com/office/powerpoint/2010/main" val="807324807"/>
+        <p14:creationId xmlns:p14="http://schemas.microsoft.com/office/powerpoint/2010/main" val="141319613"/>
       </p:ext>
     </p:extLst>
   </p:cSld>
@@ -2082,7 +2082,7 @@
           <p:cNvPr id="1" name="">
             <a:extLst xmlns:a="http://schemas.openxmlformats.org/drawingml/2006/main">
               <a:ext uri="{FF2B5EF4-FFF2-40B4-BE49-F238E27FC236}">
-                <a16:creationId xmlns:a16="http://schemas.microsoft.com/office/drawing/2014/main" id="{346720F1-0461-4FC5-B971-0D629A134DD0}"/>
+                <a16:creationId xmlns:a16="http://schemas.microsoft.com/office/drawing/2014/main" id="{2E513AA6-7A90-4A46-8984-5AADE3EC03D8}"/>
               </a:ext>
             </a:extLst>
           </p:cNvPr>
@@ -2117,7 +2117,7 @@
           <p:cNvPr id="2" name="">
             <a:extLst xmlns:a="http://schemas.openxmlformats.org/drawingml/2006/main">
               <a:ext uri="{FF2B5EF4-FFF2-40B4-BE49-F238E27FC236}">
-                <a16:creationId xmlns:a16="http://schemas.microsoft.com/office/drawing/2014/main" id="{CB579EB0-7E51-43D3-B736-87395CB93CDF}"/>
+                <a16:creationId xmlns:a16="http://schemas.microsoft.com/office/drawing/2014/main" id="{854DB3A0-9B68-4F31-8D77-DDEA2E04369F}"/>
               </a:ext>
             </a:extLst>
           </p:cNvPr>
@@ -2181,7 +2181,7 @@
           <p:cNvPr id="3" name="">
             <a:extLst xmlns:a="http://schemas.openxmlformats.org/drawingml/2006/main">
               <a:ext uri="{FF2B5EF4-FFF2-40B4-BE49-F238E27FC236}">
-                <a16:creationId xmlns:a16="http://schemas.microsoft.com/office/drawing/2014/main" id="{CF45D251-11AD-4E66-9AF0-F08124C90295}"/>
+                <a16:creationId xmlns:a16="http://schemas.microsoft.com/office/drawing/2014/main" id="{7F57DC06-C445-493E-9085-9E1F7E517AB5}"/>
               </a:ext>
             </a:extLst>
           </p:cNvPr>
@@ -2245,7 +2245,7 @@
           <p:cNvPr id="4" name="">
             <a:extLst xmlns:a="http://schemas.openxmlformats.org/drawingml/2006/main">
               <a:ext uri="{FF2B5EF4-FFF2-40B4-BE49-F238E27FC236}">
-                <a16:creationId xmlns:a16="http://schemas.microsoft.com/office/drawing/2014/main" id="{B918F904-7C07-46AB-8504-B0277FE6D943}"/>
+                <a16:creationId xmlns:a16="http://schemas.microsoft.com/office/drawing/2014/main" id="{0A667408-4435-4D8C-929C-5303B1E97E0B}"/>
               </a:ext>
             </a:extLst>
           </p:cNvPr>
@@ -2309,7 +2309,7 @@
           <p:cNvPr id="5" name="">
             <a:extLst xmlns:a="http://schemas.openxmlformats.org/drawingml/2006/main">
               <a:ext uri="{FF2B5EF4-FFF2-40B4-BE49-F238E27FC236}">
-                <a16:creationId xmlns:a16="http://schemas.microsoft.com/office/drawing/2014/main" id="{456B513F-9A35-4C2E-B3C2-3E3FE967851A}"/>
+                <a16:creationId xmlns:a16="http://schemas.microsoft.com/office/drawing/2014/main" id="{3A047A8C-FA13-4284-A991-EF3E6D772F09}"/>
               </a:ext>
             </a:extLst>
           </p:cNvPr>
@@ -2342,7 +2342,7 @@
           <p:cNvPr id="6" name="">
             <a:extLst xmlns:a="http://schemas.openxmlformats.org/drawingml/2006/main">
               <a:ext uri="{FF2B5EF4-FFF2-40B4-BE49-F238E27FC236}">
-                <a16:creationId xmlns:a16="http://schemas.microsoft.com/office/drawing/2014/main" id="{F512D754-817C-4F1E-8493-1566C6A19D80}"/>
+                <a16:creationId xmlns:a16="http://schemas.microsoft.com/office/drawing/2014/main" id="{4BE3B562-E852-47CF-999C-36F95702CF8A}"/>
               </a:ext>
             </a:extLst>
           </p:cNvPr>
@@ -2406,7 +2406,7 @@
           <p:cNvPr id="7" name="">
             <a:extLst xmlns:a="http://schemas.openxmlformats.org/drawingml/2006/main">
               <a:ext uri="{FF2B5EF4-FFF2-40B4-BE49-F238E27FC236}">
-                <a16:creationId xmlns:a16="http://schemas.microsoft.com/office/drawing/2014/main" id="{8C9B9824-BDAE-4CD4-B9DF-DB764E460DB2}"/>
+                <a16:creationId xmlns:a16="http://schemas.microsoft.com/office/drawing/2014/main" id="{C0539E6D-B9F0-4774-BA98-7C4159882742}"/>
               </a:ext>
             </a:extLst>
           </p:cNvPr>
@@ -2470,7 +2470,7 @@
           <p:cNvPr id="8" name="">
             <a:extLst xmlns:a="http://schemas.openxmlformats.org/drawingml/2006/main">
               <a:ext uri="{FF2B5EF4-FFF2-40B4-BE49-F238E27FC236}">
-                <a16:creationId xmlns:a16="http://schemas.microsoft.com/office/drawing/2014/main" id="{15C22D64-59BB-41EC-A3FE-186F628F8CC4}"/>
+                <a16:creationId xmlns:a16="http://schemas.microsoft.com/office/drawing/2014/main" id="{6C469632-AF04-4AC0-97A0-7F38E7707AD6}"/>
               </a:ext>
             </a:extLst>
           </p:cNvPr>
@@ -2503,7 +2503,7 @@
           <p:cNvPr id="9" name="">
             <a:extLst xmlns:a="http://schemas.openxmlformats.org/drawingml/2006/main">
               <a:ext uri="{FF2B5EF4-FFF2-40B4-BE49-F238E27FC236}">
-                <a16:creationId xmlns:a16="http://schemas.microsoft.com/office/drawing/2014/main" id="{83B0A8E4-86DD-49E7-88E9-97F7A8636B9C}"/>
+                <a16:creationId xmlns:a16="http://schemas.microsoft.com/office/drawing/2014/main" id="{6D6D2E5F-1F62-4CBC-A71B-CADCE24879B8}"/>
               </a:ext>
             </a:extLst>
           </p:cNvPr>
@@ -2567,7 +2567,7 @@
           <p:cNvPr id="10" name="">
             <a:extLst xmlns:a="http://schemas.openxmlformats.org/drawingml/2006/main">
               <a:ext uri="{FF2B5EF4-FFF2-40B4-BE49-F238E27FC236}">
-                <a16:creationId xmlns:a16="http://schemas.microsoft.com/office/drawing/2014/main" id="{64F1948C-5F90-4040-997D-514E45F6CFC1}"/>
+                <a16:creationId xmlns:a16="http://schemas.microsoft.com/office/drawing/2014/main" id="{791292BC-8944-47E4-B156-ED5C3F983803}"/>
               </a:ext>
             </a:extLst>
           </p:cNvPr>
@@ -2631,7 +2631,7 @@
           <p:cNvPr id="11" name="">
             <a:extLst xmlns:a="http://schemas.openxmlformats.org/drawingml/2006/main">
               <a:ext uri="{FF2B5EF4-FFF2-40B4-BE49-F238E27FC236}">
-                <a16:creationId xmlns:a16="http://schemas.microsoft.com/office/drawing/2014/main" id="{1F8C1409-F504-4D3B-838D-13047870F440}"/>
+                <a16:creationId xmlns:a16="http://schemas.microsoft.com/office/drawing/2014/main" id="{77700410-E47E-408C-AE34-349DD510DC25}"/>
               </a:ext>
             </a:extLst>
           </p:cNvPr>
@@ -2664,7 +2664,7 @@
           <p:cNvPr id="12" name="">
             <a:extLst xmlns:a="http://schemas.openxmlformats.org/drawingml/2006/main">
               <a:ext uri="{FF2B5EF4-FFF2-40B4-BE49-F238E27FC236}">
-                <a16:creationId xmlns:a16="http://schemas.microsoft.com/office/drawing/2014/main" id="{9D987630-CED8-4AC2-AEF2-0E718CFA541C}"/>
+                <a16:creationId xmlns:a16="http://schemas.microsoft.com/office/drawing/2014/main" id="{F2606777-A9ED-4C2A-AC2B-94AEE052D01F}"/>
               </a:ext>
             </a:extLst>
           </p:cNvPr>
@@ -2728,7 +2728,7 @@
           <p:cNvPr id="13" name="">
             <a:extLst xmlns:a="http://schemas.openxmlformats.org/drawingml/2006/main">
               <a:ext uri="{FF2B5EF4-FFF2-40B4-BE49-F238E27FC236}">
-                <a16:creationId xmlns:a16="http://schemas.microsoft.com/office/drawing/2014/main" id="{821BF15F-4A21-40F9-8455-A2E39F7E2D6B}"/>
+                <a16:creationId xmlns:a16="http://schemas.microsoft.com/office/drawing/2014/main" id="{E8E4ACC6-2BFD-4A1E-8DF3-F184FDA349B0}"/>
               </a:ext>
             </a:extLst>
           </p:cNvPr>
@@ -2792,7 +2792,7 @@
           <p:cNvPr id="14" name="">
             <a:extLst xmlns:a="http://schemas.openxmlformats.org/drawingml/2006/main">
               <a:ext uri="{FF2B5EF4-FFF2-40B4-BE49-F238E27FC236}">
-                <a16:creationId xmlns:a16="http://schemas.microsoft.com/office/drawing/2014/main" id="{3266BA11-24C8-4A77-B2E2-C0A6331494FD}"/>
+                <a16:creationId xmlns:a16="http://schemas.microsoft.com/office/drawing/2014/main" id="{F48746D5-6D82-4EDC-AC52-22632613763F}"/>
               </a:ext>
             </a:extLst>
           </p:cNvPr>
@@ -2825,7 +2825,7 @@
           <p:cNvPr id="15" name="">
             <a:extLst xmlns:a="http://schemas.openxmlformats.org/drawingml/2006/main">
               <a:ext uri="{FF2B5EF4-FFF2-40B4-BE49-F238E27FC236}">
-                <a16:creationId xmlns:a16="http://schemas.microsoft.com/office/drawing/2014/main" id="{A2E3375C-E2E3-4427-8C3F-8E010E24A8AB}"/>
+                <a16:creationId xmlns:a16="http://schemas.microsoft.com/office/drawing/2014/main" id="{E7A9A6FF-51D5-4E33-BE8B-A9AF64D9ECD4}"/>
               </a:ext>
             </a:extLst>
           </p:cNvPr>
@@ -2889,7 +2889,7 @@
           <p:cNvPr id="16" name="">
             <a:extLst xmlns:a="http://schemas.openxmlformats.org/drawingml/2006/main">
               <a:ext uri="{FF2B5EF4-FFF2-40B4-BE49-F238E27FC236}">
-                <a16:creationId xmlns:a16="http://schemas.microsoft.com/office/drawing/2014/main" id="{C0A70CB4-ECCC-473F-B208-9B531E06E1CA}"/>
+                <a16:creationId xmlns:a16="http://schemas.microsoft.com/office/drawing/2014/main" id="{EEDA50B8-9C38-4A11-B393-F06E99CE07EA}"/>
               </a:ext>
             </a:extLst>
           </p:cNvPr>
@@ -2953,7 +2953,7 @@
           <p:cNvPr id="17" name="">
             <a:extLst xmlns:a="http://schemas.openxmlformats.org/drawingml/2006/main">
               <a:ext uri="{FF2B5EF4-FFF2-40B4-BE49-F238E27FC236}">
-                <a16:creationId xmlns:a16="http://schemas.microsoft.com/office/drawing/2014/main" id="{CF6424C6-C3D3-4C70-B2A1-305EE03AC213}"/>
+                <a16:creationId xmlns:a16="http://schemas.microsoft.com/office/drawing/2014/main" id="{7DBCD1D5-5129-4F14-A568-A2C6569EB8B7}"/>
               </a:ext>
             </a:extLst>
           </p:cNvPr>
@@ -2986,7 +2986,7 @@
           <p:cNvPr id="18" name="">
             <a:extLst xmlns:a="http://schemas.openxmlformats.org/drawingml/2006/main">
               <a:ext uri="{FF2B5EF4-FFF2-40B4-BE49-F238E27FC236}">
-                <a16:creationId xmlns:a16="http://schemas.microsoft.com/office/drawing/2014/main" id="{0C7CCD12-6B5D-40B1-A9B0-2ECBFF6C9283}"/>
+                <a16:creationId xmlns:a16="http://schemas.microsoft.com/office/drawing/2014/main" id="{66014A80-90F5-4EA5-92FD-315843F5687F}"/>
               </a:ext>
             </a:extLst>
           </p:cNvPr>
@@ -3050,7 +3050,7 @@
           <p:cNvPr id="19" name="">
             <a:extLst xmlns:a="http://schemas.openxmlformats.org/drawingml/2006/main">
               <a:ext uri="{FF2B5EF4-FFF2-40B4-BE49-F238E27FC236}">
-                <a16:creationId xmlns:a16="http://schemas.microsoft.com/office/drawing/2014/main" id="{234628D9-C334-4C29-88DD-2D13EDAFCDC5}"/>
+                <a16:creationId xmlns:a16="http://schemas.microsoft.com/office/drawing/2014/main" id="{1CD050E9-7CA4-43CB-BC81-18D51D2BBE6F}"/>
               </a:ext>
             </a:extLst>
           </p:cNvPr>
@@ -3114,7 +3114,7 @@
           <p:cNvPr id="20" name="">
             <a:extLst xmlns:a="http://schemas.openxmlformats.org/drawingml/2006/main">
               <a:ext uri="{FF2B5EF4-FFF2-40B4-BE49-F238E27FC236}">
-                <a16:creationId xmlns:a16="http://schemas.microsoft.com/office/drawing/2014/main" id="{05A65EF4-96D4-49BD-BC7E-36205B0E7C34}"/>
+                <a16:creationId xmlns:a16="http://schemas.microsoft.com/office/drawing/2014/main" id="{A18780F5-F65C-4F9E-8523-7A4EAF83D909}"/>
               </a:ext>
             </a:extLst>
           </p:cNvPr>
@@ -3147,7 +3147,7 @@
           <p:cNvPr id="21" name="">
             <a:extLst xmlns:a="http://schemas.openxmlformats.org/drawingml/2006/main">
               <a:ext uri="{FF2B5EF4-FFF2-40B4-BE49-F238E27FC236}">
-                <a16:creationId xmlns:a16="http://schemas.microsoft.com/office/drawing/2014/main" id="{EE2BF05E-0F60-42D0-ACAB-CC8CA2C9536B}"/>
+                <a16:creationId xmlns:a16="http://schemas.microsoft.com/office/drawing/2014/main" id="{BFD965B8-CB91-44B1-9939-56C6BE0264AD}"/>
               </a:ext>
             </a:extLst>
           </p:cNvPr>
@@ -3211,7 +3211,7 @@
           <p:cNvPr id="22" name="">
             <a:extLst xmlns:a="http://schemas.openxmlformats.org/drawingml/2006/main">
               <a:ext uri="{FF2B5EF4-FFF2-40B4-BE49-F238E27FC236}">
-                <a16:creationId xmlns:a16="http://schemas.microsoft.com/office/drawing/2014/main" id="{6BF45DA3-A39C-42FB-B763-C443B800E6EB}"/>
+                <a16:creationId xmlns:a16="http://schemas.microsoft.com/office/drawing/2014/main" id="{236EE9EB-1FCB-4BFF-8CBB-4979F5DCCD6F}"/>
               </a:ext>
             </a:extLst>
           </p:cNvPr>
@@ -3275,7 +3275,7 @@
           <p:cNvPr id="23" name="">
             <a:extLst xmlns:a="http://schemas.openxmlformats.org/drawingml/2006/main">
               <a:ext uri="{FF2B5EF4-FFF2-40B4-BE49-F238E27FC236}">
-                <a16:creationId xmlns:a16="http://schemas.microsoft.com/office/drawing/2014/main" id="{AFC4FB5B-1E2C-4268-BF4A-0F3EC01BEBEB}"/>
+                <a16:creationId xmlns:a16="http://schemas.microsoft.com/office/drawing/2014/main" id="{12764CAE-12BE-4A6C-AFA8-2A41D707B4E4}"/>
               </a:ext>
             </a:extLst>
           </p:cNvPr>
@@ -3339,7 +3339,7 @@
           <p:cNvPr id="24" name="">
             <a:extLst xmlns:a="http://schemas.openxmlformats.org/drawingml/2006/main">
               <a:ext uri="{FF2B5EF4-FFF2-40B4-BE49-F238E27FC236}">
-                <a16:creationId xmlns:a16="http://schemas.microsoft.com/office/drawing/2014/main" id="{A9855023-7E16-4E73-B21B-7AAF389A2D97}"/>
+                <a16:creationId xmlns:a16="http://schemas.microsoft.com/office/drawing/2014/main" id="{339C9A3F-B645-42C6-A581-9286E702E842}"/>
               </a:ext>
             </a:extLst>
           </p:cNvPr>
@@ -3401,7 +3401,7 @@
     </p:spTree>
     <p:extLst>
       <p:ext uri="{BB962C8B-B14F-4D97-AF65-F5344CB8AC3E}">
-        <p14:creationId xmlns:p14="http://schemas.microsoft.com/office/powerpoint/2010/main" val="795603887"/>
+        <p14:creationId xmlns:p14="http://schemas.microsoft.com/office/powerpoint/2010/main" val="432107775"/>
       </p:ext>
     </p:extLst>
   </p:cSld>
@@ -3425,7 +3425,7 @@
           <p:cNvPr id="1" name="">
             <a:extLst xmlns:a="http://schemas.openxmlformats.org/drawingml/2006/main">
               <a:ext uri="{FF2B5EF4-FFF2-40B4-BE49-F238E27FC236}">
-                <a16:creationId xmlns:a16="http://schemas.microsoft.com/office/drawing/2014/main" id="{A306D328-24A0-431A-AE43-BBF1FBE7BE97}"/>
+                <a16:creationId xmlns:a16="http://schemas.microsoft.com/office/drawing/2014/main" id="{8772149F-A31A-487A-A209-B10D1D20AE0B}"/>
               </a:ext>
             </a:extLst>
           </p:cNvPr>
@@ -3460,7 +3460,7 @@
           <p:cNvPr id="2" name="">
             <a:extLst xmlns:a="http://schemas.openxmlformats.org/drawingml/2006/main">
               <a:ext uri="{FF2B5EF4-FFF2-40B4-BE49-F238E27FC236}">
-                <a16:creationId xmlns:a16="http://schemas.microsoft.com/office/drawing/2014/main" id="{BEBB73DA-6143-4F60-B86D-28367014AC91}"/>
+                <a16:creationId xmlns:a16="http://schemas.microsoft.com/office/drawing/2014/main" id="{9FBC0B07-D8B9-40D1-B7CE-47FC352573B6}"/>
               </a:ext>
             </a:extLst>
           </p:cNvPr>
@@ -3524,7 +3524,7 @@
           <p:cNvPr id="3" name="">
             <a:extLst xmlns:a="http://schemas.openxmlformats.org/drawingml/2006/main">
               <a:ext uri="{FF2B5EF4-FFF2-40B4-BE49-F238E27FC236}">
-                <a16:creationId xmlns:a16="http://schemas.microsoft.com/office/drawing/2014/main" id="{1C3A78CC-D04C-468E-82D9-8CC2DA1BC1A3}"/>
+                <a16:creationId xmlns:a16="http://schemas.microsoft.com/office/drawing/2014/main" id="{0BCBC3BD-AF1A-462F-99A4-CBB93C630402}"/>
               </a:ext>
             </a:extLst>
           </p:cNvPr>
@@ -3588,7 +3588,7 @@
           <p:cNvPr id="4" name="">
             <a:extLst xmlns:a="http://schemas.openxmlformats.org/drawingml/2006/main">
               <a:ext uri="{FF2B5EF4-FFF2-40B4-BE49-F238E27FC236}">
-                <a16:creationId xmlns:a16="http://schemas.microsoft.com/office/drawing/2014/main" id="{699726C2-FE22-4EBB-B2D6-08C64230830D}"/>
+                <a16:creationId xmlns:a16="http://schemas.microsoft.com/office/drawing/2014/main" id="{B427EA4B-D934-4DE7-9967-F9211F228333}"/>
               </a:ext>
             </a:extLst>
           </p:cNvPr>
@@ -3652,7 +3652,7 @@
           <p:cNvPr id="5" name="">
             <a:extLst xmlns:a="http://schemas.openxmlformats.org/drawingml/2006/main">
               <a:ext uri="{FF2B5EF4-FFF2-40B4-BE49-F238E27FC236}">
-                <a16:creationId xmlns:a16="http://schemas.microsoft.com/office/drawing/2014/main" id="{73545046-3A24-4C10-9733-4C4B5AA51EE4}"/>
+                <a16:creationId xmlns:a16="http://schemas.microsoft.com/office/drawing/2014/main" id="{F5C07117-9247-44B2-8277-8AE3DA371A38}"/>
               </a:ext>
             </a:extLst>
           </p:cNvPr>
@@ -3685,7 +3685,7 @@
           <p:cNvPr id="6" name="">
             <a:extLst xmlns:a="http://schemas.openxmlformats.org/drawingml/2006/main">
               <a:ext uri="{FF2B5EF4-FFF2-40B4-BE49-F238E27FC236}">
-                <a16:creationId xmlns:a16="http://schemas.microsoft.com/office/drawing/2014/main" id="{4A1F0101-C84A-4DF7-8750-6082D5C2C0D3}"/>
+                <a16:creationId xmlns:a16="http://schemas.microsoft.com/office/drawing/2014/main" id="{BB2E8B90-CDCA-43E4-AE82-AEFFB171341A}"/>
               </a:ext>
             </a:extLst>
           </p:cNvPr>
@@ -3749,7 +3749,7 @@
           <p:cNvPr id="7" name="">
             <a:extLst xmlns:a="http://schemas.openxmlformats.org/drawingml/2006/main">
               <a:ext uri="{FF2B5EF4-FFF2-40B4-BE49-F238E27FC236}">
-                <a16:creationId xmlns:a16="http://schemas.microsoft.com/office/drawing/2014/main" id="{3248F565-F5CE-4218-8D9B-5EDC3A70B81D}"/>
+                <a16:creationId xmlns:a16="http://schemas.microsoft.com/office/drawing/2014/main" id="{5DF94B45-4ABB-4D7D-B81C-A04968B5D5DD}"/>
               </a:ext>
             </a:extLst>
           </p:cNvPr>
@@ -3813,7 +3813,7 @@
           <p:cNvPr id="8" name="">
             <a:extLst xmlns:a="http://schemas.openxmlformats.org/drawingml/2006/main">
               <a:ext uri="{FF2B5EF4-FFF2-40B4-BE49-F238E27FC236}">
-                <a16:creationId xmlns:a16="http://schemas.microsoft.com/office/drawing/2014/main" id="{BB6437D8-699B-42E4-AC7D-89E4668ED7F3}"/>
+                <a16:creationId xmlns:a16="http://schemas.microsoft.com/office/drawing/2014/main" id="{63D237B6-5DFE-4399-9068-0A8746A5080B}"/>
               </a:ext>
             </a:extLst>
           </p:cNvPr>
@@ -3846,7 +3846,7 @@
           <p:cNvPr id="9" name="">
             <a:extLst xmlns:a="http://schemas.openxmlformats.org/drawingml/2006/main">
               <a:ext uri="{FF2B5EF4-FFF2-40B4-BE49-F238E27FC236}">
-                <a16:creationId xmlns:a16="http://schemas.microsoft.com/office/drawing/2014/main" id="{35ECBD81-E9E4-4C5E-BD5D-F95CE8D29749}"/>
+                <a16:creationId xmlns:a16="http://schemas.microsoft.com/office/drawing/2014/main" id="{3503A137-C441-448E-A8BA-61D6E71C93D3}"/>
               </a:ext>
             </a:extLst>
           </p:cNvPr>
@@ -3910,7 +3910,7 @@
           <p:cNvPr id="10" name="">
             <a:extLst xmlns:a="http://schemas.openxmlformats.org/drawingml/2006/main">
               <a:ext uri="{FF2B5EF4-FFF2-40B4-BE49-F238E27FC236}">
-                <a16:creationId xmlns:a16="http://schemas.microsoft.com/office/drawing/2014/main" id="{D0BFAEE6-2FCA-4E32-B2A1-BB59ABFCE2F4}"/>
+                <a16:creationId xmlns:a16="http://schemas.microsoft.com/office/drawing/2014/main" id="{B3D2C1DD-F7C3-4FF2-8C25-109F0BBEA165}"/>
               </a:ext>
             </a:extLst>
           </p:cNvPr>
@@ -3974,7 +3974,7 @@
           <p:cNvPr id="11" name="">
             <a:extLst xmlns:a="http://schemas.openxmlformats.org/drawingml/2006/main">
               <a:ext uri="{FF2B5EF4-FFF2-40B4-BE49-F238E27FC236}">
-                <a16:creationId xmlns:a16="http://schemas.microsoft.com/office/drawing/2014/main" id="{66B0DC8E-0DCE-400F-A62A-DC2944EE9037}"/>
+                <a16:creationId xmlns:a16="http://schemas.microsoft.com/office/drawing/2014/main" id="{0C9DBC9C-ADF0-4ECD-82F5-E398C1627909}"/>
               </a:ext>
             </a:extLst>
           </p:cNvPr>
@@ -4007,7 +4007,7 @@
           <p:cNvPr id="12" name="">
             <a:extLst xmlns:a="http://schemas.openxmlformats.org/drawingml/2006/main">
               <a:ext uri="{FF2B5EF4-FFF2-40B4-BE49-F238E27FC236}">
-                <a16:creationId xmlns:a16="http://schemas.microsoft.com/office/drawing/2014/main" id="{E4BAC507-DE48-49A6-9867-F8015B681AE1}"/>
+                <a16:creationId xmlns:a16="http://schemas.microsoft.com/office/drawing/2014/main" id="{8DCB62DF-0295-4A10-AE7C-945B4724256D}"/>
               </a:ext>
             </a:extLst>
           </p:cNvPr>
@@ -4071,7 +4071,7 @@
           <p:cNvPr id="13" name="">
             <a:extLst xmlns:a="http://schemas.openxmlformats.org/drawingml/2006/main">
               <a:ext uri="{FF2B5EF4-FFF2-40B4-BE49-F238E27FC236}">
-                <a16:creationId xmlns:a16="http://schemas.microsoft.com/office/drawing/2014/main" id="{86D14B35-C103-409B-9444-82EACE0C6923}"/>
+                <a16:creationId xmlns:a16="http://schemas.microsoft.com/office/drawing/2014/main" id="{11B54B50-0B21-4DA4-8CE3-B1B167C18937}"/>
               </a:ext>
             </a:extLst>
           </p:cNvPr>
@@ -4135,7 +4135,7 @@
           <p:cNvPr id="14" name="">
             <a:extLst xmlns:a="http://schemas.openxmlformats.org/drawingml/2006/main">
               <a:ext uri="{FF2B5EF4-FFF2-40B4-BE49-F238E27FC236}">
-                <a16:creationId xmlns:a16="http://schemas.microsoft.com/office/drawing/2014/main" id="{DAB5E1C9-E6FD-4141-A48D-5240E72D1FF3}"/>
+                <a16:creationId xmlns:a16="http://schemas.microsoft.com/office/drawing/2014/main" id="{3DA6D50C-5D0D-426B-822B-C5CC5E13A9ED}"/>
               </a:ext>
             </a:extLst>
           </p:cNvPr>
@@ -4168,7 +4168,7 @@
           <p:cNvPr id="15" name="">
             <a:extLst xmlns:a="http://schemas.openxmlformats.org/drawingml/2006/main">
               <a:ext uri="{FF2B5EF4-FFF2-40B4-BE49-F238E27FC236}">
-                <a16:creationId xmlns:a16="http://schemas.microsoft.com/office/drawing/2014/main" id="{00DC0885-FE57-4B43-925D-C2F41A8EA0D5}"/>
+                <a16:creationId xmlns:a16="http://schemas.microsoft.com/office/drawing/2014/main" id="{A3295630-79B1-4FDF-A510-95304635C6E1}"/>
               </a:ext>
             </a:extLst>
           </p:cNvPr>
@@ -4232,7 +4232,7 @@
           <p:cNvPr id="16" name="">
             <a:extLst xmlns:a="http://schemas.openxmlformats.org/drawingml/2006/main">
               <a:ext uri="{FF2B5EF4-FFF2-40B4-BE49-F238E27FC236}">
-                <a16:creationId xmlns:a16="http://schemas.microsoft.com/office/drawing/2014/main" id="{CE4C7FE5-CA4E-48A4-A6F7-2F3D6060BBBD}"/>
+                <a16:creationId xmlns:a16="http://schemas.microsoft.com/office/drawing/2014/main" id="{674DB31D-1F16-446E-B564-21F002B3B9C4}"/>
               </a:ext>
             </a:extLst>
           </p:cNvPr>
@@ -4296,7 +4296,7 @@
           <p:cNvPr id="17" name="">
             <a:extLst xmlns:a="http://schemas.openxmlformats.org/drawingml/2006/main">
               <a:ext uri="{FF2B5EF4-FFF2-40B4-BE49-F238E27FC236}">
-                <a16:creationId xmlns:a16="http://schemas.microsoft.com/office/drawing/2014/main" id="{83BB7F3C-1A0A-437F-B1F6-FD7F695B10BE}"/>
+                <a16:creationId xmlns:a16="http://schemas.microsoft.com/office/drawing/2014/main" id="{0E455B2D-8607-4ACE-903E-D18C4966ED41}"/>
               </a:ext>
             </a:extLst>
           </p:cNvPr>
@@ -4329,7 +4329,7 @@
           <p:cNvPr id="18" name="">
             <a:extLst xmlns:a="http://schemas.openxmlformats.org/drawingml/2006/main">
               <a:ext uri="{FF2B5EF4-FFF2-40B4-BE49-F238E27FC236}">
-                <a16:creationId xmlns:a16="http://schemas.microsoft.com/office/drawing/2014/main" id="{61648288-34F7-4328-AFC7-7164224833E2}"/>
+                <a16:creationId xmlns:a16="http://schemas.microsoft.com/office/drawing/2014/main" id="{FB773C4F-02BE-4614-A2B4-F1575AAEBAF4}"/>
               </a:ext>
             </a:extLst>
           </p:cNvPr>
@@ -4393,7 +4393,7 @@
           <p:cNvPr id="19" name="">
             <a:extLst xmlns:a="http://schemas.openxmlformats.org/drawingml/2006/main">
               <a:ext uri="{FF2B5EF4-FFF2-40B4-BE49-F238E27FC236}">
-                <a16:creationId xmlns:a16="http://schemas.microsoft.com/office/drawing/2014/main" id="{FC59A440-2A6E-41A4-BE29-61F9552609B7}"/>
+                <a16:creationId xmlns:a16="http://schemas.microsoft.com/office/drawing/2014/main" id="{2E186369-327E-4D4F-BFC7-E345A3B6BB87}"/>
               </a:ext>
             </a:extLst>
           </p:cNvPr>
@@ -4457,7 +4457,7 @@
           <p:cNvPr id="20" name="">
             <a:extLst xmlns:a="http://schemas.openxmlformats.org/drawingml/2006/main">
               <a:ext uri="{FF2B5EF4-FFF2-40B4-BE49-F238E27FC236}">
-                <a16:creationId xmlns:a16="http://schemas.microsoft.com/office/drawing/2014/main" id="{21E544A1-89D2-4B8D-8C58-F95BA3678CD9}"/>
+                <a16:creationId xmlns:a16="http://schemas.microsoft.com/office/drawing/2014/main" id="{C7FA1677-B99F-4DCD-917B-3BD580713A54}"/>
               </a:ext>
             </a:extLst>
           </p:cNvPr>
@@ -4490,7 +4490,7 @@
           <p:cNvPr id="21" name="">
             <a:extLst xmlns:a="http://schemas.openxmlformats.org/drawingml/2006/main">
               <a:ext uri="{FF2B5EF4-FFF2-40B4-BE49-F238E27FC236}">
-                <a16:creationId xmlns:a16="http://schemas.microsoft.com/office/drawing/2014/main" id="{BC407E3D-EC9C-4A8D-AA71-DD0B10746424}"/>
+                <a16:creationId xmlns:a16="http://schemas.microsoft.com/office/drawing/2014/main" id="{69DD89B2-14DF-471A-9013-D6D9228A6D44}"/>
               </a:ext>
             </a:extLst>
           </p:cNvPr>
@@ -4554,7 +4554,7 @@
           <p:cNvPr id="22" name="">
             <a:extLst xmlns:a="http://schemas.openxmlformats.org/drawingml/2006/main">
               <a:ext uri="{FF2B5EF4-FFF2-40B4-BE49-F238E27FC236}">
-                <a16:creationId xmlns:a16="http://schemas.microsoft.com/office/drawing/2014/main" id="{6BAC31C2-9708-412C-9AC7-B2F214D45610}"/>
+                <a16:creationId xmlns:a16="http://schemas.microsoft.com/office/drawing/2014/main" id="{5F0F8A69-94FF-452D-9E53-18AD31F6B303}"/>
               </a:ext>
             </a:extLst>
           </p:cNvPr>
@@ -4618,7 +4618,7 @@
           <p:cNvPr id="23" name="">
             <a:extLst xmlns:a="http://schemas.openxmlformats.org/drawingml/2006/main">
               <a:ext uri="{FF2B5EF4-FFF2-40B4-BE49-F238E27FC236}">
-                <a16:creationId xmlns:a16="http://schemas.microsoft.com/office/drawing/2014/main" id="{431A774B-4F6A-40C9-BBEB-9C2F8821A234}"/>
+                <a16:creationId xmlns:a16="http://schemas.microsoft.com/office/drawing/2014/main" id="{81C2B746-3D1E-4227-B277-0FFBD7978E38}"/>
               </a:ext>
             </a:extLst>
           </p:cNvPr>
@@ -4651,7 +4651,7 @@
           <p:cNvPr id="24" name="">
             <a:extLst xmlns:a="http://schemas.openxmlformats.org/drawingml/2006/main">
               <a:ext uri="{FF2B5EF4-FFF2-40B4-BE49-F238E27FC236}">
-                <a16:creationId xmlns:a16="http://schemas.microsoft.com/office/drawing/2014/main" id="{9631A2C9-40F7-4961-B7A0-D593366D7773}"/>
+                <a16:creationId xmlns:a16="http://schemas.microsoft.com/office/drawing/2014/main" id="{594DDA7A-8DCC-4788-8472-686333058A74}"/>
               </a:ext>
             </a:extLst>
           </p:cNvPr>
@@ -4715,7 +4715,7 @@
           <p:cNvPr id="25" name="">
             <a:extLst xmlns:a="http://schemas.openxmlformats.org/drawingml/2006/main">
               <a:ext uri="{FF2B5EF4-FFF2-40B4-BE49-F238E27FC236}">
-                <a16:creationId xmlns:a16="http://schemas.microsoft.com/office/drawing/2014/main" id="{B3DAD474-DF25-49D3-8ADF-CCB56B2880C5}"/>
+                <a16:creationId xmlns:a16="http://schemas.microsoft.com/office/drawing/2014/main" id="{A793F00B-CB32-4120-96BE-B92569D53526}"/>
               </a:ext>
             </a:extLst>
           </p:cNvPr>
@@ -4779,7 +4779,7 @@
           <p:cNvPr id="26" name="">
             <a:extLst xmlns:a="http://schemas.openxmlformats.org/drawingml/2006/main">
               <a:ext uri="{FF2B5EF4-FFF2-40B4-BE49-F238E27FC236}">
-                <a16:creationId xmlns:a16="http://schemas.microsoft.com/office/drawing/2014/main" id="{FD76175A-E3F7-418F-824A-BD869663159E}"/>
+                <a16:creationId xmlns:a16="http://schemas.microsoft.com/office/drawing/2014/main" id="{94CE477E-3D62-4EAA-A891-B591E7E333E0}"/>
               </a:ext>
             </a:extLst>
           </p:cNvPr>
@@ -4843,7 +4843,7 @@
           <p:cNvPr id="27" name="">
             <a:extLst xmlns:a="http://schemas.openxmlformats.org/drawingml/2006/main">
               <a:ext uri="{FF2B5EF4-FFF2-40B4-BE49-F238E27FC236}">
-                <a16:creationId xmlns:a16="http://schemas.microsoft.com/office/drawing/2014/main" id="{E487971C-7CD2-4FFD-A0C7-30CB2F3A033A}"/>
+                <a16:creationId xmlns:a16="http://schemas.microsoft.com/office/drawing/2014/main" id="{8968EF34-65CA-4AB2-A755-DCA4D75363D7}"/>
               </a:ext>
             </a:extLst>
           </p:cNvPr>
@@ -4905,7 +4905,7 @@
     </p:spTree>
     <p:extLst>
       <p:ext uri="{BB962C8B-B14F-4D97-AF65-F5344CB8AC3E}">
-        <p14:creationId xmlns:p14="http://schemas.microsoft.com/office/powerpoint/2010/main" val="1117670587"/>
+        <p14:creationId xmlns:p14="http://schemas.microsoft.com/office/powerpoint/2010/main" val="1497078416"/>
       </p:ext>
     </p:extLst>
   </p:cSld>
@@ -4929,7 +4929,7 @@
           <p:cNvPr id="1" name="">
             <a:extLst xmlns:a="http://schemas.openxmlformats.org/drawingml/2006/main">
               <a:ext uri="{FF2B5EF4-FFF2-40B4-BE49-F238E27FC236}">
-                <a16:creationId xmlns:a16="http://schemas.microsoft.com/office/drawing/2014/main" id="{3CE1FBEA-B8FB-412A-ACBB-F6A852AB396E}"/>
+                <a16:creationId xmlns:a16="http://schemas.microsoft.com/office/drawing/2014/main" id="{6BB98267-0A11-4874-A248-AA1FC299640B}"/>
               </a:ext>
             </a:extLst>
           </p:cNvPr>
@@ -4964,7 +4964,7 @@
           <p:cNvPr id="2" name="">
             <a:extLst xmlns:a="http://schemas.openxmlformats.org/drawingml/2006/main">
               <a:ext uri="{FF2B5EF4-FFF2-40B4-BE49-F238E27FC236}">
-                <a16:creationId xmlns:a16="http://schemas.microsoft.com/office/drawing/2014/main" id="{0DF1CBFE-A433-45A4-B354-50DECC9E7B9E}"/>
+                <a16:creationId xmlns:a16="http://schemas.microsoft.com/office/drawing/2014/main" id="{1C8525FF-DB39-43B5-9638-FEDD7EA92632}"/>
               </a:ext>
             </a:extLst>
           </p:cNvPr>
@@ -5028,7 +5028,7 @@
           <p:cNvPr id="3" name="">
             <a:extLst xmlns:a="http://schemas.openxmlformats.org/drawingml/2006/main">
               <a:ext uri="{FF2B5EF4-FFF2-40B4-BE49-F238E27FC236}">
-                <a16:creationId xmlns:a16="http://schemas.microsoft.com/office/drawing/2014/main" id="{233CAE04-E8DA-416A-B597-2FDC65625B7A}"/>
+                <a16:creationId xmlns:a16="http://schemas.microsoft.com/office/drawing/2014/main" id="{9CBE2AAE-6E1A-4076-A9FF-6D5FFFE86776}"/>
               </a:ext>
             </a:extLst>
           </p:cNvPr>
@@ -5092,7 +5092,7 @@
           <p:cNvPr id="4" name="">
             <a:extLst xmlns:a="http://schemas.openxmlformats.org/drawingml/2006/main">
               <a:ext uri="{FF2B5EF4-FFF2-40B4-BE49-F238E27FC236}">
-                <a16:creationId xmlns:a16="http://schemas.microsoft.com/office/drawing/2014/main" id="{1FFDC0CE-7456-4BB5-9259-018718F29003}"/>
+                <a16:creationId xmlns:a16="http://schemas.microsoft.com/office/drawing/2014/main" id="{69639F0E-7FAE-4286-B1B1-77DAB8E70027}"/>
               </a:ext>
             </a:extLst>
           </p:cNvPr>
@@ -5156,7 +5156,7 @@
           <p:cNvPr id="5" name="">
             <a:extLst xmlns:a="http://schemas.openxmlformats.org/drawingml/2006/main">
               <a:ext uri="{FF2B5EF4-FFF2-40B4-BE49-F238E27FC236}">
-                <a16:creationId xmlns:a16="http://schemas.microsoft.com/office/drawing/2014/main" id="{364F82D0-27D9-46DC-AC5E-81F4DCA5DF0F}"/>
+                <a16:creationId xmlns:a16="http://schemas.microsoft.com/office/drawing/2014/main" id="{2DDA6AD8-6F2D-42D3-9E7B-E54661CC1F6C}"/>
               </a:ext>
             </a:extLst>
           </p:cNvPr>
@@ -5189,7 +5189,7 @@
           <p:cNvPr id="6" name="">
             <a:extLst xmlns:a="http://schemas.openxmlformats.org/drawingml/2006/main">
               <a:ext uri="{FF2B5EF4-FFF2-40B4-BE49-F238E27FC236}">
-                <a16:creationId xmlns:a16="http://schemas.microsoft.com/office/drawing/2014/main" id="{FC810802-07EE-492D-93AC-C39A19A73BCD}"/>
+                <a16:creationId xmlns:a16="http://schemas.microsoft.com/office/drawing/2014/main" id="{CB7C9841-9939-40C7-AA18-41B175CE8CD2}"/>
               </a:ext>
             </a:extLst>
           </p:cNvPr>
@@ -5253,7 +5253,7 @@
           <p:cNvPr id="7" name="">
             <a:extLst xmlns:a="http://schemas.openxmlformats.org/drawingml/2006/main">
               <a:ext uri="{FF2B5EF4-FFF2-40B4-BE49-F238E27FC236}">
-                <a16:creationId xmlns:a16="http://schemas.microsoft.com/office/drawing/2014/main" id="{84A094E2-252A-41E2-BD19-5CD7814BFB54}"/>
+                <a16:creationId xmlns:a16="http://schemas.microsoft.com/office/drawing/2014/main" id="{AA31969B-F131-4E72-A909-26A1DB152CDE}"/>
               </a:ext>
             </a:extLst>
           </p:cNvPr>
@@ -5321,7 +5321,7 @@
           <p:nvPr/>
         </p:nvPicPr>
         <p:blipFill>
-          <a:blip xmlns:r="http://schemas.openxmlformats.org/officeDocument/2006/relationships" xmlns:a="http://schemas.openxmlformats.org/drawingml/2006/main" r:embed="R01d11fc7293a4ee1"/>
+          <a:blip xmlns:r="http://schemas.openxmlformats.org/officeDocument/2006/relationships" xmlns:a="http://schemas.openxmlformats.org/drawingml/2006/main" r:embed="R176c554fee724b05"/>
           <a:stretch xmlns:a="http://schemas.openxmlformats.org/drawingml/2006/main"/>
         </p:blipFill>
         <p:spPr>
@@ -5339,7 +5339,7 @@
           <p:cNvPr id="9" name="">
             <a:extLst xmlns:a="http://schemas.openxmlformats.org/drawingml/2006/main">
               <a:ext uri="{FF2B5EF4-FFF2-40B4-BE49-F238E27FC236}">
-                <a16:creationId xmlns:a16="http://schemas.microsoft.com/office/drawing/2014/main" id="{BD90F2A0-A01A-4214-9BB2-B9CAC767FA3B}"/>
+                <a16:creationId xmlns:a16="http://schemas.microsoft.com/office/drawing/2014/main" id="{D326356C-9BC0-4FA9-9F67-3EF678D72076}"/>
               </a:ext>
             </a:extLst>
           </p:cNvPr>
@@ -5403,7 +5403,7 @@
           <p:cNvPr id="10" name="">
             <a:extLst xmlns:a="http://schemas.openxmlformats.org/drawingml/2006/main">
               <a:ext uri="{FF2B5EF4-FFF2-40B4-BE49-F238E27FC236}">
-                <a16:creationId xmlns:a16="http://schemas.microsoft.com/office/drawing/2014/main" id="{3DE88807-8988-4FD8-93CB-FB4BBA4B2699}"/>
+                <a16:creationId xmlns:a16="http://schemas.microsoft.com/office/drawing/2014/main" id="{23BF4B7A-149C-495C-A3BF-3850FFFFD2F9}"/>
               </a:ext>
             </a:extLst>
           </p:cNvPr>
@@ -5465,7 +5465,7 @@
     </p:spTree>
     <p:extLst>
       <p:ext uri="{BB962C8B-B14F-4D97-AF65-F5344CB8AC3E}">
-        <p14:creationId xmlns:p14="http://schemas.microsoft.com/office/powerpoint/2010/main" val="745785986"/>
+        <p14:creationId xmlns:p14="http://schemas.microsoft.com/office/powerpoint/2010/main" val="1290298903"/>
       </p:ext>
     </p:extLst>
   </p:cSld>
@@ -5489,7 +5489,7 @@
           <p:cNvPr id="1" name="">
             <a:extLst xmlns:a="http://schemas.openxmlformats.org/drawingml/2006/main">
               <a:ext uri="{FF2B5EF4-FFF2-40B4-BE49-F238E27FC236}">
-                <a16:creationId xmlns:a16="http://schemas.microsoft.com/office/drawing/2014/main" id="{54361006-1E77-406D-A43F-6A1BCA088D2F}"/>
+                <a16:creationId xmlns:a16="http://schemas.microsoft.com/office/drawing/2014/main" id="{739F577D-0A19-424E-BE3D-BFAE06C270D6}"/>
               </a:ext>
             </a:extLst>
           </p:cNvPr>
@@ -5524,7 +5524,7 @@
           <p:cNvPr id="2" name="">
             <a:extLst xmlns:a="http://schemas.openxmlformats.org/drawingml/2006/main">
               <a:ext uri="{FF2B5EF4-FFF2-40B4-BE49-F238E27FC236}">
-                <a16:creationId xmlns:a16="http://schemas.microsoft.com/office/drawing/2014/main" id="{3DC6AE02-6A83-4EAE-BF4F-10F62B84C112}"/>
+                <a16:creationId xmlns:a16="http://schemas.microsoft.com/office/drawing/2014/main" id="{8B68DBE5-004C-4869-9504-00BB313FE776}"/>
               </a:ext>
             </a:extLst>
           </p:cNvPr>
@@ -5588,7 +5588,7 @@
           <p:cNvPr id="3" name="">
             <a:extLst xmlns:a="http://schemas.openxmlformats.org/drawingml/2006/main">
               <a:ext uri="{FF2B5EF4-FFF2-40B4-BE49-F238E27FC236}">
-                <a16:creationId xmlns:a16="http://schemas.microsoft.com/office/drawing/2014/main" id="{B0642BBC-47B0-4EC5-802D-F462FEA7AE51}"/>
+                <a16:creationId xmlns:a16="http://schemas.microsoft.com/office/drawing/2014/main" id="{DAE1564F-C3B9-4AD2-8668-E55577837DB2}"/>
               </a:ext>
             </a:extLst>
           </p:cNvPr>
@@ -5652,7 +5652,7 @@
           <p:cNvPr id="4" name="">
             <a:extLst xmlns:a="http://schemas.openxmlformats.org/drawingml/2006/main">
               <a:ext uri="{FF2B5EF4-FFF2-40B4-BE49-F238E27FC236}">
-                <a16:creationId xmlns:a16="http://schemas.microsoft.com/office/drawing/2014/main" id="{9918C38C-9422-47B9-9A29-FED7F19CBC31}"/>
+                <a16:creationId xmlns:a16="http://schemas.microsoft.com/office/drawing/2014/main" id="{620A3290-986E-4424-BF86-3D6159E60E5F}"/>
               </a:ext>
             </a:extLst>
           </p:cNvPr>
@@ -5716,7 +5716,7 @@
           <p:cNvPr id="5" name="">
             <a:extLst xmlns:a="http://schemas.openxmlformats.org/drawingml/2006/main">
               <a:ext uri="{FF2B5EF4-FFF2-40B4-BE49-F238E27FC236}">
-                <a16:creationId xmlns:a16="http://schemas.microsoft.com/office/drawing/2014/main" id="{A094EEE3-398B-4617-A32F-B1E6550A48CC}"/>
+                <a16:creationId xmlns:a16="http://schemas.microsoft.com/office/drawing/2014/main" id="{6472F0C7-D9A8-4557-ADBC-EFDB3A6AB663}"/>
               </a:ext>
             </a:extLst>
           </p:cNvPr>
@@ -5749,7 +5749,7 @@
           <p:cNvPr id="6" name="">
             <a:extLst xmlns:a="http://schemas.openxmlformats.org/drawingml/2006/main">
               <a:ext uri="{FF2B5EF4-FFF2-40B4-BE49-F238E27FC236}">
-                <a16:creationId xmlns:a16="http://schemas.microsoft.com/office/drawing/2014/main" id="{496AAD16-EA91-4709-8CC8-7D1004471799}"/>
+                <a16:creationId xmlns:a16="http://schemas.microsoft.com/office/drawing/2014/main" id="{3D7EC495-8B06-46FC-884E-A034494869A2}"/>
               </a:ext>
             </a:extLst>
           </p:cNvPr>
@@ -5813,7 +5813,7 @@
           <p:cNvPr id="7" name="">
             <a:extLst xmlns:a="http://schemas.openxmlformats.org/drawingml/2006/main">
               <a:ext uri="{FF2B5EF4-FFF2-40B4-BE49-F238E27FC236}">
-                <a16:creationId xmlns:a16="http://schemas.microsoft.com/office/drawing/2014/main" id="{597C0F67-9DEC-40E8-9F6C-15C3D4D010D8}"/>
+                <a16:creationId xmlns:a16="http://schemas.microsoft.com/office/drawing/2014/main" id="{73566842-4CD3-4856-A0D3-1BD5A6EC8C74}"/>
               </a:ext>
             </a:extLst>
           </p:cNvPr>
@@ -5881,7 +5881,7 @@
           <p:nvPr/>
         </p:nvPicPr>
         <p:blipFill>
-          <a:blip xmlns:r="http://schemas.openxmlformats.org/officeDocument/2006/relationships" xmlns:a="http://schemas.openxmlformats.org/drawingml/2006/main" r:embed="Rf118d1db4ce64909"/>
+          <a:blip xmlns:r="http://schemas.openxmlformats.org/officeDocument/2006/relationships" xmlns:a="http://schemas.openxmlformats.org/drawingml/2006/main" r:embed="R9d1f71ec7ffa4131"/>
           <a:stretch xmlns:a="http://schemas.openxmlformats.org/drawingml/2006/main"/>
         </p:blipFill>
         <p:spPr>
@@ -5899,7 +5899,7 @@
           <p:cNvPr id="9" name="">
             <a:extLst xmlns:a="http://schemas.openxmlformats.org/drawingml/2006/main">
               <a:ext uri="{FF2B5EF4-FFF2-40B4-BE49-F238E27FC236}">
-                <a16:creationId xmlns:a16="http://schemas.microsoft.com/office/drawing/2014/main" id="{74561A27-653E-49B6-897F-D84893F284A8}"/>
+                <a16:creationId xmlns:a16="http://schemas.microsoft.com/office/drawing/2014/main" id="{33900E07-AAA8-4B63-AD2C-49F3B6AB699B}"/>
               </a:ext>
             </a:extLst>
           </p:cNvPr>
@@ -5963,7 +5963,7 @@
           <p:cNvPr id="10" name="">
             <a:extLst xmlns:a="http://schemas.openxmlformats.org/drawingml/2006/main">
               <a:ext uri="{FF2B5EF4-FFF2-40B4-BE49-F238E27FC236}">
-                <a16:creationId xmlns:a16="http://schemas.microsoft.com/office/drawing/2014/main" id="{B7792234-8FE1-42F5-8D62-F079353B5B04}"/>
+                <a16:creationId xmlns:a16="http://schemas.microsoft.com/office/drawing/2014/main" id="{EE5291AB-B4AD-40AF-86B8-D247B66C3F43}"/>
               </a:ext>
             </a:extLst>
           </p:cNvPr>
@@ -6025,7 +6025,7 @@
     </p:spTree>
     <p:extLst>
       <p:ext uri="{BB962C8B-B14F-4D97-AF65-F5344CB8AC3E}">
-        <p14:creationId xmlns:p14="http://schemas.microsoft.com/office/powerpoint/2010/main" val="1873790465"/>
+        <p14:creationId xmlns:p14="http://schemas.microsoft.com/office/powerpoint/2010/main" val="1004385627"/>
       </p:ext>
     </p:extLst>
   </p:cSld>
@@ -6049,7 +6049,7 @@
           <p:cNvPr id="1" name="">
             <a:extLst xmlns:a="http://schemas.openxmlformats.org/drawingml/2006/main">
               <a:ext uri="{FF2B5EF4-FFF2-40B4-BE49-F238E27FC236}">
-                <a16:creationId xmlns:a16="http://schemas.microsoft.com/office/drawing/2014/main" id="{6E6BF383-2133-40A6-9ACA-1A456DA6153F}"/>
+                <a16:creationId xmlns:a16="http://schemas.microsoft.com/office/drawing/2014/main" id="{6C1B1665-904B-4C52-841A-C1DB58E28564}"/>
               </a:ext>
             </a:extLst>
           </p:cNvPr>
@@ -6084,7 +6084,7 @@
           <p:cNvPr id="2" name="">
             <a:extLst xmlns:a="http://schemas.openxmlformats.org/drawingml/2006/main">
               <a:ext uri="{FF2B5EF4-FFF2-40B4-BE49-F238E27FC236}">
-                <a16:creationId xmlns:a16="http://schemas.microsoft.com/office/drawing/2014/main" id="{94F1571C-FFBE-4A45-A365-8E321C4515F6}"/>
+                <a16:creationId xmlns:a16="http://schemas.microsoft.com/office/drawing/2014/main" id="{163D4BAA-CDE6-467C-9FE6-70F7AC85B8C6}"/>
               </a:ext>
             </a:extLst>
           </p:cNvPr>
@@ -6148,7 +6148,7 @@
           <p:cNvPr id="3" name="">
             <a:extLst xmlns:a="http://schemas.openxmlformats.org/drawingml/2006/main">
               <a:ext uri="{FF2B5EF4-FFF2-40B4-BE49-F238E27FC236}">
-                <a16:creationId xmlns:a16="http://schemas.microsoft.com/office/drawing/2014/main" id="{3AB965CD-3C50-44F2-A0E6-CE6272D07B92}"/>
+                <a16:creationId xmlns:a16="http://schemas.microsoft.com/office/drawing/2014/main" id="{5F5E2F33-3AD0-409B-AEEF-8BD3AC369352}"/>
               </a:ext>
             </a:extLst>
           </p:cNvPr>
@@ -6212,7 +6212,7 @@
           <p:cNvPr id="4" name="">
             <a:extLst xmlns:a="http://schemas.openxmlformats.org/drawingml/2006/main">
               <a:ext uri="{FF2B5EF4-FFF2-40B4-BE49-F238E27FC236}">
-                <a16:creationId xmlns:a16="http://schemas.microsoft.com/office/drawing/2014/main" id="{0CBDA6AD-5355-444F-AAED-3B98C2C84896}"/>
+                <a16:creationId xmlns:a16="http://schemas.microsoft.com/office/drawing/2014/main" id="{5D53A28E-3D34-4F4C-B73F-D182E681C663}"/>
               </a:ext>
             </a:extLst>
           </p:cNvPr>
@@ -6276,7 +6276,7 @@
           <p:cNvPr id="5" name="">
             <a:extLst xmlns:a="http://schemas.openxmlformats.org/drawingml/2006/main">
               <a:ext uri="{FF2B5EF4-FFF2-40B4-BE49-F238E27FC236}">
-                <a16:creationId xmlns:a16="http://schemas.microsoft.com/office/drawing/2014/main" id="{899ED75F-4E1D-4A5D-BBA9-CFF55A7923CD}"/>
+                <a16:creationId xmlns:a16="http://schemas.microsoft.com/office/drawing/2014/main" id="{FB86235D-8D38-4748-92D4-22CD1AE55BA7}"/>
               </a:ext>
             </a:extLst>
           </p:cNvPr>
@@ -6309,7 +6309,7 @@
           <p:cNvPr id="6" name="">
             <a:extLst xmlns:a="http://schemas.openxmlformats.org/drawingml/2006/main">
               <a:ext uri="{FF2B5EF4-FFF2-40B4-BE49-F238E27FC236}">
-                <a16:creationId xmlns:a16="http://schemas.microsoft.com/office/drawing/2014/main" id="{FA3ECA13-449D-498D-B20B-D8B1E5440732}"/>
+                <a16:creationId xmlns:a16="http://schemas.microsoft.com/office/drawing/2014/main" id="{E2C487EB-A30E-4B76-8EC4-36B184A040B1}"/>
               </a:ext>
             </a:extLst>
           </p:cNvPr>
@@ -6373,7 +6373,7 @@
           <p:cNvPr id="7" name="">
             <a:extLst xmlns:a="http://schemas.openxmlformats.org/drawingml/2006/main">
               <a:ext uri="{FF2B5EF4-FFF2-40B4-BE49-F238E27FC236}">
-                <a16:creationId xmlns:a16="http://schemas.microsoft.com/office/drawing/2014/main" id="{14A08DA2-A48C-4176-B364-07474C169A92}"/>
+                <a16:creationId xmlns:a16="http://schemas.microsoft.com/office/drawing/2014/main" id="{A205B589-607A-4CBD-8B92-FE3B12C84B8C}"/>
               </a:ext>
             </a:extLst>
           </p:cNvPr>
@@ -6437,7 +6437,7 @@
           <p:cNvPr id="8" name="">
             <a:extLst xmlns:a="http://schemas.openxmlformats.org/drawingml/2006/main">
               <a:ext uri="{FF2B5EF4-FFF2-40B4-BE49-F238E27FC236}">
-                <a16:creationId xmlns:a16="http://schemas.microsoft.com/office/drawing/2014/main" id="{71407F29-A84D-41C3-ADA3-AA155B45397E}"/>
+                <a16:creationId xmlns:a16="http://schemas.microsoft.com/office/drawing/2014/main" id="{C2265CB0-26ED-4173-B77C-97B4EC6547ED}"/>
               </a:ext>
             </a:extLst>
           </p:cNvPr>
@@ -6470,7 +6470,7 @@
           <p:cNvPr id="9" name="">
             <a:extLst xmlns:a="http://schemas.openxmlformats.org/drawingml/2006/main">
               <a:ext uri="{FF2B5EF4-FFF2-40B4-BE49-F238E27FC236}">
-                <a16:creationId xmlns:a16="http://schemas.microsoft.com/office/drawing/2014/main" id="{58CC3624-6710-4FB0-9466-19A4EBF9BC0D}"/>
+                <a16:creationId xmlns:a16="http://schemas.microsoft.com/office/drawing/2014/main" id="{B852DFD2-A049-4C2D-9C7C-9D08D16AAD8C}"/>
               </a:ext>
             </a:extLst>
           </p:cNvPr>
@@ -6534,7 +6534,7 @@
           <p:cNvPr id="10" name="">
             <a:extLst xmlns:a="http://schemas.openxmlformats.org/drawingml/2006/main">
               <a:ext uri="{FF2B5EF4-FFF2-40B4-BE49-F238E27FC236}">
-                <a16:creationId xmlns:a16="http://schemas.microsoft.com/office/drawing/2014/main" id="{BA243653-6476-4897-81CC-220801199814}"/>
+                <a16:creationId xmlns:a16="http://schemas.microsoft.com/office/drawing/2014/main" id="{052711CA-CCEB-45F3-9681-0D666F00748A}"/>
               </a:ext>
             </a:extLst>
           </p:cNvPr>
@@ -6598,7 +6598,7 @@
           <p:cNvPr id="11" name="">
             <a:extLst xmlns:a="http://schemas.openxmlformats.org/drawingml/2006/main">
               <a:ext uri="{FF2B5EF4-FFF2-40B4-BE49-F238E27FC236}">
-                <a16:creationId xmlns:a16="http://schemas.microsoft.com/office/drawing/2014/main" id="{9803CAD4-EC11-4B79-9167-9F7C1B7DAF76}"/>
+                <a16:creationId xmlns:a16="http://schemas.microsoft.com/office/drawing/2014/main" id="{3A59B612-A219-4039-A0D0-066E58CD36F1}"/>
               </a:ext>
             </a:extLst>
           </p:cNvPr>
@@ -6631,7 +6631,7 @@
           <p:cNvPr id="12" name="">
             <a:extLst xmlns:a="http://schemas.openxmlformats.org/drawingml/2006/main">
               <a:ext uri="{FF2B5EF4-FFF2-40B4-BE49-F238E27FC236}">
-                <a16:creationId xmlns:a16="http://schemas.microsoft.com/office/drawing/2014/main" id="{3D74119B-F2B3-4003-9A79-F13EB9159839}"/>
+                <a16:creationId xmlns:a16="http://schemas.microsoft.com/office/drawing/2014/main" id="{147CD249-57E1-49C7-BFCC-612EE76D0C3E}"/>
               </a:ext>
             </a:extLst>
           </p:cNvPr>
@@ -6695,7 +6695,7 @@
           <p:cNvPr id="13" name="">
             <a:extLst xmlns:a="http://schemas.openxmlformats.org/drawingml/2006/main">
               <a:ext uri="{FF2B5EF4-FFF2-40B4-BE49-F238E27FC236}">
-                <a16:creationId xmlns:a16="http://schemas.microsoft.com/office/drawing/2014/main" id="{D02EFC80-38CC-4199-A3C4-AF6FA7336811}"/>
+                <a16:creationId xmlns:a16="http://schemas.microsoft.com/office/drawing/2014/main" id="{C1EAFDE9-EC78-404B-BB27-43B8687B1ADD}"/>
               </a:ext>
             </a:extLst>
           </p:cNvPr>
@@ -6759,7 +6759,7 @@
           <p:cNvPr id="14" name="">
             <a:extLst xmlns:a="http://schemas.openxmlformats.org/drawingml/2006/main">
               <a:ext uri="{FF2B5EF4-FFF2-40B4-BE49-F238E27FC236}">
-                <a16:creationId xmlns:a16="http://schemas.microsoft.com/office/drawing/2014/main" id="{3B8657CC-4246-4A34-8099-1016928EBBF8}"/>
+                <a16:creationId xmlns:a16="http://schemas.microsoft.com/office/drawing/2014/main" id="{97F0F06F-CF8E-4357-833E-426EDF0A0AC8}"/>
               </a:ext>
             </a:extLst>
           </p:cNvPr>
@@ -6792,7 +6792,7 @@
           <p:cNvPr id="15" name="">
             <a:extLst xmlns:a="http://schemas.openxmlformats.org/drawingml/2006/main">
               <a:ext uri="{FF2B5EF4-FFF2-40B4-BE49-F238E27FC236}">
-                <a16:creationId xmlns:a16="http://schemas.microsoft.com/office/drawing/2014/main" id="{1D620540-4B1B-4995-A209-B2EBF2E248C3}"/>
+                <a16:creationId xmlns:a16="http://schemas.microsoft.com/office/drawing/2014/main" id="{8195CFEC-B20E-4D63-A948-B6517A432170}"/>
               </a:ext>
             </a:extLst>
           </p:cNvPr>
@@ -6856,7 +6856,7 @@
           <p:cNvPr id="16" name="">
             <a:extLst xmlns:a="http://schemas.openxmlformats.org/drawingml/2006/main">
               <a:ext uri="{FF2B5EF4-FFF2-40B4-BE49-F238E27FC236}">
-                <a16:creationId xmlns:a16="http://schemas.microsoft.com/office/drawing/2014/main" id="{6998C234-EAB7-4A2F-9B08-46BE9EC5E3ED}"/>
+                <a16:creationId xmlns:a16="http://schemas.microsoft.com/office/drawing/2014/main" id="{7F965B4D-F6BF-43EC-8E98-4163AE7E487A}"/>
               </a:ext>
             </a:extLst>
           </p:cNvPr>
@@ -6920,7 +6920,7 @@
           <p:cNvPr id="17" name="">
             <a:extLst xmlns:a="http://schemas.openxmlformats.org/drawingml/2006/main">
               <a:ext uri="{FF2B5EF4-FFF2-40B4-BE49-F238E27FC236}">
-                <a16:creationId xmlns:a16="http://schemas.microsoft.com/office/drawing/2014/main" id="{04FD3683-732A-4A54-AE26-2EAE452828EB}"/>
+                <a16:creationId xmlns:a16="http://schemas.microsoft.com/office/drawing/2014/main" id="{AE0B282C-E3D4-4066-A43C-A5E4D32F399E}"/>
               </a:ext>
             </a:extLst>
           </p:cNvPr>
@@ -6953,7 +6953,7 @@
           <p:cNvPr id="18" name="">
             <a:extLst xmlns:a="http://schemas.openxmlformats.org/drawingml/2006/main">
               <a:ext uri="{FF2B5EF4-FFF2-40B4-BE49-F238E27FC236}">
-                <a16:creationId xmlns:a16="http://schemas.microsoft.com/office/drawing/2014/main" id="{067944EB-D21E-473D-BEA2-16364953D273}"/>
+                <a16:creationId xmlns:a16="http://schemas.microsoft.com/office/drawing/2014/main" id="{64C5F058-3854-42B0-BAE2-B749BB6C7880}"/>
               </a:ext>
             </a:extLst>
           </p:cNvPr>
@@ -7017,7 +7017,7 @@
           <p:cNvPr id="19" name="">
             <a:extLst xmlns:a="http://schemas.openxmlformats.org/drawingml/2006/main">
               <a:ext uri="{FF2B5EF4-FFF2-40B4-BE49-F238E27FC236}">
-                <a16:creationId xmlns:a16="http://schemas.microsoft.com/office/drawing/2014/main" id="{AAD6180D-5024-4767-8676-DA1340F1F9DB}"/>
+                <a16:creationId xmlns:a16="http://schemas.microsoft.com/office/drawing/2014/main" id="{2542C142-1D47-4B4E-AB1A-C33CD3638CAC}"/>
               </a:ext>
             </a:extLst>
           </p:cNvPr>
@@ -7081,7 +7081,7 @@
           <p:cNvPr id="20" name="">
             <a:extLst xmlns:a="http://schemas.openxmlformats.org/drawingml/2006/main">
               <a:ext uri="{FF2B5EF4-FFF2-40B4-BE49-F238E27FC236}">
-                <a16:creationId xmlns:a16="http://schemas.microsoft.com/office/drawing/2014/main" id="{9CE3415C-5D78-485C-B59F-A1C208A74A13}"/>
+                <a16:creationId xmlns:a16="http://schemas.microsoft.com/office/drawing/2014/main" id="{90BF982F-0305-4A0E-94F2-A0670F407A4B}"/>
               </a:ext>
             </a:extLst>
           </p:cNvPr>
@@ -7114,7 +7114,7 @@
           <p:cNvPr id="21" name="">
             <a:extLst xmlns:a="http://schemas.openxmlformats.org/drawingml/2006/main">
               <a:ext uri="{FF2B5EF4-FFF2-40B4-BE49-F238E27FC236}">
-                <a16:creationId xmlns:a16="http://schemas.microsoft.com/office/drawing/2014/main" id="{85DA8B6A-8697-42B8-90E1-51D1A7521AD0}"/>
+                <a16:creationId xmlns:a16="http://schemas.microsoft.com/office/drawing/2014/main" id="{E803C949-3A2B-40A5-BE44-18FCCF2AA3FA}"/>
               </a:ext>
             </a:extLst>
           </p:cNvPr>
@@ -7178,7 +7178,7 @@
           <p:cNvPr id="22" name="">
             <a:extLst xmlns:a="http://schemas.openxmlformats.org/drawingml/2006/main">
               <a:ext uri="{FF2B5EF4-FFF2-40B4-BE49-F238E27FC236}">
-                <a16:creationId xmlns:a16="http://schemas.microsoft.com/office/drawing/2014/main" id="{DC3446A8-2D46-45EE-80DA-4EDC97861B27}"/>
+                <a16:creationId xmlns:a16="http://schemas.microsoft.com/office/drawing/2014/main" id="{04F0AB17-75BB-42A3-8182-1C8A3B4D6013}"/>
               </a:ext>
             </a:extLst>
           </p:cNvPr>
@@ -7242,7 +7242,7 @@
           <p:cNvPr id="23" name="">
             <a:extLst xmlns:a="http://schemas.openxmlformats.org/drawingml/2006/main">
               <a:ext uri="{FF2B5EF4-FFF2-40B4-BE49-F238E27FC236}">
-                <a16:creationId xmlns:a16="http://schemas.microsoft.com/office/drawing/2014/main" id="{719EB79B-664B-4693-B0F0-6D1ED2A1C526}"/>
+                <a16:creationId xmlns:a16="http://schemas.microsoft.com/office/drawing/2014/main" id="{A861B946-064D-4862-AAD6-F78BA312E2EB}"/>
               </a:ext>
             </a:extLst>
           </p:cNvPr>
@@ -7306,7 +7306,7 @@
           <p:cNvPr id="24" name="">
             <a:extLst xmlns:a="http://schemas.openxmlformats.org/drawingml/2006/main">
               <a:ext uri="{FF2B5EF4-FFF2-40B4-BE49-F238E27FC236}">
-                <a16:creationId xmlns:a16="http://schemas.microsoft.com/office/drawing/2014/main" id="{DA3022A9-13FA-4723-B30B-0DD3C5A8F940}"/>
+                <a16:creationId xmlns:a16="http://schemas.microsoft.com/office/drawing/2014/main" id="{695BAB0A-4BF6-4BB2-B587-B089FE1F4AD1}"/>
               </a:ext>
             </a:extLst>
           </p:cNvPr>
@@ -7368,7 +7368,7 @@
     </p:spTree>
     <p:extLst>
       <p:ext uri="{BB962C8B-B14F-4D97-AF65-F5344CB8AC3E}">
-        <p14:creationId xmlns:p14="http://schemas.microsoft.com/office/powerpoint/2010/main" val="168901779"/>
+        <p14:creationId xmlns:p14="http://schemas.microsoft.com/office/powerpoint/2010/main" val="1420780870"/>
       </p:ext>
     </p:extLst>
   </p:cSld>
@@ -7392,7 +7392,7 @@
           <p:cNvPr id="1" name="">
             <a:extLst xmlns:a="http://schemas.openxmlformats.org/drawingml/2006/main">
               <a:ext uri="{FF2B5EF4-FFF2-40B4-BE49-F238E27FC236}">
-                <a16:creationId xmlns:a16="http://schemas.microsoft.com/office/drawing/2014/main" id="{53EE073E-8083-44BA-8269-495A9EB88D03}"/>
+                <a16:creationId xmlns:a16="http://schemas.microsoft.com/office/drawing/2014/main" id="{3A535203-7113-4843-A68A-A38C6E895F8B}"/>
               </a:ext>
             </a:extLst>
           </p:cNvPr>
@@ -7427,7 +7427,7 @@
           <p:cNvPr id="2" name="">
             <a:extLst xmlns:a="http://schemas.openxmlformats.org/drawingml/2006/main">
               <a:ext uri="{FF2B5EF4-FFF2-40B4-BE49-F238E27FC236}">
-                <a16:creationId xmlns:a16="http://schemas.microsoft.com/office/drawing/2014/main" id="{2155ADA5-23CF-4FA8-B98F-26EE092F667C}"/>
+                <a16:creationId xmlns:a16="http://schemas.microsoft.com/office/drawing/2014/main" id="{295F00EC-FBFE-49F9-AF30-30B071C4098D}"/>
               </a:ext>
             </a:extLst>
           </p:cNvPr>
@@ -7491,7 +7491,7 @@
           <p:cNvPr id="3" name="">
             <a:extLst xmlns:a="http://schemas.openxmlformats.org/drawingml/2006/main">
               <a:ext uri="{FF2B5EF4-FFF2-40B4-BE49-F238E27FC236}">
-                <a16:creationId xmlns:a16="http://schemas.microsoft.com/office/drawing/2014/main" id="{C5B471E7-ACDA-4532-99F8-0D80A082E222}"/>
+                <a16:creationId xmlns:a16="http://schemas.microsoft.com/office/drawing/2014/main" id="{B0E2EF71-8509-4852-8333-6CF9BFF367CE}"/>
               </a:ext>
             </a:extLst>
           </p:cNvPr>
@@ -7555,7 +7555,7 @@
           <p:cNvPr id="4" name="">
             <a:extLst xmlns:a="http://schemas.openxmlformats.org/drawingml/2006/main">
               <a:ext uri="{FF2B5EF4-FFF2-40B4-BE49-F238E27FC236}">
-                <a16:creationId xmlns:a16="http://schemas.microsoft.com/office/drawing/2014/main" id="{E97FD269-8B0A-48EC-8CB5-F783F9114EF3}"/>
+                <a16:creationId xmlns:a16="http://schemas.microsoft.com/office/drawing/2014/main" id="{A7166039-F1C1-4C49-86D0-3E3ACB8D516D}"/>
               </a:ext>
             </a:extLst>
           </p:cNvPr>
@@ -7619,7 +7619,7 @@
           <p:cNvPr id="5" name="">
             <a:extLst xmlns:a="http://schemas.openxmlformats.org/drawingml/2006/main">
               <a:ext uri="{FF2B5EF4-FFF2-40B4-BE49-F238E27FC236}">
-                <a16:creationId xmlns:a16="http://schemas.microsoft.com/office/drawing/2014/main" id="{3C491232-33A0-4E73-A217-8508D4F24F59}"/>
+                <a16:creationId xmlns:a16="http://schemas.microsoft.com/office/drawing/2014/main" id="{FC446992-97A2-441A-8B16-45266DBEC704}"/>
               </a:ext>
             </a:extLst>
           </p:cNvPr>
@@ -7652,7 +7652,7 @@
           <p:cNvPr id="6" name="">
             <a:extLst xmlns:a="http://schemas.openxmlformats.org/drawingml/2006/main">
               <a:ext uri="{FF2B5EF4-FFF2-40B4-BE49-F238E27FC236}">
-                <a16:creationId xmlns:a16="http://schemas.microsoft.com/office/drawing/2014/main" id="{351F2E02-D3FC-493C-8A79-2E469FCEFE9E}"/>
+                <a16:creationId xmlns:a16="http://schemas.microsoft.com/office/drawing/2014/main" id="{BF742F00-2F54-41A3-A21B-3B3505580C6D}"/>
               </a:ext>
             </a:extLst>
           </p:cNvPr>
@@ -7716,7 +7716,7 @@
           <p:cNvPr id="7" name="">
             <a:extLst xmlns:a="http://schemas.openxmlformats.org/drawingml/2006/main">
               <a:ext uri="{FF2B5EF4-FFF2-40B4-BE49-F238E27FC236}">
-                <a16:creationId xmlns:a16="http://schemas.microsoft.com/office/drawing/2014/main" id="{38174B2E-743F-4539-B64B-D553F5E2C20D}"/>
+                <a16:creationId xmlns:a16="http://schemas.microsoft.com/office/drawing/2014/main" id="{1E22DA76-9A5F-40B5-9344-686E9B6C928B}"/>
               </a:ext>
             </a:extLst>
           </p:cNvPr>
@@ -7780,7 +7780,7 @@
           <p:cNvPr id="8" name="">
             <a:extLst xmlns:a="http://schemas.openxmlformats.org/drawingml/2006/main">
               <a:ext uri="{FF2B5EF4-FFF2-40B4-BE49-F238E27FC236}">
-                <a16:creationId xmlns:a16="http://schemas.microsoft.com/office/drawing/2014/main" id="{F3DACEE0-1F15-4E05-BB67-F39604CD8E17}"/>
+                <a16:creationId xmlns:a16="http://schemas.microsoft.com/office/drawing/2014/main" id="{EE63AD08-8F6D-4556-9E57-DD52C476D6B0}"/>
               </a:ext>
             </a:extLst>
           </p:cNvPr>
@@ -7813,7 +7813,7 @@
           <p:cNvPr id="9" name="">
             <a:extLst xmlns:a="http://schemas.openxmlformats.org/drawingml/2006/main">
               <a:ext uri="{FF2B5EF4-FFF2-40B4-BE49-F238E27FC236}">
-                <a16:creationId xmlns:a16="http://schemas.microsoft.com/office/drawing/2014/main" id="{A5D0C88E-1D55-47F1-8E15-FFA481526D28}"/>
+                <a16:creationId xmlns:a16="http://schemas.microsoft.com/office/drawing/2014/main" id="{FDF2B506-1860-4F78-8354-F8C459DF8128}"/>
               </a:ext>
             </a:extLst>
           </p:cNvPr>
@@ -7877,7 +7877,7 @@
           <p:cNvPr id="10" name="">
             <a:extLst xmlns:a="http://schemas.openxmlformats.org/drawingml/2006/main">
               <a:ext uri="{FF2B5EF4-FFF2-40B4-BE49-F238E27FC236}">
-                <a16:creationId xmlns:a16="http://schemas.microsoft.com/office/drawing/2014/main" id="{E0AD3FF8-9969-4B00-AC33-34289F93D5AE}"/>
+                <a16:creationId xmlns:a16="http://schemas.microsoft.com/office/drawing/2014/main" id="{AD514D7B-3B8E-48EB-B728-6947875B1CE5}"/>
               </a:ext>
             </a:extLst>
           </p:cNvPr>
@@ -7941,7 +7941,7 @@
           <p:cNvPr id="11" name="">
             <a:extLst xmlns:a="http://schemas.openxmlformats.org/drawingml/2006/main">
               <a:ext uri="{FF2B5EF4-FFF2-40B4-BE49-F238E27FC236}">
-                <a16:creationId xmlns:a16="http://schemas.microsoft.com/office/drawing/2014/main" id="{568D9054-FD4F-45AD-8B05-3D3199A8A399}"/>
+                <a16:creationId xmlns:a16="http://schemas.microsoft.com/office/drawing/2014/main" id="{4C3A0AE0-5CA2-414D-A42A-CF8D572884FC}"/>
               </a:ext>
             </a:extLst>
           </p:cNvPr>
@@ -7974,7 +7974,7 @@
           <p:cNvPr id="12" name="">
             <a:extLst xmlns:a="http://schemas.openxmlformats.org/drawingml/2006/main">
               <a:ext uri="{FF2B5EF4-FFF2-40B4-BE49-F238E27FC236}">
-                <a16:creationId xmlns:a16="http://schemas.microsoft.com/office/drawing/2014/main" id="{3795F272-DFA5-4FD7-A8BE-D491CF3691F4}"/>
+                <a16:creationId xmlns:a16="http://schemas.microsoft.com/office/drawing/2014/main" id="{C458620D-AAB5-4532-AE21-882E37B1FFDA}"/>
               </a:ext>
             </a:extLst>
           </p:cNvPr>
@@ -8038,7 +8038,7 @@
           <p:cNvPr id="13" name="">
             <a:extLst xmlns:a="http://schemas.openxmlformats.org/drawingml/2006/main">
               <a:ext uri="{FF2B5EF4-FFF2-40B4-BE49-F238E27FC236}">
-                <a16:creationId xmlns:a16="http://schemas.microsoft.com/office/drawing/2014/main" id="{18EFD586-34A7-427C-9E25-3DE11C74FAE1}"/>
+                <a16:creationId xmlns:a16="http://schemas.microsoft.com/office/drawing/2014/main" id="{0A264B90-58C8-4773-B409-BE86D7761D16}"/>
               </a:ext>
             </a:extLst>
           </p:cNvPr>
@@ -8102,7 +8102,7 @@
           <p:cNvPr id="14" name="">
             <a:extLst xmlns:a="http://schemas.openxmlformats.org/drawingml/2006/main">
               <a:ext uri="{FF2B5EF4-FFF2-40B4-BE49-F238E27FC236}">
-                <a16:creationId xmlns:a16="http://schemas.microsoft.com/office/drawing/2014/main" id="{D25FEAD7-963D-45DF-922B-7860472804A9}"/>
+                <a16:creationId xmlns:a16="http://schemas.microsoft.com/office/drawing/2014/main" id="{CA3AA1EF-CB88-4606-9D08-78CB4B0712A2}"/>
               </a:ext>
             </a:extLst>
           </p:cNvPr>
@@ -8135,7 +8135,7 @@
           <p:cNvPr id="15" name="">
             <a:extLst xmlns:a="http://schemas.openxmlformats.org/drawingml/2006/main">
               <a:ext uri="{FF2B5EF4-FFF2-40B4-BE49-F238E27FC236}">
-                <a16:creationId xmlns:a16="http://schemas.microsoft.com/office/drawing/2014/main" id="{D8191A92-5889-4546-9809-264BF1B44EB7}"/>
+                <a16:creationId xmlns:a16="http://schemas.microsoft.com/office/drawing/2014/main" id="{5B2BD48A-9D8F-48B5-86C3-F2AA369DF7D4}"/>
               </a:ext>
             </a:extLst>
           </p:cNvPr>
@@ -8199,7 +8199,7 @@
           <p:cNvPr id="16" name="">
             <a:extLst xmlns:a="http://schemas.openxmlformats.org/drawingml/2006/main">
               <a:ext uri="{FF2B5EF4-FFF2-40B4-BE49-F238E27FC236}">
-                <a16:creationId xmlns:a16="http://schemas.microsoft.com/office/drawing/2014/main" id="{090B9A10-D82A-4233-9823-9D6967155E02}"/>
+                <a16:creationId xmlns:a16="http://schemas.microsoft.com/office/drawing/2014/main" id="{1E5C2B7B-88D7-4469-9206-D135D21C099C}"/>
               </a:ext>
             </a:extLst>
           </p:cNvPr>
@@ -8263,7 +8263,7 @@
           <p:cNvPr id="17" name="">
             <a:extLst xmlns:a="http://schemas.openxmlformats.org/drawingml/2006/main">
               <a:ext uri="{FF2B5EF4-FFF2-40B4-BE49-F238E27FC236}">
-                <a16:creationId xmlns:a16="http://schemas.microsoft.com/office/drawing/2014/main" id="{2BB6DF54-735F-4769-B3D5-F64BF94599BB}"/>
+                <a16:creationId xmlns:a16="http://schemas.microsoft.com/office/drawing/2014/main" id="{CBF19166-7E04-4735-A59B-315C3F4EF5C9}"/>
               </a:ext>
             </a:extLst>
           </p:cNvPr>
@@ -8296,7 +8296,7 @@
           <p:cNvPr id="18" name="">
             <a:extLst xmlns:a="http://schemas.openxmlformats.org/drawingml/2006/main">
               <a:ext uri="{FF2B5EF4-FFF2-40B4-BE49-F238E27FC236}">
-                <a16:creationId xmlns:a16="http://schemas.microsoft.com/office/drawing/2014/main" id="{2B34BFF9-8708-4047-AC1C-D709676B8797}"/>
+                <a16:creationId xmlns:a16="http://schemas.microsoft.com/office/drawing/2014/main" id="{84E91101-37E9-4614-9ACE-592DF9FE3831}"/>
               </a:ext>
             </a:extLst>
           </p:cNvPr>
@@ -8360,7 +8360,7 @@
           <p:cNvPr id="19" name="">
             <a:extLst xmlns:a="http://schemas.openxmlformats.org/drawingml/2006/main">
               <a:ext uri="{FF2B5EF4-FFF2-40B4-BE49-F238E27FC236}">
-                <a16:creationId xmlns:a16="http://schemas.microsoft.com/office/drawing/2014/main" id="{72B89748-A6CA-4186-A3A8-5D8159410562}"/>
+                <a16:creationId xmlns:a16="http://schemas.microsoft.com/office/drawing/2014/main" id="{B4098635-EFB9-4744-9D90-B444980416AE}"/>
               </a:ext>
             </a:extLst>
           </p:cNvPr>
@@ -8424,7 +8424,7 @@
           <p:cNvPr id="20" name="">
             <a:extLst xmlns:a="http://schemas.openxmlformats.org/drawingml/2006/main">
               <a:ext uri="{FF2B5EF4-FFF2-40B4-BE49-F238E27FC236}">
-                <a16:creationId xmlns:a16="http://schemas.microsoft.com/office/drawing/2014/main" id="{9CDF49A0-9F6D-4877-BD35-547F823D56F1}"/>
+                <a16:creationId xmlns:a16="http://schemas.microsoft.com/office/drawing/2014/main" id="{A2C1D1A1-96D0-4324-B13B-B64BDAD61055}"/>
               </a:ext>
             </a:extLst>
           </p:cNvPr>
@@ -8457,7 +8457,7 @@
           <p:cNvPr id="21" name="">
             <a:extLst xmlns:a="http://schemas.openxmlformats.org/drawingml/2006/main">
               <a:ext uri="{FF2B5EF4-FFF2-40B4-BE49-F238E27FC236}">
-                <a16:creationId xmlns:a16="http://schemas.microsoft.com/office/drawing/2014/main" id="{865A80BB-19E8-4543-99E3-81A7CA079CF3}"/>
+                <a16:creationId xmlns:a16="http://schemas.microsoft.com/office/drawing/2014/main" id="{80EF3400-9F8B-4052-8DB5-50FCB4428DB9}"/>
               </a:ext>
             </a:extLst>
           </p:cNvPr>
@@ -8521,7 +8521,7 @@
           <p:cNvPr id="22" name="">
             <a:extLst xmlns:a="http://schemas.openxmlformats.org/drawingml/2006/main">
               <a:ext uri="{FF2B5EF4-FFF2-40B4-BE49-F238E27FC236}">
-                <a16:creationId xmlns:a16="http://schemas.microsoft.com/office/drawing/2014/main" id="{9AE65BDB-5405-4867-8DD1-5185E8A706F9}"/>
+                <a16:creationId xmlns:a16="http://schemas.microsoft.com/office/drawing/2014/main" id="{FECB8AC9-6FFD-454E-9433-04C41C1BFC63}"/>
               </a:ext>
             </a:extLst>
           </p:cNvPr>
@@ -8585,7 +8585,7 @@
           <p:cNvPr id="23" name="">
             <a:extLst xmlns:a="http://schemas.openxmlformats.org/drawingml/2006/main">
               <a:ext uri="{FF2B5EF4-FFF2-40B4-BE49-F238E27FC236}">
-                <a16:creationId xmlns:a16="http://schemas.microsoft.com/office/drawing/2014/main" id="{DE4FE21C-57CB-46E8-A7A7-78863F64D160}"/>
+                <a16:creationId xmlns:a16="http://schemas.microsoft.com/office/drawing/2014/main" id="{DC263F65-4CE3-44DC-A5F2-23676C0B5DDB}"/>
               </a:ext>
             </a:extLst>
           </p:cNvPr>
@@ -8618,7 +8618,7 @@
           <p:cNvPr id="24" name="">
             <a:extLst xmlns:a="http://schemas.openxmlformats.org/drawingml/2006/main">
               <a:ext uri="{FF2B5EF4-FFF2-40B4-BE49-F238E27FC236}">
-                <a16:creationId xmlns:a16="http://schemas.microsoft.com/office/drawing/2014/main" id="{5EDC42C7-D665-45F4-8118-49AA0ACC8E24}"/>
+                <a16:creationId xmlns:a16="http://schemas.microsoft.com/office/drawing/2014/main" id="{6911530B-B730-4379-B904-E230BAE8DA45}"/>
               </a:ext>
             </a:extLst>
           </p:cNvPr>
@@ -8682,7 +8682,7 @@
           <p:cNvPr id="25" name="">
             <a:extLst xmlns:a="http://schemas.openxmlformats.org/drawingml/2006/main">
               <a:ext uri="{FF2B5EF4-FFF2-40B4-BE49-F238E27FC236}">
-                <a16:creationId xmlns:a16="http://schemas.microsoft.com/office/drawing/2014/main" id="{9EF9CAE7-6597-4613-9EDF-53ED3B7FEFB7}"/>
+                <a16:creationId xmlns:a16="http://schemas.microsoft.com/office/drawing/2014/main" id="{60C18868-0A84-4ADC-9694-BA833ECDE81C}"/>
               </a:ext>
             </a:extLst>
           </p:cNvPr>
@@ -8746,7 +8746,7 @@
           <p:cNvPr id="26" name="">
             <a:extLst xmlns:a="http://schemas.openxmlformats.org/drawingml/2006/main">
               <a:ext uri="{FF2B5EF4-FFF2-40B4-BE49-F238E27FC236}">
-                <a16:creationId xmlns:a16="http://schemas.microsoft.com/office/drawing/2014/main" id="{0C1B2216-41AD-4E68-A163-CC6327EBA61B}"/>
+                <a16:creationId xmlns:a16="http://schemas.microsoft.com/office/drawing/2014/main" id="{6B8C6EEA-060B-4926-847E-1F0C4819EECB}"/>
               </a:ext>
             </a:extLst>
           </p:cNvPr>
@@ -8810,7 +8810,7 @@
           <p:cNvPr id="27" name="">
             <a:extLst xmlns:a="http://schemas.openxmlformats.org/drawingml/2006/main">
               <a:ext uri="{FF2B5EF4-FFF2-40B4-BE49-F238E27FC236}">
-                <a16:creationId xmlns:a16="http://schemas.microsoft.com/office/drawing/2014/main" id="{3AC26561-BB77-407A-B667-4B6FF6EA1178}"/>
+                <a16:creationId xmlns:a16="http://schemas.microsoft.com/office/drawing/2014/main" id="{6A599D50-E11B-497A-9C36-170F8EAB9AB7}"/>
               </a:ext>
             </a:extLst>
           </p:cNvPr>
@@ -8872,7 +8872,7 @@
     </p:spTree>
     <p:extLst>
       <p:ext uri="{BB962C8B-B14F-4D97-AF65-F5344CB8AC3E}">
-        <p14:creationId xmlns:p14="http://schemas.microsoft.com/office/powerpoint/2010/main" val="1159092800"/>
+        <p14:creationId xmlns:p14="http://schemas.microsoft.com/office/powerpoint/2010/main" val="1390913658"/>
       </p:ext>
     </p:extLst>
   </p:cSld>
@@ -8896,7 +8896,7 @@
           <p:cNvPr id="1" name="">
             <a:extLst xmlns:a="http://schemas.openxmlformats.org/drawingml/2006/main">
               <a:ext uri="{FF2B5EF4-FFF2-40B4-BE49-F238E27FC236}">
-                <a16:creationId xmlns:a16="http://schemas.microsoft.com/office/drawing/2014/main" id="{84000C66-C9AD-40F7-82C3-9EABC8D145DA}"/>
+                <a16:creationId xmlns:a16="http://schemas.microsoft.com/office/drawing/2014/main" id="{FE138756-073D-4A49-86F9-B4F974B11900}"/>
               </a:ext>
             </a:extLst>
           </p:cNvPr>
@@ -8931,7 +8931,7 @@
           <p:cNvPr id="2" name="">
             <a:extLst xmlns:a="http://schemas.openxmlformats.org/drawingml/2006/main">
               <a:ext uri="{FF2B5EF4-FFF2-40B4-BE49-F238E27FC236}">
-                <a16:creationId xmlns:a16="http://schemas.microsoft.com/office/drawing/2014/main" id="{EDF32FC6-30B6-4AE4-92C7-69B6C715E87F}"/>
+                <a16:creationId xmlns:a16="http://schemas.microsoft.com/office/drawing/2014/main" id="{246AD9EA-8B9D-4C33-8863-696497E590C4}"/>
               </a:ext>
             </a:extLst>
           </p:cNvPr>
@@ -8995,7 +8995,7 @@
           <p:cNvPr id="3" name="">
             <a:extLst xmlns:a="http://schemas.openxmlformats.org/drawingml/2006/main">
               <a:ext uri="{FF2B5EF4-FFF2-40B4-BE49-F238E27FC236}">
-                <a16:creationId xmlns:a16="http://schemas.microsoft.com/office/drawing/2014/main" id="{945852C6-9362-428E-8696-E19882A7D398}"/>
+                <a16:creationId xmlns:a16="http://schemas.microsoft.com/office/drawing/2014/main" id="{6C5B95EF-132B-4B72-A1B9-2D8FED75BC47}"/>
               </a:ext>
             </a:extLst>
           </p:cNvPr>
@@ -9007,31 +9007,31 @@
         <p:spPr>
           <a:xfrm xmlns:a="http://schemas.openxmlformats.org/drawingml/2006/main">
             <a:off x="552450" y="781050"/>
-            <a:ext cx="7239000" cy="1381125"/>
-          </a:xfrm>
-          <a:prstGeom xmlns:a="http://schemas.openxmlformats.org/drawingml/2006/main" prst="rect">
-            <a:avLst/>
-          </a:prstGeom>
-          <a:solidFill xmlns:a="http://schemas.openxmlformats.org/drawingml/2006/main">
-            <a:srgbClr val="000000">
-              <a:alpha val="0"/>
-            </a:srgbClr>
-          </a:solidFill>
-          <a:ln xmlns:a="http://schemas.openxmlformats.org/drawingml/2006/main" w="0">
-            <a:solidFill>
-              <a:srgbClr val="000000">
-                <a:alpha val="0"/>
-              </a:srgbClr>
-            </a:solidFill>
-            <a:prstDash val="solid"/>
-          </a:ln>
-        </p:spPr>
-        <p:txBody>
-          <a:bodyPr xmlns:a="http://schemas.openxmlformats.org/drawingml/2006/main" lIns="0" tIns="0" rIns="0" bIns="0" anchor="t"/>
-          <a:lstStyle xmlns:a="http://schemas.openxmlformats.org/drawingml/2006/main"/>
-          <a:p xmlns:a="http://schemas.openxmlformats.org/drawingml/2006/main">
-            <a:pPr algn="l">
-              <a:defRPr sz="2700" b="1">
+            <a:ext cx="6572250" cy="1381125"/>
+          </a:xfrm>
+          <a:prstGeom xmlns:a="http://schemas.openxmlformats.org/drawingml/2006/main" prst="rect">
+            <a:avLst/>
+          </a:prstGeom>
+          <a:solidFill xmlns:a="http://schemas.openxmlformats.org/drawingml/2006/main">
+            <a:srgbClr val="000000">
+              <a:alpha val="0"/>
+            </a:srgbClr>
+          </a:solidFill>
+          <a:ln xmlns:a="http://schemas.openxmlformats.org/drawingml/2006/main" w="0">
+            <a:solidFill>
+              <a:srgbClr val="000000">
+                <a:alpha val="0"/>
+              </a:srgbClr>
+            </a:solidFill>
+            <a:prstDash val="solid"/>
+          </a:ln>
+        </p:spPr>
+        <p:txBody>
+          <a:bodyPr xmlns:a="http://schemas.openxmlformats.org/drawingml/2006/main" lIns="0" tIns="0" rIns="0" bIns="0" anchor="t"/>
+          <a:lstStyle xmlns:a="http://schemas.openxmlformats.org/drawingml/2006/main"/>
+          <a:p xmlns:a="http://schemas.openxmlformats.org/drawingml/2006/main">
+            <a:pPr algn="l">
+              <a:defRPr sz="2400" b="1">
                 <a:solidFill>
                   <a:srgbClr val="16211A"/>
                 </a:solidFill>
@@ -9041,7 +9041,7 @@
               </a:defRPr>
             </a:pPr>
             <a:r>
-              <a:rPr sz="2700" b="1">
+              <a:rPr sz="2400" b="1">
                 <a:solidFill>
                   <a:srgbClr val="16211A"/>
                 </a:solidFill>
@@ -9049,7 +9049,7 @@
                 <a:ea typeface="Aptos Display"/>
                 <a:cs typeface="Aptos Display"/>
               </a:rPr>
-              <a:t>A lightweight prototype keeps the demo stable while preserving honest live boundaries.</a:t>
+              <a:t>A lightweight prototype keeps the demo stable without broadening live claims.</a:t>
             </a:r>
           </a:p>
         </p:txBody>
@@ -9059,7 +9059,7 @@
           <p:cNvPr id="4" name="">
             <a:extLst xmlns:a="http://schemas.openxmlformats.org/drawingml/2006/main">
               <a:ext uri="{FF2B5EF4-FFF2-40B4-BE49-F238E27FC236}">
-                <a16:creationId xmlns:a16="http://schemas.microsoft.com/office/drawing/2014/main" id="{8D84D644-5527-4158-AE3A-7BC9D67BE607}"/>
+                <a16:creationId xmlns:a16="http://schemas.microsoft.com/office/drawing/2014/main" id="{32668FAD-48E2-4960-AF22-056AB296F0FD}"/>
               </a:ext>
             </a:extLst>
           </p:cNvPr>
@@ -9123,7 +9123,7 @@
           <p:cNvPr id="5" name="">
             <a:extLst xmlns:a="http://schemas.openxmlformats.org/drawingml/2006/main">
               <a:ext uri="{FF2B5EF4-FFF2-40B4-BE49-F238E27FC236}">
-                <a16:creationId xmlns:a16="http://schemas.microsoft.com/office/drawing/2014/main" id="{57AB737C-39F1-46B0-8D68-10D50B325E65}"/>
+                <a16:creationId xmlns:a16="http://schemas.microsoft.com/office/drawing/2014/main" id="{98CF7AA6-C36C-4200-9608-A055F6C9A296}"/>
               </a:ext>
             </a:extLst>
           </p:cNvPr>
@@ -9156,7 +9156,7 @@
           <p:cNvPr id="6" name="">
             <a:extLst xmlns:a="http://schemas.openxmlformats.org/drawingml/2006/main">
               <a:ext uri="{FF2B5EF4-FFF2-40B4-BE49-F238E27FC236}">
-                <a16:creationId xmlns:a16="http://schemas.microsoft.com/office/drawing/2014/main" id="{C04403C3-D0FA-4564-8AFF-894FDE472286}"/>
+                <a16:creationId xmlns:a16="http://schemas.microsoft.com/office/drawing/2014/main" id="{5BA090F6-5ADA-4763-812F-EC73A1F55222}"/>
               </a:ext>
             </a:extLst>
           </p:cNvPr>
@@ -9220,7 +9220,7 @@
           <p:cNvPr id="7" name="">
             <a:extLst xmlns:a="http://schemas.openxmlformats.org/drawingml/2006/main">
               <a:ext uri="{FF2B5EF4-FFF2-40B4-BE49-F238E27FC236}">
-                <a16:creationId xmlns:a16="http://schemas.microsoft.com/office/drawing/2014/main" id="{168F9939-5184-4AA4-A032-6073C894C269}"/>
+                <a16:creationId xmlns:a16="http://schemas.microsoft.com/office/drawing/2014/main" id="{F4AFB433-073F-4234-BFD2-BC693939294A}"/>
               </a:ext>
             </a:extLst>
           </p:cNvPr>
@@ -9284,19 +9284,19 @@
           <p:cNvPr id="8" name="">
             <a:extLst xmlns:a="http://schemas.openxmlformats.org/drawingml/2006/main">
               <a:ext uri="{FF2B5EF4-FFF2-40B4-BE49-F238E27FC236}">
-                <a16:creationId xmlns:a16="http://schemas.microsoft.com/office/drawing/2014/main" id="{73A65C25-5772-46C1-8484-9ADD203F5DE4}"/>
-              </a:ext>
-            </a:extLst>
-          </p:cNvPr>
-          <p:cNvSpPr>
-            <a:spLocks xmlns:a="http://schemas.openxmlformats.org/drawingml/2006/main" noGrp="1"/>
-          </p:cNvSpPr>
-          <p:nvPr/>
-        </p:nvSpPr>
-        <p:spPr>
-          <a:xfrm xmlns:a="http://schemas.openxmlformats.org/drawingml/2006/main">
-            <a:off x="7096125" y="1104900"/>
-            <a:ext cx="4524375" cy="628650"/>
+                <a16:creationId xmlns:a16="http://schemas.microsoft.com/office/drawing/2014/main" id="{D6BE51DD-B1C3-4FF2-8CAE-298D5020D0DA}"/>
+              </a:ext>
+            </a:extLst>
+          </p:cNvPr>
+          <p:cNvSpPr>
+            <a:spLocks xmlns:a="http://schemas.openxmlformats.org/drawingml/2006/main" noGrp="1"/>
+          </p:cNvSpPr>
+          <p:nvPr/>
+        </p:nvSpPr>
+        <p:spPr>
+          <a:xfrm xmlns:a="http://schemas.openxmlformats.org/drawingml/2006/main">
+            <a:off x="7953375" y="1524000"/>
+            <a:ext cx="3429000" cy="628650"/>
           </a:xfrm>
           <a:prstGeom xmlns:a="http://schemas.openxmlformats.org/drawingml/2006/main" prst="rect">
             <a:avLst/>
@@ -9317,19 +9317,19 @@
           <p:cNvPr id="9" name="">
             <a:extLst xmlns:a="http://schemas.openxmlformats.org/drawingml/2006/main">
               <a:ext uri="{FF2B5EF4-FFF2-40B4-BE49-F238E27FC236}">
-                <a16:creationId xmlns:a16="http://schemas.microsoft.com/office/drawing/2014/main" id="{BD6400A4-FB6F-4F88-A8D4-55F2CCB35597}"/>
-              </a:ext>
-            </a:extLst>
-          </p:cNvPr>
-          <p:cNvSpPr>
-            <a:spLocks xmlns:a="http://schemas.openxmlformats.org/drawingml/2006/main" noGrp="1"/>
-          </p:cNvSpPr>
-          <p:nvPr/>
-        </p:nvSpPr>
-        <p:spPr>
-          <a:xfrm xmlns:a="http://schemas.openxmlformats.org/drawingml/2006/main">
-            <a:off x="7229475" y="1219200"/>
-            <a:ext cx="4257675" cy="209550"/>
+                <a16:creationId xmlns:a16="http://schemas.microsoft.com/office/drawing/2014/main" id="{CCD0C05D-493B-467F-8B88-554047BC4EB2}"/>
+              </a:ext>
+            </a:extLst>
+          </p:cNvPr>
+          <p:cNvSpPr>
+            <a:spLocks xmlns:a="http://schemas.openxmlformats.org/drawingml/2006/main" noGrp="1"/>
+          </p:cNvSpPr>
+          <p:nvPr/>
+        </p:nvSpPr>
+        <p:spPr>
+          <a:xfrm xmlns:a="http://schemas.openxmlformats.org/drawingml/2006/main">
+            <a:off x="8086725" y="1638300"/>
+            <a:ext cx="3162300" cy="209550"/>
           </a:xfrm>
           <a:prstGeom xmlns:a="http://schemas.openxmlformats.org/drawingml/2006/main" prst="rect">
             <a:avLst/>
@@ -9381,19 +9381,19 @@
           <p:cNvPr id="10" name="">
             <a:extLst xmlns:a="http://schemas.openxmlformats.org/drawingml/2006/main">
               <a:ext uri="{FF2B5EF4-FFF2-40B4-BE49-F238E27FC236}">
-                <a16:creationId xmlns:a16="http://schemas.microsoft.com/office/drawing/2014/main" id="{0253B0C1-9C0C-4D86-BC9C-E83AF9481BED}"/>
-              </a:ext>
-            </a:extLst>
-          </p:cNvPr>
-          <p:cNvSpPr>
-            <a:spLocks xmlns:a="http://schemas.openxmlformats.org/drawingml/2006/main" noGrp="1"/>
-          </p:cNvSpPr>
-          <p:nvPr/>
-        </p:nvSpPr>
-        <p:spPr>
-          <a:xfrm xmlns:a="http://schemas.openxmlformats.org/drawingml/2006/main">
-            <a:off x="7229475" y="1466850"/>
-            <a:ext cx="4257675" cy="171450"/>
+                <a16:creationId xmlns:a16="http://schemas.microsoft.com/office/drawing/2014/main" id="{2F2BBCD6-974D-4A29-B885-9EBAA8EDD156}"/>
+              </a:ext>
+            </a:extLst>
+          </p:cNvPr>
+          <p:cNvSpPr>
+            <a:spLocks xmlns:a="http://schemas.openxmlformats.org/drawingml/2006/main" noGrp="1"/>
+          </p:cNvSpPr>
+          <p:nvPr/>
+        </p:nvSpPr>
+        <p:spPr>
+          <a:xfrm xmlns:a="http://schemas.openxmlformats.org/drawingml/2006/main">
+            <a:off x="8086725" y="1885950"/>
+            <a:ext cx="3162300" cy="171450"/>
           </a:xfrm>
           <a:prstGeom xmlns:a="http://schemas.openxmlformats.org/drawingml/2006/main" prst="rect">
             <a:avLst/>
@@ -9445,19 +9445,19 @@
           <p:cNvPr id="11" name="">
             <a:extLst xmlns:a="http://schemas.openxmlformats.org/drawingml/2006/main">
               <a:ext uri="{FF2B5EF4-FFF2-40B4-BE49-F238E27FC236}">
-                <a16:creationId xmlns:a16="http://schemas.microsoft.com/office/drawing/2014/main" id="{D2A4302A-4CBD-4F61-88DD-EE5F983E282B}"/>
-              </a:ext>
-            </a:extLst>
-          </p:cNvPr>
-          <p:cNvSpPr>
-            <a:spLocks xmlns:a="http://schemas.openxmlformats.org/drawingml/2006/main" noGrp="1"/>
-          </p:cNvSpPr>
-          <p:nvPr/>
-        </p:nvSpPr>
-        <p:spPr>
-          <a:xfrm xmlns:a="http://schemas.openxmlformats.org/drawingml/2006/main">
-            <a:off x="7096125" y="1924050"/>
-            <a:ext cx="4524375" cy="628650"/>
+                <a16:creationId xmlns:a16="http://schemas.microsoft.com/office/drawing/2014/main" id="{F07990C6-ABAB-4F5F-AA47-EA6BC1510662}"/>
+              </a:ext>
+            </a:extLst>
+          </p:cNvPr>
+          <p:cNvSpPr>
+            <a:spLocks xmlns:a="http://schemas.openxmlformats.org/drawingml/2006/main" noGrp="1"/>
+          </p:cNvSpPr>
+          <p:nvPr/>
+        </p:nvSpPr>
+        <p:spPr>
+          <a:xfrm xmlns:a="http://schemas.openxmlformats.org/drawingml/2006/main">
+            <a:off x="7953375" y="2343150"/>
+            <a:ext cx="3429000" cy="628650"/>
           </a:xfrm>
           <a:prstGeom xmlns:a="http://schemas.openxmlformats.org/drawingml/2006/main" prst="rect">
             <a:avLst/>
@@ -9478,19 +9478,19 @@
           <p:cNvPr id="12" name="">
             <a:extLst xmlns:a="http://schemas.openxmlformats.org/drawingml/2006/main">
               <a:ext uri="{FF2B5EF4-FFF2-40B4-BE49-F238E27FC236}">
-                <a16:creationId xmlns:a16="http://schemas.microsoft.com/office/drawing/2014/main" id="{51CE2B89-49D3-462F-B997-ADCE8531B3B9}"/>
-              </a:ext>
-            </a:extLst>
-          </p:cNvPr>
-          <p:cNvSpPr>
-            <a:spLocks xmlns:a="http://schemas.openxmlformats.org/drawingml/2006/main" noGrp="1"/>
-          </p:cNvSpPr>
-          <p:nvPr/>
-        </p:nvSpPr>
-        <p:spPr>
-          <a:xfrm xmlns:a="http://schemas.openxmlformats.org/drawingml/2006/main">
-            <a:off x="7229475" y="2038350"/>
-            <a:ext cx="4257675" cy="209550"/>
+                <a16:creationId xmlns:a16="http://schemas.microsoft.com/office/drawing/2014/main" id="{4C4471AF-17A6-4A1F-96EC-32DB6D7FC0B5}"/>
+              </a:ext>
+            </a:extLst>
+          </p:cNvPr>
+          <p:cNvSpPr>
+            <a:spLocks xmlns:a="http://schemas.openxmlformats.org/drawingml/2006/main" noGrp="1"/>
+          </p:cNvSpPr>
+          <p:nvPr/>
+        </p:nvSpPr>
+        <p:spPr>
+          <a:xfrm xmlns:a="http://schemas.openxmlformats.org/drawingml/2006/main">
+            <a:off x="8086725" y="2457450"/>
+            <a:ext cx="3162300" cy="209550"/>
           </a:xfrm>
           <a:prstGeom xmlns:a="http://schemas.openxmlformats.org/drawingml/2006/main" prst="rect">
             <a:avLst/>
@@ -9542,19 +9542,19 @@
           <p:cNvPr id="13" name="">
             <a:extLst xmlns:a="http://schemas.openxmlformats.org/drawingml/2006/main">
               <a:ext uri="{FF2B5EF4-FFF2-40B4-BE49-F238E27FC236}">
-                <a16:creationId xmlns:a16="http://schemas.microsoft.com/office/drawing/2014/main" id="{0C1C4106-F415-44C1-9AD7-B22B9E1384F0}"/>
-              </a:ext>
-            </a:extLst>
-          </p:cNvPr>
-          <p:cNvSpPr>
-            <a:spLocks xmlns:a="http://schemas.openxmlformats.org/drawingml/2006/main" noGrp="1"/>
-          </p:cNvSpPr>
-          <p:nvPr/>
-        </p:nvSpPr>
-        <p:spPr>
-          <a:xfrm xmlns:a="http://schemas.openxmlformats.org/drawingml/2006/main">
-            <a:off x="7229475" y="2286000"/>
-            <a:ext cx="4257675" cy="171450"/>
+                <a16:creationId xmlns:a16="http://schemas.microsoft.com/office/drawing/2014/main" id="{765DB173-6979-4997-A397-5ABFB9F8DFF9}"/>
+              </a:ext>
+            </a:extLst>
+          </p:cNvPr>
+          <p:cNvSpPr>
+            <a:spLocks xmlns:a="http://schemas.openxmlformats.org/drawingml/2006/main" noGrp="1"/>
+          </p:cNvSpPr>
+          <p:nvPr/>
+        </p:nvSpPr>
+        <p:spPr>
+          <a:xfrm xmlns:a="http://schemas.openxmlformats.org/drawingml/2006/main">
+            <a:off x="8086725" y="2705100"/>
+            <a:ext cx="3162300" cy="171450"/>
           </a:xfrm>
           <a:prstGeom xmlns:a="http://schemas.openxmlformats.org/drawingml/2006/main" prst="rect">
             <a:avLst/>
@@ -9606,19 +9606,19 @@
           <p:cNvPr id="14" name="">
             <a:extLst xmlns:a="http://schemas.openxmlformats.org/drawingml/2006/main">
               <a:ext uri="{FF2B5EF4-FFF2-40B4-BE49-F238E27FC236}">
-                <a16:creationId xmlns:a16="http://schemas.microsoft.com/office/drawing/2014/main" id="{0D74B974-F356-4326-8DE6-1DE4B150EDF6}"/>
-              </a:ext>
-            </a:extLst>
-          </p:cNvPr>
-          <p:cNvSpPr>
-            <a:spLocks xmlns:a="http://schemas.openxmlformats.org/drawingml/2006/main" noGrp="1"/>
-          </p:cNvSpPr>
-          <p:nvPr/>
-        </p:nvSpPr>
-        <p:spPr>
-          <a:xfrm xmlns:a="http://schemas.openxmlformats.org/drawingml/2006/main">
-            <a:off x="7096125" y="2743200"/>
-            <a:ext cx="4524375" cy="628650"/>
+                <a16:creationId xmlns:a16="http://schemas.microsoft.com/office/drawing/2014/main" id="{7DCA8027-22AB-4BD2-A112-5FBD92D00728}"/>
+              </a:ext>
+            </a:extLst>
+          </p:cNvPr>
+          <p:cNvSpPr>
+            <a:spLocks xmlns:a="http://schemas.openxmlformats.org/drawingml/2006/main" noGrp="1"/>
+          </p:cNvSpPr>
+          <p:nvPr/>
+        </p:nvSpPr>
+        <p:spPr>
+          <a:xfrm xmlns:a="http://schemas.openxmlformats.org/drawingml/2006/main">
+            <a:off x="7953375" y="3162300"/>
+            <a:ext cx="3429000" cy="628650"/>
           </a:xfrm>
           <a:prstGeom xmlns:a="http://schemas.openxmlformats.org/drawingml/2006/main" prst="rect">
             <a:avLst/>
@@ -9639,19 +9639,19 @@
           <p:cNvPr id="15" name="">
             <a:extLst xmlns:a="http://schemas.openxmlformats.org/drawingml/2006/main">
               <a:ext uri="{FF2B5EF4-FFF2-40B4-BE49-F238E27FC236}">
-                <a16:creationId xmlns:a16="http://schemas.microsoft.com/office/drawing/2014/main" id="{09148C76-C9C9-4F5D-9989-679EAD327BBA}"/>
-              </a:ext>
-            </a:extLst>
-          </p:cNvPr>
-          <p:cNvSpPr>
-            <a:spLocks xmlns:a="http://schemas.openxmlformats.org/drawingml/2006/main" noGrp="1"/>
-          </p:cNvSpPr>
-          <p:nvPr/>
-        </p:nvSpPr>
-        <p:spPr>
-          <a:xfrm xmlns:a="http://schemas.openxmlformats.org/drawingml/2006/main">
-            <a:off x="7229475" y="2857500"/>
-            <a:ext cx="4257675" cy="209550"/>
+                <a16:creationId xmlns:a16="http://schemas.microsoft.com/office/drawing/2014/main" id="{3E92A6EE-6481-42F3-BA83-3C94183C7362}"/>
+              </a:ext>
+            </a:extLst>
+          </p:cNvPr>
+          <p:cNvSpPr>
+            <a:spLocks xmlns:a="http://schemas.openxmlformats.org/drawingml/2006/main" noGrp="1"/>
+          </p:cNvSpPr>
+          <p:nvPr/>
+        </p:nvSpPr>
+        <p:spPr>
+          <a:xfrm xmlns:a="http://schemas.openxmlformats.org/drawingml/2006/main">
+            <a:off x="8086725" y="3276600"/>
+            <a:ext cx="3162300" cy="209550"/>
           </a:xfrm>
           <a:prstGeom xmlns:a="http://schemas.openxmlformats.org/drawingml/2006/main" prst="rect">
             <a:avLst/>
@@ -9703,19 +9703,19 @@
           <p:cNvPr id="16" name="">
             <a:extLst xmlns:a="http://schemas.openxmlformats.org/drawingml/2006/main">
               <a:ext uri="{FF2B5EF4-FFF2-40B4-BE49-F238E27FC236}">
-                <a16:creationId xmlns:a16="http://schemas.microsoft.com/office/drawing/2014/main" id="{353F7EBE-B145-4DC4-A308-443C936EA630}"/>
-              </a:ext>
-            </a:extLst>
-          </p:cNvPr>
-          <p:cNvSpPr>
-            <a:spLocks xmlns:a="http://schemas.openxmlformats.org/drawingml/2006/main" noGrp="1"/>
-          </p:cNvSpPr>
-          <p:nvPr/>
-        </p:nvSpPr>
-        <p:spPr>
-          <a:xfrm xmlns:a="http://schemas.openxmlformats.org/drawingml/2006/main">
-            <a:off x="7229475" y="3105150"/>
-            <a:ext cx="4257675" cy="171450"/>
+                <a16:creationId xmlns:a16="http://schemas.microsoft.com/office/drawing/2014/main" id="{EE82C500-FE7D-41DA-ABBB-FE25FCC9A29E}"/>
+              </a:ext>
+            </a:extLst>
+          </p:cNvPr>
+          <p:cNvSpPr>
+            <a:spLocks xmlns:a="http://schemas.openxmlformats.org/drawingml/2006/main" noGrp="1"/>
+          </p:cNvSpPr>
+          <p:nvPr/>
+        </p:nvSpPr>
+        <p:spPr>
+          <a:xfrm xmlns:a="http://schemas.openxmlformats.org/drawingml/2006/main">
+            <a:off x="8086725" y="3524250"/>
+            <a:ext cx="3162300" cy="171450"/>
           </a:xfrm>
           <a:prstGeom xmlns:a="http://schemas.openxmlformats.org/drawingml/2006/main" prst="rect">
             <a:avLst/>
@@ -9767,19 +9767,19 @@
           <p:cNvPr id="17" name="">
             <a:extLst xmlns:a="http://schemas.openxmlformats.org/drawingml/2006/main">
               <a:ext uri="{FF2B5EF4-FFF2-40B4-BE49-F238E27FC236}">
-                <a16:creationId xmlns:a16="http://schemas.microsoft.com/office/drawing/2014/main" id="{8431522E-1C09-4088-A84A-DBDB37724425}"/>
-              </a:ext>
-            </a:extLst>
-          </p:cNvPr>
-          <p:cNvSpPr>
-            <a:spLocks xmlns:a="http://schemas.openxmlformats.org/drawingml/2006/main" noGrp="1"/>
-          </p:cNvSpPr>
-          <p:nvPr/>
-        </p:nvSpPr>
-        <p:spPr>
-          <a:xfrm xmlns:a="http://schemas.openxmlformats.org/drawingml/2006/main">
-            <a:off x="7096125" y="3562350"/>
-            <a:ext cx="4524375" cy="628650"/>
+                <a16:creationId xmlns:a16="http://schemas.microsoft.com/office/drawing/2014/main" id="{62D895BA-0A7D-49B3-BE7C-BD008917F153}"/>
+              </a:ext>
+            </a:extLst>
+          </p:cNvPr>
+          <p:cNvSpPr>
+            <a:spLocks xmlns:a="http://schemas.openxmlformats.org/drawingml/2006/main" noGrp="1"/>
+          </p:cNvSpPr>
+          <p:nvPr/>
+        </p:nvSpPr>
+        <p:spPr>
+          <a:xfrm xmlns:a="http://schemas.openxmlformats.org/drawingml/2006/main">
+            <a:off x="7953375" y="3981450"/>
+            <a:ext cx="3429000" cy="628650"/>
           </a:xfrm>
           <a:prstGeom xmlns:a="http://schemas.openxmlformats.org/drawingml/2006/main" prst="rect">
             <a:avLst/>
@@ -9800,19 +9800,19 @@
           <p:cNvPr id="18" name="">
             <a:extLst xmlns:a="http://schemas.openxmlformats.org/drawingml/2006/main">
               <a:ext uri="{FF2B5EF4-FFF2-40B4-BE49-F238E27FC236}">
-                <a16:creationId xmlns:a16="http://schemas.microsoft.com/office/drawing/2014/main" id="{9D4E4DBC-9200-4233-8F3E-222C0B9A5770}"/>
-              </a:ext>
-            </a:extLst>
-          </p:cNvPr>
-          <p:cNvSpPr>
-            <a:spLocks xmlns:a="http://schemas.openxmlformats.org/drawingml/2006/main" noGrp="1"/>
-          </p:cNvSpPr>
-          <p:nvPr/>
-        </p:nvSpPr>
-        <p:spPr>
-          <a:xfrm xmlns:a="http://schemas.openxmlformats.org/drawingml/2006/main">
-            <a:off x="7229475" y="3676650"/>
-            <a:ext cx="4257675" cy="209550"/>
+                <a16:creationId xmlns:a16="http://schemas.microsoft.com/office/drawing/2014/main" id="{F85EDBC4-C9DB-47F9-A15F-259309E11138}"/>
+              </a:ext>
+            </a:extLst>
+          </p:cNvPr>
+          <p:cNvSpPr>
+            <a:spLocks xmlns:a="http://schemas.openxmlformats.org/drawingml/2006/main" noGrp="1"/>
+          </p:cNvSpPr>
+          <p:nvPr/>
+        </p:nvSpPr>
+        <p:spPr>
+          <a:xfrm xmlns:a="http://schemas.openxmlformats.org/drawingml/2006/main">
+            <a:off x="8086725" y="4095750"/>
+            <a:ext cx="3162300" cy="209550"/>
           </a:xfrm>
           <a:prstGeom xmlns:a="http://schemas.openxmlformats.org/drawingml/2006/main" prst="rect">
             <a:avLst/>
@@ -9864,19 +9864,19 @@
           <p:cNvPr id="19" name="">
             <a:extLst xmlns:a="http://schemas.openxmlformats.org/drawingml/2006/main">
               <a:ext uri="{FF2B5EF4-FFF2-40B4-BE49-F238E27FC236}">
-                <a16:creationId xmlns:a16="http://schemas.microsoft.com/office/drawing/2014/main" id="{86642F83-E097-4D2D-8BEC-7071E52A9AA6}"/>
-              </a:ext>
-            </a:extLst>
-          </p:cNvPr>
-          <p:cNvSpPr>
-            <a:spLocks xmlns:a="http://schemas.openxmlformats.org/drawingml/2006/main" noGrp="1"/>
-          </p:cNvSpPr>
-          <p:nvPr/>
-        </p:nvSpPr>
-        <p:spPr>
-          <a:xfrm xmlns:a="http://schemas.openxmlformats.org/drawingml/2006/main">
-            <a:off x="7229475" y="3924300"/>
-            <a:ext cx="4257675" cy="171450"/>
+                <a16:creationId xmlns:a16="http://schemas.microsoft.com/office/drawing/2014/main" id="{0394B54B-FC13-4DC2-A313-F5AF6A2B6E9E}"/>
+              </a:ext>
+            </a:extLst>
+          </p:cNvPr>
+          <p:cNvSpPr>
+            <a:spLocks xmlns:a="http://schemas.openxmlformats.org/drawingml/2006/main" noGrp="1"/>
+          </p:cNvSpPr>
+          <p:nvPr/>
+        </p:nvSpPr>
+        <p:spPr>
+          <a:xfrm xmlns:a="http://schemas.openxmlformats.org/drawingml/2006/main">
+            <a:off x="8086725" y="4343400"/>
+            <a:ext cx="3162300" cy="171450"/>
           </a:xfrm>
           <a:prstGeom xmlns:a="http://schemas.openxmlformats.org/drawingml/2006/main" prst="rect">
             <a:avLst/>
@@ -9928,7 +9928,7 @@
           <p:cNvPr id="20" name="">
             <a:extLst xmlns:a="http://schemas.openxmlformats.org/drawingml/2006/main">
               <a:ext uri="{FF2B5EF4-FFF2-40B4-BE49-F238E27FC236}">
-                <a16:creationId xmlns:a16="http://schemas.microsoft.com/office/drawing/2014/main" id="{F13D2F7C-A210-4639-B728-F6DE0E834D61}"/>
+                <a16:creationId xmlns:a16="http://schemas.microsoft.com/office/drawing/2014/main" id="{C2F25F5F-5205-4437-BE4A-6EF62314D955}"/>
               </a:ext>
             </a:extLst>
           </p:cNvPr>
@@ -9992,7 +9992,7 @@
           <p:cNvPr id="21" name="">
             <a:extLst xmlns:a="http://schemas.openxmlformats.org/drawingml/2006/main">
               <a:ext uri="{FF2B5EF4-FFF2-40B4-BE49-F238E27FC236}">
-                <a16:creationId xmlns:a16="http://schemas.microsoft.com/office/drawing/2014/main" id="{9E750C79-7BF5-4205-9A9E-55619B034D80}"/>
+                <a16:creationId xmlns:a16="http://schemas.microsoft.com/office/drawing/2014/main" id="{97706AB5-15CC-4911-98E6-089CAB5F6830}"/>
               </a:ext>
             </a:extLst>
           </p:cNvPr>
@@ -10054,7 +10054,7 @@
     </p:spTree>
     <p:extLst>
       <p:ext uri="{BB962C8B-B14F-4D97-AF65-F5344CB8AC3E}">
-        <p14:creationId xmlns:p14="http://schemas.microsoft.com/office/powerpoint/2010/main" val="1004747241"/>
+        <p14:creationId xmlns:p14="http://schemas.microsoft.com/office/powerpoint/2010/main" val="840809064"/>
       </p:ext>
     </p:extLst>
   </p:cSld>

</xml_diff>

<commit_message>
fix: polish TrustRoom UI and submission deck
</commit_message>
<xml_diff>
--- a/docs/submission-assets/rfp-trustroom-submission-deck.pptx
+++ b/docs/submission-assets/rfp-trustroom-submission-deck.pptx
@@ -2,20 +2,20 @@
 <file path=ppt/presentation.xml><?xml version="1.0" encoding="utf-8"?>
 <p:presentation xmlns:p="http://schemas.openxmlformats.org/presentationml/2006/main">
   <p:sldMasterIdLst>
-    <p:sldMasterId xmlns:r="http://schemas.openxmlformats.org/officeDocument/2006/relationships" id="2147483648" r:id="R000b3215d9e34abc"/>
+    <p:sldMasterId xmlns:r="http://schemas.openxmlformats.org/officeDocument/2006/relationships" id="2147483648" r:id="R699752fba75748d5"/>
   </p:sldMasterIdLst>
   <p:notesMasterIdLst>
-    <p:notesMasterId xmlns:r="http://schemas.openxmlformats.org/officeDocument/2006/relationships" r:id="R085c06d36dfd4ba5"/>
+    <p:notesMasterId xmlns:r="http://schemas.openxmlformats.org/officeDocument/2006/relationships" r:id="R858c40dce7124136"/>
   </p:notesMasterIdLst>
   <p:sldIdLst>
-    <p:sldId xmlns:r="http://schemas.openxmlformats.org/officeDocument/2006/relationships" id="256" r:id="R15040264448047b3"/>
-    <p:sldId xmlns:r="http://schemas.openxmlformats.org/officeDocument/2006/relationships" id="257" r:id="Raf6399b4864948b9"/>
-    <p:sldId xmlns:r="http://schemas.openxmlformats.org/officeDocument/2006/relationships" id="258" r:id="Re427276330a04204"/>
-    <p:sldId xmlns:r="http://schemas.openxmlformats.org/officeDocument/2006/relationships" id="259" r:id="Rbc282be1721e4478"/>
-    <p:sldId xmlns:r="http://schemas.openxmlformats.org/officeDocument/2006/relationships" id="260" r:id="R0362062d69264da3"/>
-    <p:sldId xmlns:r="http://schemas.openxmlformats.org/officeDocument/2006/relationships" id="261" r:id="Reccb6d19679c45f4"/>
-    <p:sldId xmlns:r="http://schemas.openxmlformats.org/officeDocument/2006/relationships" id="262" r:id="R5e51aa1470cb4edb"/>
-    <p:sldId xmlns:r="http://schemas.openxmlformats.org/officeDocument/2006/relationships" id="263" r:id="R95bc52fe1fbd4534"/>
+    <p:sldId xmlns:r="http://schemas.openxmlformats.org/officeDocument/2006/relationships" id="256" r:id="R665db51e59ac4855"/>
+    <p:sldId xmlns:r="http://schemas.openxmlformats.org/officeDocument/2006/relationships" id="257" r:id="R84c7c67646674516"/>
+    <p:sldId xmlns:r="http://schemas.openxmlformats.org/officeDocument/2006/relationships" id="258" r:id="Rf2c73418e2f942c8"/>
+    <p:sldId xmlns:r="http://schemas.openxmlformats.org/officeDocument/2006/relationships" id="259" r:id="Rdcd6c5569f1041fb"/>
+    <p:sldId xmlns:r="http://schemas.openxmlformats.org/officeDocument/2006/relationships" id="260" r:id="Rd7aef42435df4b5e"/>
+    <p:sldId xmlns:r="http://schemas.openxmlformats.org/officeDocument/2006/relationships" id="261" r:id="Re88d38e202044b43"/>
+    <p:sldId xmlns:r="http://schemas.openxmlformats.org/officeDocument/2006/relationships" id="262" r:id="Rc769764f4abb4232"/>
+    <p:sldId xmlns:r="http://schemas.openxmlformats.org/officeDocument/2006/relationships" id="263" r:id="R4e7a192a2345440f"/>
   </p:sldIdLst>
   <p:sldSz cx="12192000" cy="6858000"/>
   <p:notesSz cx="6858000" cy="9144000"/>
@@ -1024,7 +1024,7 @@
   </p:cSld>
   <p:clrMap bg1="lt1" tx1="dk1" bg2="lt2" tx2="dk2" accent1="accent1" accent2="accent2" accent3="accent3" accent4="accent4" accent5="accent5" accent6="accent6" hlink="hlink" folHlink="folHlink"/>
   <p:sldLayoutIdLst>
-    <p:sldLayoutId xmlns:r="http://schemas.openxmlformats.org/officeDocument/2006/relationships" id="2147483649" r:id="Rb53f7b2c3f9b4889"/>
+    <p:sldLayoutId xmlns:r="http://schemas.openxmlformats.org/officeDocument/2006/relationships" id="2147483649" r:id="Re12245bd19104ff5"/>
   </p:sldLayoutIdLst>
   <p:txStyles>
     <p:titleStyle>
@@ -1522,7 +1522,7 @@
           <p:cNvPr id="1" name="">
             <a:extLst xmlns:a="http://schemas.openxmlformats.org/drawingml/2006/main">
               <a:ext uri="{FF2B5EF4-FFF2-40B4-BE49-F238E27FC236}">
-                <a16:creationId xmlns:a16="http://schemas.microsoft.com/office/drawing/2014/main" id="{533A0C27-CEF4-4F6B-904F-A8E2A2A889ED}"/>
+                <a16:creationId xmlns:a16="http://schemas.microsoft.com/office/drawing/2014/main" id="{184BAF7D-91D0-4232-82B7-F7FB018174E5}"/>
               </a:ext>
             </a:extLst>
           </p:cNvPr>
@@ -1557,7 +1557,7 @@
           <p:cNvPr id="2" name="">
             <a:extLst xmlns:a="http://schemas.openxmlformats.org/drawingml/2006/main">
               <a:ext uri="{FF2B5EF4-FFF2-40B4-BE49-F238E27FC236}">
-                <a16:creationId xmlns:a16="http://schemas.microsoft.com/office/drawing/2014/main" id="{7DD07C8E-346D-482D-82B2-3F386FEC6050}"/>
+                <a16:creationId xmlns:a16="http://schemas.microsoft.com/office/drawing/2014/main" id="{C4E9DAE8-5852-417F-B2BD-D9B0EA61F070}"/>
               </a:ext>
             </a:extLst>
           </p:cNvPr>
@@ -1621,7 +1621,7 @@
           <p:cNvPr id="3" name="">
             <a:extLst xmlns:a="http://schemas.openxmlformats.org/drawingml/2006/main">
               <a:ext uri="{FF2B5EF4-FFF2-40B4-BE49-F238E27FC236}">
-                <a16:creationId xmlns:a16="http://schemas.microsoft.com/office/drawing/2014/main" id="{B31A47B1-D7D7-40E8-B1E6-E718378A5BD9}"/>
+                <a16:creationId xmlns:a16="http://schemas.microsoft.com/office/drawing/2014/main" id="{1B50F514-1854-4A73-B463-32C1BB2E98E5}"/>
               </a:ext>
             </a:extLst>
           </p:cNvPr>
@@ -1685,7 +1685,7 @@
           <p:cNvPr id="4" name="">
             <a:extLst xmlns:a="http://schemas.openxmlformats.org/drawingml/2006/main">
               <a:ext uri="{FF2B5EF4-FFF2-40B4-BE49-F238E27FC236}">
-                <a16:creationId xmlns:a16="http://schemas.microsoft.com/office/drawing/2014/main" id="{5EE90F65-F158-450C-9C99-C3830FF87F50}"/>
+                <a16:creationId xmlns:a16="http://schemas.microsoft.com/office/drawing/2014/main" id="{B8D35F8D-4612-4360-82A0-4192230CA6FC}"/>
               </a:ext>
             </a:extLst>
           </p:cNvPr>
@@ -1749,7 +1749,7 @@
           <p:cNvPr id="5" name="">
             <a:extLst xmlns:a="http://schemas.openxmlformats.org/drawingml/2006/main">
               <a:ext uri="{FF2B5EF4-FFF2-40B4-BE49-F238E27FC236}">
-                <a16:creationId xmlns:a16="http://schemas.microsoft.com/office/drawing/2014/main" id="{EA5B547C-2BF1-4985-8EC3-C8385F9DDC25}"/>
+                <a16:creationId xmlns:a16="http://schemas.microsoft.com/office/drawing/2014/main" id="{0FEB3A5E-C744-4719-B0CF-BAD42B9D9E12}"/>
               </a:ext>
             </a:extLst>
           </p:cNvPr>
@@ -1782,7 +1782,7 @@
           <p:cNvPr id="6" name="">
             <a:extLst xmlns:a="http://schemas.openxmlformats.org/drawingml/2006/main">
               <a:ext uri="{FF2B5EF4-FFF2-40B4-BE49-F238E27FC236}">
-                <a16:creationId xmlns:a16="http://schemas.microsoft.com/office/drawing/2014/main" id="{7C4B2E26-01F1-42AE-8AB1-59DB66871473}"/>
+                <a16:creationId xmlns:a16="http://schemas.microsoft.com/office/drawing/2014/main" id="{38FD44D1-20BB-48ED-BD14-EE0874706C5F}"/>
               </a:ext>
             </a:extLst>
           </p:cNvPr>
@@ -1846,7 +1846,7 @@
           <p:cNvPr id="7" name="">
             <a:extLst xmlns:a="http://schemas.openxmlformats.org/drawingml/2006/main">
               <a:ext uri="{FF2B5EF4-FFF2-40B4-BE49-F238E27FC236}">
-                <a16:creationId xmlns:a16="http://schemas.microsoft.com/office/drawing/2014/main" id="{4F38272B-A9F1-45C3-8563-E6A14CAC66DB}"/>
+                <a16:creationId xmlns:a16="http://schemas.microsoft.com/office/drawing/2014/main" id="{A3B18947-CFFC-4276-9031-753CE6E72283}"/>
               </a:ext>
             </a:extLst>
           </p:cNvPr>
@@ -1914,7 +1914,7 @@
           <p:nvPr/>
         </p:nvPicPr>
         <p:blipFill>
-          <a:blip xmlns:r="http://schemas.openxmlformats.org/officeDocument/2006/relationships" xmlns:a="http://schemas.openxmlformats.org/drawingml/2006/main" r:embed="R96560140b03e4713"/>
+          <a:blip xmlns:r="http://schemas.openxmlformats.org/officeDocument/2006/relationships" xmlns:a="http://schemas.openxmlformats.org/drawingml/2006/main" r:embed="Rfdda58f0dd404aed"/>
           <a:stretch xmlns:a="http://schemas.openxmlformats.org/drawingml/2006/main"/>
         </p:blipFill>
         <p:spPr>
@@ -1932,7 +1932,7 @@
           <p:cNvPr id="9" name="">
             <a:extLst xmlns:a="http://schemas.openxmlformats.org/drawingml/2006/main">
               <a:ext uri="{FF2B5EF4-FFF2-40B4-BE49-F238E27FC236}">
-                <a16:creationId xmlns:a16="http://schemas.microsoft.com/office/drawing/2014/main" id="{8FFDE335-88FB-4373-B9AA-C84615D5DC82}"/>
+                <a16:creationId xmlns:a16="http://schemas.microsoft.com/office/drawing/2014/main" id="{8E7A784D-F358-4C7B-9474-68E0E6F56C6A}"/>
               </a:ext>
             </a:extLst>
           </p:cNvPr>
@@ -1996,7 +1996,7 @@
           <p:cNvPr id="10" name="">
             <a:extLst xmlns:a="http://schemas.openxmlformats.org/drawingml/2006/main">
               <a:ext uri="{FF2B5EF4-FFF2-40B4-BE49-F238E27FC236}">
-                <a16:creationId xmlns:a16="http://schemas.microsoft.com/office/drawing/2014/main" id="{BEB9E026-1504-44B6-8622-8DE2BC7C1A3E}"/>
+                <a16:creationId xmlns:a16="http://schemas.microsoft.com/office/drawing/2014/main" id="{7EEBE180-9984-421C-B0DB-F1CC772AB2F7}"/>
               </a:ext>
             </a:extLst>
           </p:cNvPr>
@@ -2058,7 +2058,7 @@
     </p:spTree>
     <p:extLst>
       <p:ext uri="{BB962C8B-B14F-4D97-AF65-F5344CB8AC3E}">
-        <p14:creationId xmlns:p14="http://schemas.microsoft.com/office/powerpoint/2010/main" val="141319613"/>
+        <p14:creationId xmlns:p14="http://schemas.microsoft.com/office/powerpoint/2010/main" val="182195546"/>
       </p:ext>
     </p:extLst>
   </p:cSld>
@@ -2082,7 +2082,7 @@
           <p:cNvPr id="1" name="">
             <a:extLst xmlns:a="http://schemas.openxmlformats.org/drawingml/2006/main">
               <a:ext uri="{FF2B5EF4-FFF2-40B4-BE49-F238E27FC236}">
-                <a16:creationId xmlns:a16="http://schemas.microsoft.com/office/drawing/2014/main" id="{2E513AA6-7A90-4A46-8984-5AADE3EC03D8}"/>
+                <a16:creationId xmlns:a16="http://schemas.microsoft.com/office/drawing/2014/main" id="{9800AED7-2167-4997-B600-54504F83C991}"/>
               </a:ext>
             </a:extLst>
           </p:cNvPr>
@@ -2117,7 +2117,7 @@
           <p:cNvPr id="2" name="">
             <a:extLst xmlns:a="http://schemas.openxmlformats.org/drawingml/2006/main">
               <a:ext uri="{FF2B5EF4-FFF2-40B4-BE49-F238E27FC236}">
-                <a16:creationId xmlns:a16="http://schemas.microsoft.com/office/drawing/2014/main" id="{854DB3A0-9B68-4F31-8D77-DDEA2E04369F}"/>
+                <a16:creationId xmlns:a16="http://schemas.microsoft.com/office/drawing/2014/main" id="{EDA6A045-6A7B-41D5-9C57-B4429C757C00}"/>
               </a:ext>
             </a:extLst>
           </p:cNvPr>
@@ -2181,7 +2181,7 @@
           <p:cNvPr id="3" name="">
             <a:extLst xmlns:a="http://schemas.openxmlformats.org/drawingml/2006/main">
               <a:ext uri="{FF2B5EF4-FFF2-40B4-BE49-F238E27FC236}">
-                <a16:creationId xmlns:a16="http://schemas.microsoft.com/office/drawing/2014/main" id="{7F57DC06-C445-493E-9085-9E1F7E517AB5}"/>
+                <a16:creationId xmlns:a16="http://schemas.microsoft.com/office/drawing/2014/main" id="{0F850CDD-3F94-43DB-9F38-F199A5F62DE1}"/>
               </a:ext>
             </a:extLst>
           </p:cNvPr>
@@ -2245,7 +2245,7 @@
           <p:cNvPr id="4" name="">
             <a:extLst xmlns:a="http://schemas.openxmlformats.org/drawingml/2006/main">
               <a:ext uri="{FF2B5EF4-FFF2-40B4-BE49-F238E27FC236}">
-                <a16:creationId xmlns:a16="http://schemas.microsoft.com/office/drawing/2014/main" id="{0A667408-4435-4D8C-929C-5303B1E97E0B}"/>
+                <a16:creationId xmlns:a16="http://schemas.microsoft.com/office/drawing/2014/main" id="{328BF2D5-D938-48C5-8A53-2B046D484E20}"/>
               </a:ext>
             </a:extLst>
           </p:cNvPr>
@@ -2309,7 +2309,7 @@
           <p:cNvPr id="5" name="">
             <a:extLst xmlns:a="http://schemas.openxmlformats.org/drawingml/2006/main">
               <a:ext uri="{FF2B5EF4-FFF2-40B4-BE49-F238E27FC236}">
-                <a16:creationId xmlns:a16="http://schemas.microsoft.com/office/drawing/2014/main" id="{3A047A8C-FA13-4284-A991-EF3E6D772F09}"/>
+                <a16:creationId xmlns:a16="http://schemas.microsoft.com/office/drawing/2014/main" id="{EDD948C6-C709-4592-96CB-0B4461EB98ED}"/>
               </a:ext>
             </a:extLst>
           </p:cNvPr>
@@ -2342,7 +2342,7 @@
           <p:cNvPr id="6" name="">
             <a:extLst xmlns:a="http://schemas.openxmlformats.org/drawingml/2006/main">
               <a:ext uri="{FF2B5EF4-FFF2-40B4-BE49-F238E27FC236}">
-                <a16:creationId xmlns:a16="http://schemas.microsoft.com/office/drawing/2014/main" id="{4BE3B562-E852-47CF-999C-36F95702CF8A}"/>
+                <a16:creationId xmlns:a16="http://schemas.microsoft.com/office/drawing/2014/main" id="{530DE381-A933-4FAC-AAC1-B73E1CCD06CF}"/>
               </a:ext>
             </a:extLst>
           </p:cNvPr>
@@ -2406,7 +2406,7 @@
           <p:cNvPr id="7" name="">
             <a:extLst xmlns:a="http://schemas.openxmlformats.org/drawingml/2006/main">
               <a:ext uri="{FF2B5EF4-FFF2-40B4-BE49-F238E27FC236}">
-                <a16:creationId xmlns:a16="http://schemas.microsoft.com/office/drawing/2014/main" id="{C0539E6D-B9F0-4774-BA98-7C4159882742}"/>
+                <a16:creationId xmlns:a16="http://schemas.microsoft.com/office/drawing/2014/main" id="{AC776D87-F380-484D-9FD9-8CF2FE7F67E6}"/>
               </a:ext>
             </a:extLst>
           </p:cNvPr>
@@ -2470,7 +2470,7 @@
           <p:cNvPr id="8" name="">
             <a:extLst xmlns:a="http://schemas.openxmlformats.org/drawingml/2006/main">
               <a:ext uri="{FF2B5EF4-FFF2-40B4-BE49-F238E27FC236}">
-                <a16:creationId xmlns:a16="http://schemas.microsoft.com/office/drawing/2014/main" id="{6C469632-AF04-4AC0-97A0-7F38E7707AD6}"/>
+                <a16:creationId xmlns:a16="http://schemas.microsoft.com/office/drawing/2014/main" id="{F3193052-1CCB-46B6-8B7E-336DF1A963EE}"/>
               </a:ext>
             </a:extLst>
           </p:cNvPr>
@@ -2503,7 +2503,7 @@
           <p:cNvPr id="9" name="">
             <a:extLst xmlns:a="http://schemas.openxmlformats.org/drawingml/2006/main">
               <a:ext uri="{FF2B5EF4-FFF2-40B4-BE49-F238E27FC236}">
-                <a16:creationId xmlns:a16="http://schemas.microsoft.com/office/drawing/2014/main" id="{6D6D2E5F-1F62-4CBC-A71B-CADCE24879B8}"/>
+                <a16:creationId xmlns:a16="http://schemas.microsoft.com/office/drawing/2014/main" id="{8E97F418-695A-4544-8F33-927168D8CE68}"/>
               </a:ext>
             </a:extLst>
           </p:cNvPr>
@@ -2567,7 +2567,7 @@
           <p:cNvPr id="10" name="">
             <a:extLst xmlns:a="http://schemas.openxmlformats.org/drawingml/2006/main">
               <a:ext uri="{FF2B5EF4-FFF2-40B4-BE49-F238E27FC236}">
-                <a16:creationId xmlns:a16="http://schemas.microsoft.com/office/drawing/2014/main" id="{791292BC-8944-47E4-B156-ED5C3F983803}"/>
+                <a16:creationId xmlns:a16="http://schemas.microsoft.com/office/drawing/2014/main" id="{4BB9BD8C-26B4-4E69-9ECE-4A34825A1E47}"/>
               </a:ext>
             </a:extLst>
           </p:cNvPr>
@@ -2631,7 +2631,7 @@
           <p:cNvPr id="11" name="">
             <a:extLst xmlns:a="http://schemas.openxmlformats.org/drawingml/2006/main">
               <a:ext uri="{FF2B5EF4-FFF2-40B4-BE49-F238E27FC236}">
-                <a16:creationId xmlns:a16="http://schemas.microsoft.com/office/drawing/2014/main" id="{77700410-E47E-408C-AE34-349DD510DC25}"/>
+                <a16:creationId xmlns:a16="http://schemas.microsoft.com/office/drawing/2014/main" id="{C80C6B8B-8143-4CB9-B617-3539941FE17F}"/>
               </a:ext>
             </a:extLst>
           </p:cNvPr>
@@ -2664,7 +2664,7 @@
           <p:cNvPr id="12" name="">
             <a:extLst xmlns:a="http://schemas.openxmlformats.org/drawingml/2006/main">
               <a:ext uri="{FF2B5EF4-FFF2-40B4-BE49-F238E27FC236}">
-                <a16:creationId xmlns:a16="http://schemas.microsoft.com/office/drawing/2014/main" id="{F2606777-A9ED-4C2A-AC2B-94AEE052D01F}"/>
+                <a16:creationId xmlns:a16="http://schemas.microsoft.com/office/drawing/2014/main" id="{E3E03D8C-B562-4787-87B6-1F4FDFF96E02}"/>
               </a:ext>
             </a:extLst>
           </p:cNvPr>
@@ -2728,7 +2728,7 @@
           <p:cNvPr id="13" name="">
             <a:extLst xmlns:a="http://schemas.openxmlformats.org/drawingml/2006/main">
               <a:ext uri="{FF2B5EF4-FFF2-40B4-BE49-F238E27FC236}">
-                <a16:creationId xmlns:a16="http://schemas.microsoft.com/office/drawing/2014/main" id="{E8E4ACC6-2BFD-4A1E-8DF3-F184FDA349B0}"/>
+                <a16:creationId xmlns:a16="http://schemas.microsoft.com/office/drawing/2014/main" id="{FC78D3A8-645B-4E03-AC35-8865CBD2EB95}"/>
               </a:ext>
             </a:extLst>
           </p:cNvPr>
@@ -2792,7 +2792,7 @@
           <p:cNvPr id="14" name="">
             <a:extLst xmlns:a="http://schemas.openxmlformats.org/drawingml/2006/main">
               <a:ext uri="{FF2B5EF4-FFF2-40B4-BE49-F238E27FC236}">
-                <a16:creationId xmlns:a16="http://schemas.microsoft.com/office/drawing/2014/main" id="{F48746D5-6D82-4EDC-AC52-22632613763F}"/>
+                <a16:creationId xmlns:a16="http://schemas.microsoft.com/office/drawing/2014/main" id="{041A78C3-A9C7-455B-9312-A314949972A7}"/>
               </a:ext>
             </a:extLst>
           </p:cNvPr>
@@ -2825,7 +2825,7 @@
           <p:cNvPr id="15" name="">
             <a:extLst xmlns:a="http://schemas.openxmlformats.org/drawingml/2006/main">
               <a:ext uri="{FF2B5EF4-FFF2-40B4-BE49-F238E27FC236}">
-                <a16:creationId xmlns:a16="http://schemas.microsoft.com/office/drawing/2014/main" id="{E7A9A6FF-51D5-4E33-BE8B-A9AF64D9ECD4}"/>
+                <a16:creationId xmlns:a16="http://schemas.microsoft.com/office/drawing/2014/main" id="{977A1AB6-50FE-4E3F-A475-44155C78276C}"/>
               </a:ext>
             </a:extLst>
           </p:cNvPr>
@@ -2889,7 +2889,7 @@
           <p:cNvPr id="16" name="">
             <a:extLst xmlns:a="http://schemas.openxmlformats.org/drawingml/2006/main">
               <a:ext uri="{FF2B5EF4-FFF2-40B4-BE49-F238E27FC236}">
-                <a16:creationId xmlns:a16="http://schemas.microsoft.com/office/drawing/2014/main" id="{EEDA50B8-9C38-4A11-B393-F06E99CE07EA}"/>
+                <a16:creationId xmlns:a16="http://schemas.microsoft.com/office/drawing/2014/main" id="{5D4CCD4B-6C62-4785-B1DC-BA8713237BB9}"/>
               </a:ext>
             </a:extLst>
           </p:cNvPr>
@@ -2953,7 +2953,7 @@
           <p:cNvPr id="17" name="">
             <a:extLst xmlns:a="http://schemas.openxmlformats.org/drawingml/2006/main">
               <a:ext uri="{FF2B5EF4-FFF2-40B4-BE49-F238E27FC236}">
-                <a16:creationId xmlns:a16="http://schemas.microsoft.com/office/drawing/2014/main" id="{7DBCD1D5-5129-4F14-A568-A2C6569EB8B7}"/>
+                <a16:creationId xmlns:a16="http://schemas.microsoft.com/office/drawing/2014/main" id="{A5DB5950-1D50-4E08-B8D0-769E0D1630D9}"/>
               </a:ext>
             </a:extLst>
           </p:cNvPr>
@@ -2986,7 +2986,7 @@
           <p:cNvPr id="18" name="">
             <a:extLst xmlns:a="http://schemas.openxmlformats.org/drawingml/2006/main">
               <a:ext uri="{FF2B5EF4-FFF2-40B4-BE49-F238E27FC236}">
-                <a16:creationId xmlns:a16="http://schemas.microsoft.com/office/drawing/2014/main" id="{66014A80-90F5-4EA5-92FD-315843F5687F}"/>
+                <a16:creationId xmlns:a16="http://schemas.microsoft.com/office/drawing/2014/main" id="{063F4D99-5F75-4AEA-AF99-C58BD5358BFC}"/>
               </a:ext>
             </a:extLst>
           </p:cNvPr>
@@ -3050,7 +3050,7 @@
           <p:cNvPr id="19" name="">
             <a:extLst xmlns:a="http://schemas.openxmlformats.org/drawingml/2006/main">
               <a:ext uri="{FF2B5EF4-FFF2-40B4-BE49-F238E27FC236}">
-                <a16:creationId xmlns:a16="http://schemas.microsoft.com/office/drawing/2014/main" id="{1CD050E9-7CA4-43CB-BC81-18D51D2BBE6F}"/>
+                <a16:creationId xmlns:a16="http://schemas.microsoft.com/office/drawing/2014/main" id="{8F00EC24-58FD-47A6-A35C-F93045A227FE}"/>
               </a:ext>
             </a:extLst>
           </p:cNvPr>
@@ -3114,7 +3114,7 @@
           <p:cNvPr id="20" name="">
             <a:extLst xmlns:a="http://schemas.openxmlformats.org/drawingml/2006/main">
               <a:ext uri="{FF2B5EF4-FFF2-40B4-BE49-F238E27FC236}">
-                <a16:creationId xmlns:a16="http://schemas.microsoft.com/office/drawing/2014/main" id="{A18780F5-F65C-4F9E-8523-7A4EAF83D909}"/>
+                <a16:creationId xmlns:a16="http://schemas.microsoft.com/office/drawing/2014/main" id="{549DB75D-EFDD-4C9B-AEB6-3BC985F0361B}"/>
               </a:ext>
             </a:extLst>
           </p:cNvPr>
@@ -3147,7 +3147,7 @@
           <p:cNvPr id="21" name="">
             <a:extLst xmlns:a="http://schemas.openxmlformats.org/drawingml/2006/main">
               <a:ext uri="{FF2B5EF4-FFF2-40B4-BE49-F238E27FC236}">
-                <a16:creationId xmlns:a16="http://schemas.microsoft.com/office/drawing/2014/main" id="{BFD965B8-CB91-44B1-9939-56C6BE0264AD}"/>
+                <a16:creationId xmlns:a16="http://schemas.microsoft.com/office/drawing/2014/main" id="{E0BACDA8-172D-405D-A3CB-B05E170C7323}"/>
               </a:ext>
             </a:extLst>
           </p:cNvPr>
@@ -3211,7 +3211,7 @@
           <p:cNvPr id="22" name="">
             <a:extLst xmlns:a="http://schemas.openxmlformats.org/drawingml/2006/main">
               <a:ext uri="{FF2B5EF4-FFF2-40B4-BE49-F238E27FC236}">
-                <a16:creationId xmlns:a16="http://schemas.microsoft.com/office/drawing/2014/main" id="{236EE9EB-1FCB-4BFF-8CBB-4979F5DCCD6F}"/>
+                <a16:creationId xmlns:a16="http://schemas.microsoft.com/office/drawing/2014/main" id="{278F7DC3-FDB4-47C2-B576-1DAC75B0A7E0}"/>
               </a:ext>
             </a:extLst>
           </p:cNvPr>
@@ -3275,7 +3275,7 @@
           <p:cNvPr id="23" name="">
             <a:extLst xmlns:a="http://schemas.openxmlformats.org/drawingml/2006/main">
               <a:ext uri="{FF2B5EF4-FFF2-40B4-BE49-F238E27FC236}">
-                <a16:creationId xmlns:a16="http://schemas.microsoft.com/office/drawing/2014/main" id="{12764CAE-12BE-4A6C-AFA8-2A41D707B4E4}"/>
+                <a16:creationId xmlns:a16="http://schemas.microsoft.com/office/drawing/2014/main" id="{D014A604-4973-43F4-8059-5A599AF5E538}"/>
               </a:ext>
             </a:extLst>
           </p:cNvPr>
@@ -3339,7 +3339,7 @@
           <p:cNvPr id="24" name="">
             <a:extLst xmlns:a="http://schemas.openxmlformats.org/drawingml/2006/main">
               <a:ext uri="{FF2B5EF4-FFF2-40B4-BE49-F238E27FC236}">
-                <a16:creationId xmlns:a16="http://schemas.microsoft.com/office/drawing/2014/main" id="{339C9A3F-B645-42C6-A581-9286E702E842}"/>
+                <a16:creationId xmlns:a16="http://schemas.microsoft.com/office/drawing/2014/main" id="{F3BD344D-708F-42ED-973A-8206B6627ADF}"/>
               </a:ext>
             </a:extLst>
           </p:cNvPr>
@@ -3401,7 +3401,7 @@
     </p:spTree>
     <p:extLst>
       <p:ext uri="{BB962C8B-B14F-4D97-AF65-F5344CB8AC3E}">
-        <p14:creationId xmlns:p14="http://schemas.microsoft.com/office/powerpoint/2010/main" val="432107775"/>
+        <p14:creationId xmlns:p14="http://schemas.microsoft.com/office/powerpoint/2010/main" val="1172952680"/>
       </p:ext>
     </p:extLst>
   </p:cSld>
@@ -3425,7 +3425,7 @@
           <p:cNvPr id="1" name="">
             <a:extLst xmlns:a="http://schemas.openxmlformats.org/drawingml/2006/main">
               <a:ext uri="{FF2B5EF4-FFF2-40B4-BE49-F238E27FC236}">
-                <a16:creationId xmlns:a16="http://schemas.microsoft.com/office/drawing/2014/main" id="{8772149F-A31A-487A-A209-B10D1D20AE0B}"/>
+                <a16:creationId xmlns:a16="http://schemas.microsoft.com/office/drawing/2014/main" id="{89D73A95-87FD-4BF9-96A1-8DDC2A0BCD23}"/>
               </a:ext>
             </a:extLst>
           </p:cNvPr>
@@ -3460,7 +3460,7 @@
           <p:cNvPr id="2" name="">
             <a:extLst xmlns:a="http://schemas.openxmlformats.org/drawingml/2006/main">
               <a:ext uri="{FF2B5EF4-FFF2-40B4-BE49-F238E27FC236}">
-                <a16:creationId xmlns:a16="http://schemas.microsoft.com/office/drawing/2014/main" id="{9FBC0B07-D8B9-40D1-B7CE-47FC352573B6}"/>
+                <a16:creationId xmlns:a16="http://schemas.microsoft.com/office/drawing/2014/main" id="{CF42C229-5A19-4A04-A533-B6B78DCD790F}"/>
               </a:ext>
             </a:extLst>
           </p:cNvPr>
@@ -3524,7 +3524,7 @@
           <p:cNvPr id="3" name="">
             <a:extLst xmlns:a="http://schemas.openxmlformats.org/drawingml/2006/main">
               <a:ext uri="{FF2B5EF4-FFF2-40B4-BE49-F238E27FC236}">
-                <a16:creationId xmlns:a16="http://schemas.microsoft.com/office/drawing/2014/main" id="{0BCBC3BD-AF1A-462F-99A4-CBB93C630402}"/>
+                <a16:creationId xmlns:a16="http://schemas.microsoft.com/office/drawing/2014/main" id="{F2AA1E0F-CD78-480D-9954-B3B8B2A6C63B}"/>
               </a:ext>
             </a:extLst>
           </p:cNvPr>
@@ -3588,7 +3588,7 @@
           <p:cNvPr id="4" name="">
             <a:extLst xmlns:a="http://schemas.openxmlformats.org/drawingml/2006/main">
               <a:ext uri="{FF2B5EF4-FFF2-40B4-BE49-F238E27FC236}">
-                <a16:creationId xmlns:a16="http://schemas.microsoft.com/office/drawing/2014/main" id="{B427EA4B-D934-4DE7-9967-F9211F228333}"/>
+                <a16:creationId xmlns:a16="http://schemas.microsoft.com/office/drawing/2014/main" id="{7398D4EE-A9B7-416B-829A-34683AADAC84}"/>
               </a:ext>
             </a:extLst>
           </p:cNvPr>
@@ -3652,7 +3652,7 @@
           <p:cNvPr id="5" name="">
             <a:extLst xmlns:a="http://schemas.openxmlformats.org/drawingml/2006/main">
               <a:ext uri="{FF2B5EF4-FFF2-40B4-BE49-F238E27FC236}">
-                <a16:creationId xmlns:a16="http://schemas.microsoft.com/office/drawing/2014/main" id="{F5C07117-9247-44B2-8277-8AE3DA371A38}"/>
+                <a16:creationId xmlns:a16="http://schemas.microsoft.com/office/drawing/2014/main" id="{6A0A5D1E-0D3A-4830-B5AF-5932B42918C4}"/>
               </a:ext>
             </a:extLst>
           </p:cNvPr>
@@ -3685,7 +3685,7 @@
           <p:cNvPr id="6" name="">
             <a:extLst xmlns:a="http://schemas.openxmlformats.org/drawingml/2006/main">
               <a:ext uri="{FF2B5EF4-FFF2-40B4-BE49-F238E27FC236}">
-                <a16:creationId xmlns:a16="http://schemas.microsoft.com/office/drawing/2014/main" id="{BB2E8B90-CDCA-43E4-AE82-AEFFB171341A}"/>
+                <a16:creationId xmlns:a16="http://schemas.microsoft.com/office/drawing/2014/main" id="{E0CBE06F-429B-4639-9DFD-55F3D0C9BAAE}"/>
               </a:ext>
             </a:extLst>
           </p:cNvPr>
@@ -3749,7 +3749,7 @@
           <p:cNvPr id="7" name="">
             <a:extLst xmlns:a="http://schemas.openxmlformats.org/drawingml/2006/main">
               <a:ext uri="{FF2B5EF4-FFF2-40B4-BE49-F238E27FC236}">
-                <a16:creationId xmlns:a16="http://schemas.microsoft.com/office/drawing/2014/main" id="{5DF94B45-4ABB-4D7D-B81C-A04968B5D5DD}"/>
+                <a16:creationId xmlns:a16="http://schemas.microsoft.com/office/drawing/2014/main" id="{BBD729E6-72FE-425A-804F-43E41089516E}"/>
               </a:ext>
             </a:extLst>
           </p:cNvPr>
@@ -3813,7 +3813,7 @@
           <p:cNvPr id="8" name="">
             <a:extLst xmlns:a="http://schemas.openxmlformats.org/drawingml/2006/main">
               <a:ext uri="{FF2B5EF4-FFF2-40B4-BE49-F238E27FC236}">
-                <a16:creationId xmlns:a16="http://schemas.microsoft.com/office/drawing/2014/main" id="{63D237B6-5DFE-4399-9068-0A8746A5080B}"/>
+                <a16:creationId xmlns:a16="http://schemas.microsoft.com/office/drawing/2014/main" id="{C67D4036-91ED-4D2E-A2C1-03D9681807BE}"/>
               </a:ext>
             </a:extLst>
           </p:cNvPr>
@@ -3846,7 +3846,7 @@
           <p:cNvPr id="9" name="">
             <a:extLst xmlns:a="http://schemas.openxmlformats.org/drawingml/2006/main">
               <a:ext uri="{FF2B5EF4-FFF2-40B4-BE49-F238E27FC236}">
-                <a16:creationId xmlns:a16="http://schemas.microsoft.com/office/drawing/2014/main" id="{3503A137-C441-448E-A8BA-61D6E71C93D3}"/>
+                <a16:creationId xmlns:a16="http://schemas.microsoft.com/office/drawing/2014/main" id="{57904A17-737F-4CA0-927B-1B238D9D1955}"/>
               </a:ext>
             </a:extLst>
           </p:cNvPr>
@@ -3910,7 +3910,7 @@
           <p:cNvPr id="10" name="">
             <a:extLst xmlns:a="http://schemas.openxmlformats.org/drawingml/2006/main">
               <a:ext uri="{FF2B5EF4-FFF2-40B4-BE49-F238E27FC236}">
-                <a16:creationId xmlns:a16="http://schemas.microsoft.com/office/drawing/2014/main" id="{B3D2C1DD-F7C3-4FF2-8C25-109F0BBEA165}"/>
+                <a16:creationId xmlns:a16="http://schemas.microsoft.com/office/drawing/2014/main" id="{655B2513-8039-4AEA-82AB-0EA235BC2B61}"/>
               </a:ext>
             </a:extLst>
           </p:cNvPr>
@@ -3974,7 +3974,7 @@
           <p:cNvPr id="11" name="">
             <a:extLst xmlns:a="http://schemas.openxmlformats.org/drawingml/2006/main">
               <a:ext uri="{FF2B5EF4-FFF2-40B4-BE49-F238E27FC236}">
-                <a16:creationId xmlns:a16="http://schemas.microsoft.com/office/drawing/2014/main" id="{0C9DBC9C-ADF0-4ECD-82F5-E398C1627909}"/>
+                <a16:creationId xmlns:a16="http://schemas.microsoft.com/office/drawing/2014/main" id="{589822DB-638F-426B-9B94-D30CF417C828}"/>
               </a:ext>
             </a:extLst>
           </p:cNvPr>
@@ -4007,7 +4007,7 @@
           <p:cNvPr id="12" name="">
             <a:extLst xmlns:a="http://schemas.openxmlformats.org/drawingml/2006/main">
               <a:ext uri="{FF2B5EF4-FFF2-40B4-BE49-F238E27FC236}">
-                <a16:creationId xmlns:a16="http://schemas.microsoft.com/office/drawing/2014/main" id="{8DCB62DF-0295-4A10-AE7C-945B4724256D}"/>
+                <a16:creationId xmlns:a16="http://schemas.microsoft.com/office/drawing/2014/main" id="{7152820E-703D-40E6-A236-C49BE40FAAC5}"/>
               </a:ext>
             </a:extLst>
           </p:cNvPr>
@@ -4071,7 +4071,7 @@
           <p:cNvPr id="13" name="">
             <a:extLst xmlns:a="http://schemas.openxmlformats.org/drawingml/2006/main">
               <a:ext uri="{FF2B5EF4-FFF2-40B4-BE49-F238E27FC236}">
-                <a16:creationId xmlns:a16="http://schemas.microsoft.com/office/drawing/2014/main" id="{11B54B50-0B21-4DA4-8CE3-B1B167C18937}"/>
+                <a16:creationId xmlns:a16="http://schemas.microsoft.com/office/drawing/2014/main" id="{77DB3A40-C3F2-4476-8F39-CEEC2A92012D}"/>
               </a:ext>
             </a:extLst>
           </p:cNvPr>
@@ -4135,7 +4135,7 @@
           <p:cNvPr id="14" name="">
             <a:extLst xmlns:a="http://schemas.openxmlformats.org/drawingml/2006/main">
               <a:ext uri="{FF2B5EF4-FFF2-40B4-BE49-F238E27FC236}">
-                <a16:creationId xmlns:a16="http://schemas.microsoft.com/office/drawing/2014/main" id="{3DA6D50C-5D0D-426B-822B-C5CC5E13A9ED}"/>
+                <a16:creationId xmlns:a16="http://schemas.microsoft.com/office/drawing/2014/main" id="{0720756A-EE38-4D70-98DC-46D63B1666A3}"/>
               </a:ext>
             </a:extLst>
           </p:cNvPr>
@@ -4168,7 +4168,7 @@
           <p:cNvPr id="15" name="">
             <a:extLst xmlns:a="http://schemas.openxmlformats.org/drawingml/2006/main">
               <a:ext uri="{FF2B5EF4-FFF2-40B4-BE49-F238E27FC236}">
-                <a16:creationId xmlns:a16="http://schemas.microsoft.com/office/drawing/2014/main" id="{A3295630-79B1-4FDF-A510-95304635C6E1}"/>
+                <a16:creationId xmlns:a16="http://schemas.microsoft.com/office/drawing/2014/main" id="{63CAEB47-0BF5-40B5-83B0-3105A3B2AA0C}"/>
               </a:ext>
             </a:extLst>
           </p:cNvPr>
@@ -4232,7 +4232,7 @@
           <p:cNvPr id="16" name="">
             <a:extLst xmlns:a="http://schemas.openxmlformats.org/drawingml/2006/main">
               <a:ext uri="{FF2B5EF4-FFF2-40B4-BE49-F238E27FC236}">
-                <a16:creationId xmlns:a16="http://schemas.microsoft.com/office/drawing/2014/main" id="{674DB31D-1F16-446E-B564-21F002B3B9C4}"/>
+                <a16:creationId xmlns:a16="http://schemas.microsoft.com/office/drawing/2014/main" id="{BC52FF8D-279F-4FE2-932A-E32AF6C92DF3}"/>
               </a:ext>
             </a:extLst>
           </p:cNvPr>
@@ -4296,7 +4296,7 @@
           <p:cNvPr id="17" name="">
             <a:extLst xmlns:a="http://schemas.openxmlformats.org/drawingml/2006/main">
               <a:ext uri="{FF2B5EF4-FFF2-40B4-BE49-F238E27FC236}">
-                <a16:creationId xmlns:a16="http://schemas.microsoft.com/office/drawing/2014/main" id="{0E455B2D-8607-4ACE-903E-D18C4966ED41}"/>
+                <a16:creationId xmlns:a16="http://schemas.microsoft.com/office/drawing/2014/main" id="{446874BC-A72A-43EB-930B-4E17F0A4386C}"/>
               </a:ext>
             </a:extLst>
           </p:cNvPr>
@@ -4329,7 +4329,7 @@
           <p:cNvPr id="18" name="">
             <a:extLst xmlns:a="http://schemas.openxmlformats.org/drawingml/2006/main">
               <a:ext uri="{FF2B5EF4-FFF2-40B4-BE49-F238E27FC236}">
-                <a16:creationId xmlns:a16="http://schemas.microsoft.com/office/drawing/2014/main" id="{FB773C4F-02BE-4614-A2B4-F1575AAEBAF4}"/>
+                <a16:creationId xmlns:a16="http://schemas.microsoft.com/office/drawing/2014/main" id="{1C19503F-CC13-4D8E-87F7-3A42896A6608}"/>
               </a:ext>
             </a:extLst>
           </p:cNvPr>
@@ -4393,7 +4393,7 @@
           <p:cNvPr id="19" name="">
             <a:extLst xmlns:a="http://schemas.openxmlformats.org/drawingml/2006/main">
               <a:ext uri="{FF2B5EF4-FFF2-40B4-BE49-F238E27FC236}">
-                <a16:creationId xmlns:a16="http://schemas.microsoft.com/office/drawing/2014/main" id="{2E186369-327E-4D4F-BFC7-E345A3B6BB87}"/>
+                <a16:creationId xmlns:a16="http://schemas.microsoft.com/office/drawing/2014/main" id="{65919AE4-76AF-4232-8988-82DADDF27DA1}"/>
               </a:ext>
             </a:extLst>
           </p:cNvPr>
@@ -4457,7 +4457,7 @@
           <p:cNvPr id="20" name="">
             <a:extLst xmlns:a="http://schemas.openxmlformats.org/drawingml/2006/main">
               <a:ext uri="{FF2B5EF4-FFF2-40B4-BE49-F238E27FC236}">
-                <a16:creationId xmlns:a16="http://schemas.microsoft.com/office/drawing/2014/main" id="{C7FA1677-B99F-4DCD-917B-3BD580713A54}"/>
+                <a16:creationId xmlns:a16="http://schemas.microsoft.com/office/drawing/2014/main" id="{652FD29B-69FD-4CF6-A760-D7F00B96131D}"/>
               </a:ext>
             </a:extLst>
           </p:cNvPr>
@@ -4490,7 +4490,7 @@
           <p:cNvPr id="21" name="">
             <a:extLst xmlns:a="http://schemas.openxmlformats.org/drawingml/2006/main">
               <a:ext uri="{FF2B5EF4-FFF2-40B4-BE49-F238E27FC236}">
-                <a16:creationId xmlns:a16="http://schemas.microsoft.com/office/drawing/2014/main" id="{69DD89B2-14DF-471A-9013-D6D9228A6D44}"/>
+                <a16:creationId xmlns:a16="http://schemas.microsoft.com/office/drawing/2014/main" id="{687F2708-323B-4ACA-832F-DC849EA037A0}"/>
               </a:ext>
             </a:extLst>
           </p:cNvPr>
@@ -4554,7 +4554,7 @@
           <p:cNvPr id="22" name="">
             <a:extLst xmlns:a="http://schemas.openxmlformats.org/drawingml/2006/main">
               <a:ext uri="{FF2B5EF4-FFF2-40B4-BE49-F238E27FC236}">
-                <a16:creationId xmlns:a16="http://schemas.microsoft.com/office/drawing/2014/main" id="{5F0F8A69-94FF-452D-9E53-18AD31F6B303}"/>
+                <a16:creationId xmlns:a16="http://schemas.microsoft.com/office/drawing/2014/main" id="{60BE2F8B-7A5E-4F46-A8CC-F93DB0645D4D}"/>
               </a:ext>
             </a:extLst>
           </p:cNvPr>
@@ -4618,7 +4618,7 @@
           <p:cNvPr id="23" name="">
             <a:extLst xmlns:a="http://schemas.openxmlformats.org/drawingml/2006/main">
               <a:ext uri="{FF2B5EF4-FFF2-40B4-BE49-F238E27FC236}">
-                <a16:creationId xmlns:a16="http://schemas.microsoft.com/office/drawing/2014/main" id="{81C2B746-3D1E-4227-B277-0FFBD7978E38}"/>
+                <a16:creationId xmlns:a16="http://schemas.microsoft.com/office/drawing/2014/main" id="{3463A572-CF37-4322-B4CA-61A3694363A0}"/>
               </a:ext>
             </a:extLst>
           </p:cNvPr>
@@ -4651,7 +4651,7 @@
           <p:cNvPr id="24" name="">
             <a:extLst xmlns:a="http://schemas.openxmlformats.org/drawingml/2006/main">
               <a:ext uri="{FF2B5EF4-FFF2-40B4-BE49-F238E27FC236}">
-                <a16:creationId xmlns:a16="http://schemas.microsoft.com/office/drawing/2014/main" id="{594DDA7A-8DCC-4788-8472-686333058A74}"/>
+                <a16:creationId xmlns:a16="http://schemas.microsoft.com/office/drawing/2014/main" id="{0148856A-04E0-4E6D-BA01-852D298EC0B3}"/>
               </a:ext>
             </a:extLst>
           </p:cNvPr>
@@ -4715,7 +4715,7 @@
           <p:cNvPr id="25" name="">
             <a:extLst xmlns:a="http://schemas.openxmlformats.org/drawingml/2006/main">
               <a:ext uri="{FF2B5EF4-FFF2-40B4-BE49-F238E27FC236}">
-                <a16:creationId xmlns:a16="http://schemas.microsoft.com/office/drawing/2014/main" id="{A793F00B-CB32-4120-96BE-B92569D53526}"/>
+                <a16:creationId xmlns:a16="http://schemas.microsoft.com/office/drawing/2014/main" id="{CBC1FD01-7C76-4E65-8842-1B08F830BEE1}"/>
               </a:ext>
             </a:extLst>
           </p:cNvPr>
@@ -4779,7 +4779,7 @@
           <p:cNvPr id="26" name="">
             <a:extLst xmlns:a="http://schemas.openxmlformats.org/drawingml/2006/main">
               <a:ext uri="{FF2B5EF4-FFF2-40B4-BE49-F238E27FC236}">
-                <a16:creationId xmlns:a16="http://schemas.microsoft.com/office/drawing/2014/main" id="{94CE477E-3D62-4EAA-A891-B591E7E333E0}"/>
+                <a16:creationId xmlns:a16="http://schemas.microsoft.com/office/drawing/2014/main" id="{256664F9-5A60-4EE2-951C-6B0C5749405E}"/>
               </a:ext>
             </a:extLst>
           </p:cNvPr>
@@ -4843,7 +4843,7 @@
           <p:cNvPr id="27" name="">
             <a:extLst xmlns:a="http://schemas.openxmlformats.org/drawingml/2006/main">
               <a:ext uri="{FF2B5EF4-FFF2-40B4-BE49-F238E27FC236}">
-                <a16:creationId xmlns:a16="http://schemas.microsoft.com/office/drawing/2014/main" id="{8968EF34-65CA-4AB2-A755-DCA4D75363D7}"/>
+                <a16:creationId xmlns:a16="http://schemas.microsoft.com/office/drawing/2014/main" id="{5B022A6E-CCFA-4AD0-8391-B2A27E66028E}"/>
               </a:ext>
             </a:extLst>
           </p:cNvPr>
@@ -4905,7 +4905,7 @@
     </p:spTree>
     <p:extLst>
       <p:ext uri="{BB962C8B-B14F-4D97-AF65-F5344CB8AC3E}">
-        <p14:creationId xmlns:p14="http://schemas.microsoft.com/office/powerpoint/2010/main" val="1497078416"/>
+        <p14:creationId xmlns:p14="http://schemas.microsoft.com/office/powerpoint/2010/main" val="189060232"/>
       </p:ext>
     </p:extLst>
   </p:cSld>
@@ -4929,7 +4929,7 @@
           <p:cNvPr id="1" name="">
             <a:extLst xmlns:a="http://schemas.openxmlformats.org/drawingml/2006/main">
               <a:ext uri="{FF2B5EF4-FFF2-40B4-BE49-F238E27FC236}">
-                <a16:creationId xmlns:a16="http://schemas.microsoft.com/office/drawing/2014/main" id="{6BB98267-0A11-4874-A248-AA1FC299640B}"/>
+                <a16:creationId xmlns:a16="http://schemas.microsoft.com/office/drawing/2014/main" id="{A1E1EFF8-CFB3-4124-8E47-4DF4BA16660D}"/>
               </a:ext>
             </a:extLst>
           </p:cNvPr>
@@ -4964,7 +4964,7 @@
           <p:cNvPr id="2" name="">
             <a:extLst xmlns:a="http://schemas.openxmlformats.org/drawingml/2006/main">
               <a:ext uri="{FF2B5EF4-FFF2-40B4-BE49-F238E27FC236}">
-                <a16:creationId xmlns:a16="http://schemas.microsoft.com/office/drawing/2014/main" id="{1C8525FF-DB39-43B5-9638-FEDD7EA92632}"/>
+                <a16:creationId xmlns:a16="http://schemas.microsoft.com/office/drawing/2014/main" id="{057EC3E8-9D32-4883-9ABE-8C4BD1FED704}"/>
               </a:ext>
             </a:extLst>
           </p:cNvPr>
@@ -5028,7 +5028,7 @@
           <p:cNvPr id="3" name="">
             <a:extLst xmlns:a="http://schemas.openxmlformats.org/drawingml/2006/main">
               <a:ext uri="{FF2B5EF4-FFF2-40B4-BE49-F238E27FC236}">
-                <a16:creationId xmlns:a16="http://schemas.microsoft.com/office/drawing/2014/main" id="{9CBE2AAE-6E1A-4076-A9FF-6D5FFFE86776}"/>
+                <a16:creationId xmlns:a16="http://schemas.microsoft.com/office/drawing/2014/main" id="{CB1E4B5A-0122-463F-8584-76C6B5B70430}"/>
               </a:ext>
             </a:extLst>
           </p:cNvPr>
@@ -5040,7 +5040,7 @@
         <p:spPr>
           <a:xfrm xmlns:a="http://schemas.openxmlformats.org/drawingml/2006/main">
             <a:off x="552450" y="781050"/>
-            <a:ext cx="7239000" cy="1381125"/>
+            <a:ext cx="5334000" cy="1381125"/>
           </a:xfrm>
           <a:prstGeom xmlns:a="http://schemas.openxmlformats.org/drawingml/2006/main" prst="rect">
             <a:avLst/>
@@ -5092,7 +5092,7 @@
           <p:cNvPr id="4" name="">
             <a:extLst xmlns:a="http://schemas.openxmlformats.org/drawingml/2006/main">
               <a:ext uri="{FF2B5EF4-FFF2-40B4-BE49-F238E27FC236}">
-                <a16:creationId xmlns:a16="http://schemas.microsoft.com/office/drawing/2014/main" id="{69639F0E-7FAE-4286-B1B1-77DAB8E70027}"/>
+                <a16:creationId xmlns:a16="http://schemas.microsoft.com/office/drawing/2014/main" id="{6C1F34B3-ACBB-4A2B-A7AC-19872EADEB04}"/>
               </a:ext>
             </a:extLst>
           </p:cNvPr>
@@ -5104,7 +5104,7 @@
         <p:spPr>
           <a:xfrm xmlns:a="http://schemas.openxmlformats.org/drawingml/2006/main">
             <a:off x="552450" y="2305050"/>
-            <a:ext cx="6477000" cy="876300"/>
+            <a:ext cx="5143500" cy="876300"/>
           </a:xfrm>
           <a:prstGeom xmlns:a="http://schemas.openxmlformats.org/drawingml/2006/main" prst="rect">
             <a:avLst/>
@@ -5156,7 +5156,7 @@
           <p:cNvPr id="5" name="">
             <a:extLst xmlns:a="http://schemas.openxmlformats.org/drawingml/2006/main">
               <a:ext uri="{FF2B5EF4-FFF2-40B4-BE49-F238E27FC236}">
-                <a16:creationId xmlns:a16="http://schemas.microsoft.com/office/drawing/2014/main" id="{2DDA6AD8-6F2D-42D3-9E7B-E54661CC1F6C}"/>
+                <a16:creationId xmlns:a16="http://schemas.microsoft.com/office/drawing/2014/main" id="{2D9E1D57-F8B7-426D-94DA-CA53715B3E29}"/>
               </a:ext>
             </a:extLst>
           </p:cNvPr>
@@ -5189,7 +5189,7 @@
           <p:cNvPr id="6" name="">
             <a:extLst xmlns:a="http://schemas.openxmlformats.org/drawingml/2006/main">
               <a:ext uri="{FF2B5EF4-FFF2-40B4-BE49-F238E27FC236}">
-                <a16:creationId xmlns:a16="http://schemas.microsoft.com/office/drawing/2014/main" id="{CB7C9841-9939-40C7-AA18-41B175CE8CD2}"/>
+                <a16:creationId xmlns:a16="http://schemas.microsoft.com/office/drawing/2014/main" id="{B1807B70-0A79-44CD-AEB0-7515F07F7EDA}"/>
               </a:ext>
             </a:extLst>
           </p:cNvPr>
@@ -5253,7 +5253,7 @@
           <p:cNvPr id="7" name="">
             <a:extLst xmlns:a="http://schemas.openxmlformats.org/drawingml/2006/main">
               <a:ext uri="{FF2B5EF4-FFF2-40B4-BE49-F238E27FC236}">
-                <a16:creationId xmlns:a16="http://schemas.microsoft.com/office/drawing/2014/main" id="{AA31969B-F131-4E72-A909-26A1DB152CDE}"/>
+                <a16:creationId xmlns:a16="http://schemas.microsoft.com/office/drawing/2014/main" id="{E7A76BE6-99BA-4E74-A762-F1D6478CF6EB}"/>
               </a:ext>
             </a:extLst>
           </p:cNvPr>
@@ -5321,13 +5321,13 @@
           <p:nvPr/>
         </p:nvPicPr>
         <p:blipFill>
-          <a:blip xmlns:r="http://schemas.openxmlformats.org/officeDocument/2006/relationships" xmlns:a="http://schemas.openxmlformats.org/drawingml/2006/main" r:embed="R176c554fee724b05"/>
+          <a:blip xmlns:r="http://schemas.openxmlformats.org/officeDocument/2006/relationships" xmlns:a="http://schemas.openxmlformats.org/drawingml/2006/main" r:embed="R0a457ef1e2894ef8"/>
           <a:stretch xmlns:a="http://schemas.openxmlformats.org/drawingml/2006/main"/>
         </p:blipFill>
         <p:spPr>
           <a:xfrm xmlns:a="http://schemas.openxmlformats.org/drawingml/2006/main">
-            <a:off x="7096125" y="1527188"/>
-            <a:ext cx="4524375" cy="2298674"/>
+            <a:off x="6305550" y="1642099"/>
+            <a:ext cx="5334000" cy="2659402"/>
           </a:xfrm>
           <a:prstGeom xmlns:a="http://schemas.openxmlformats.org/drawingml/2006/main" prst="rect">
             <a:avLst/>
@@ -5339,7 +5339,7 @@
           <p:cNvPr id="9" name="">
             <a:extLst xmlns:a="http://schemas.openxmlformats.org/drawingml/2006/main">
               <a:ext uri="{FF2B5EF4-FFF2-40B4-BE49-F238E27FC236}">
-                <a16:creationId xmlns:a16="http://schemas.microsoft.com/office/drawing/2014/main" id="{D326356C-9BC0-4FA9-9F67-3EF678D72076}"/>
+                <a16:creationId xmlns:a16="http://schemas.microsoft.com/office/drawing/2014/main" id="{9CD2791D-FF9F-488B-97D2-9A72468B4DF5}"/>
               </a:ext>
             </a:extLst>
           </p:cNvPr>
@@ -5403,7 +5403,7 @@
           <p:cNvPr id="10" name="">
             <a:extLst xmlns:a="http://schemas.openxmlformats.org/drawingml/2006/main">
               <a:ext uri="{FF2B5EF4-FFF2-40B4-BE49-F238E27FC236}">
-                <a16:creationId xmlns:a16="http://schemas.microsoft.com/office/drawing/2014/main" id="{23BF4B7A-149C-495C-A3BF-3850FFFFD2F9}"/>
+                <a16:creationId xmlns:a16="http://schemas.microsoft.com/office/drawing/2014/main" id="{707230E9-0755-4BFC-A352-246E0581D3DE}"/>
               </a:ext>
             </a:extLst>
           </p:cNvPr>
@@ -5465,7 +5465,7 @@
     </p:spTree>
     <p:extLst>
       <p:ext uri="{BB962C8B-B14F-4D97-AF65-F5344CB8AC3E}">
-        <p14:creationId xmlns:p14="http://schemas.microsoft.com/office/powerpoint/2010/main" val="1290298903"/>
+        <p14:creationId xmlns:p14="http://schemas.microsoft.com/office/powerpoint/2010/main" val="1306863365"/>
       </p:ext>
     </p:extLst>
   </p:cSld>
@@ -5489,7 +5489,7 @@
           <p:cNvPr id="1" name="">
             <a:extLst xmlns:a="http://schemas.openxmlformats.org/drawingml/2006/main">
               <a:ext uri="{FF2B5EF4-FFF2-40B4-BE49-F238E27FC236}">
-                <a16:creationId xmlns:a16="http://schemas.microsoft.com/office/drawing/2014/main" id="{739F577D-0A19-424E-BE3D-BFAE06C270D6}"/>
+                <a16:creationId xmlns:a16="http://schemas.microsoft.com/office/drawing/2014/main" id="{F8C1B7FA-BC74-4210-BAFB-7660646051D8}"/>
               </a:ext>
             </a:extLst>
           </p:cNvPr>
@@ -5524,7 +5524,7 @@
           <p:cNvPr id="2" name="">
             <a:extLst xmlns:a="http://schemas.openxmlformats.org/drawingml/2006/main">
               <a:ext uri="{FF2B5EF4-FFF2-40B4-BE49-F238E27FC236}">
-                <a16:creationId xmlns:a16="http://schemas.microsoft.com/office/drawing/2014/main" id="{8B68DBE5-004C-4869-9504-00BB313FE776}"/>
+                <a16:creationId xmlns:a16="http://schemas.microsoft.com/office/drawing/2014/main" id="{2A770323-4BA7-48AC-8620-1DE3E3C47357}"/>
               </a:ext>
             </a:extLst>
           </p:cNvPr>
@@ -5588,7 +5588,7 @@
           <p:cNvPr id="3" name="">
             <a:extLst xmlns:a="http://schemas.openxmlformats.org/drawingml/2006/main">
               <a:ext uri="{FF2B5EF4-FFF2-40B4-BE49-F238E27FC236}">
-                <a16:creationId xmlns:a16="http://schemas.microsoft.com/office/drawing/2014/main" id="{DAE1564F-C3B9-4AD2-8668-E55577837DB2}"/>
+                <a16:creationId xmlns:a16="http://schemas.microsoft.com/office/drawing/2014/main" id="{E4E3D771-AF7D-4089-9F3A-32DAE279177A}"/>
               </a:ext>
             </a:extLst>
           </p:cNvPr>
@@ -5600,7 +5600,7 @@
         <p:spPr>
           <a:xfrm xmlns:a="http://schemas.openxmlformats.org/drawingml/2006/main">
             <a:off x="552450" y="781050"/>
-            <a:ext cx="7239000" cy="1381125"/>
+            <a:ext cx="5334000" cy="1381125"/>
           </a:xfrm>
           <a:prstGeom xmlns:a="http://schemas.openxmlformats.org/drawingml/2006/main" prst="rect">
             <a:avLst/>
@@ -5652,7 +5652,7 @@
           <p:cNvPr id="4" name="">
             <a:extLst xmlns:a="http://schemas.openxmlformats.org/drawingml/2006/main">
               <a:ext uri="{FF2B5EF4-FFF2-40B4-BE49-F238E27FC236}">
-                <a16:creationId xmlns:a16="http://schemas.microsoft.com/office/drawing/2014/main" id="{620A3290-986E-4424-BF86-3D6159E60E5F}"/>
+                <a16:creationId xmlns:a16="http://schemas.microsoft.com/office/drawing/2014/main" id="{5C28989B-AB04-4250-AD41-FB55D2E46617}"/>
               </a:ext>
             </a:extLst>
           </p:cNvPr>
@@ -5664,7 +5664,7 @@
         <p:spPr>
           <a:xfrm xmlns:a="http://schemas.openxmlformats.org/drawingml/2006/main">
             <a:off x="552450" y="2305050"/>
-            <a:ext cx="6477000" cy="876300"/>
+            <a:ext cx="5143500" cy="876300"/>
           </a:xfrm>
           <a:prstGeom xmlns:a="http://schemas.openxmlformats.org/drawingml/2006/main" prst="rect">
             <a:avLst/>
@@ -5716,7 +5716,7 @@
           <p:cNvPr id="5" name="">
             <a:extLst xmlns:a="http://schemas.openxmlformats.org/drawingml/2006/main">
               <a:ext uri="{FF2B5EF4-FFF2-40B4-BE49-F238E27FC236}">
-                <a16:creationId xmlns:a16="http://schemas.microsoft.com/office/drawing/2014/main" id="{6472F0C7-D9A8-4557-ADBC-EFDB3A6AB663}"/>
+                <a16:creationId xmlns:a16="http://schemas.microsoft.com/office/drawing/2014/main" id="{D0865051-C9AA-48AF-AD66-2BDF0B5091B0}"/>
               </a:ext>
             </a:extLst>
           </p:cNvPr>
@@ -5749,7 +5749,7 @@
           <p:cNvPr id="6" name="">
             <a:extLst xmlns:a="http://schemas.openxmlformats.org/drawingml/2006/main">
               <a:ext uri="{FF2B5EF4-FFF2-40B4-BE49-F238E27FC236}">
-                <a16:creationId xmlns:a16="http://schemas.microsoft.com/office/drawing/2014/main" id="{3D7EC495-8B06-46FC-884E-A034494869A2}"/>
+                <a16:creationId xmlns:a16="http://schemas.microsoft.com/office/drawing/2014/main" id="{680F5986-BE2E-44D6-96F9-4B443DDB2889}"/>
               </a:ext>
             </a:extLst>
           </p:cNvPr>
@@ -5813,7 +5813,7 @@
           <p:cNvPr id="7" name="">
             <a:extLst xmlns:a="http://schemas.openxmlformats.org/drawingml/2006/main">
               <a:ext uri="{FF2B5EF4-FFF2-40B4-BE49-F238E27FC236}">
-                <a16:creationId xmlns:a16="http://schemas.microsoft.com/office/drawing/2014/main" id="{73566842-4CD3-4856-A0D3-1BD5A6EC8C74}"/>
+                <a16:creationId xmlns:a16="http://schemas.microsoft.com/office/drawing/2014/main" id="{FADEBFC6-D1B7-4C1A-9DCF-72A3E3081E36}"/>
               </a:ext>
             </a:extLst>
           </p:cNvPr>
@@ -5881,13 +5881,13 @@
           <p:nvPr/>
         </p:nvPicPr>
         <p:blipFill>
-          <a:blip xmlns:r="http://schemas.openxmlformats.org/officeDocument/2006/relationships" xmlns:a="http://schemas.openxmlformats.org/drawingml/2006/main" r:embed="R9d1f71ec7ffa4131"/>
+          <a:blip xmlns:r="http://schemas.openxmlformats.org/officeDocument/2006/relationships" xmlns:a="http://schemas.openxmlformats.org/drawingml/2006/main" r:embed="R021237c7e06c4fd5"/>
           <a:stretch xmlns:a="http://schemas.openxmlformats.org/drawingml/2006/main"/>
         </p:blipFill>
         <p:spPr>
           <a:xfrm xmlns:a="http://schemas.openxmlformats.org/drawingml/2006/main">
-            <a:off x="7096125" y="1654892"/>
-            <a:ext cx="4524375" cy="2043266"/>
+            <a:off x="6305550" y="1737078"/>
+            <a:ext cx="5334000" cy="2469444"/>
           </a:xfrm>
           <a:prstGeom xmlns:a="http://schemas.openxmlformats.org/drawingml/2006/main" prst="rect">
             <a:avLst/>
@@ -5899,7 +5899,7 @@
           <p:cNvPr id="9" name="">
             <a:extLst xmlns:a="http://schemas.openxmlformats.org/drawingml/2006/main">
               <a:ext uri="{FF2B5EF4-FFF2-40B4-BE49-F238E27FC236}">
-                <a16:creationId xmlns:a16="http://schemas.microsoft.com/office/drawing/2014/main" id="{33900E07-AAA8-4B63-AD2C-49F3B6AB699B}"/>
+                <a16:creationId xmlns:a16="http://schemas.microsoft.com/office/drawing/2014/main" id="{6210D9D9-6E02-4B76-8026-1584D2CE07B4}"/>
               </a:ext>
             </a:extLst>
           </p:cNvPr>
@@ -5963,7 +5963,7 @@
           <p:cNvPr id="10" name="">
             <a:extLst xmlns:a="http://schemas.openxmlformats.org/drawingml/2006/main">
               <a:ext uri="{FF2B5EF4-FFF2-40B4-BE49-F238E27FC236}">
-                <a16:creationId xmlns:a16="http://schemas.microsoft.com/office/drawing/2014/main" id="{EE5291AB-B4AD-40AF-86B8-D247B66C3F43}"/>
+                <a16:creationId xmlns:a16="http://schemas.microsoft.com/office/drawing/2014/main" id="{271D6F71-2831-46E2-84B0-861206CE0BD9}"/>
               </a:ext>
             </a:extLst>
           </p:cNvPr>
@@ -6025,7 +6025,7 @@
     </p:spTree>
     <p:extLst>
       <p:ext uri="{BB962C8B-B14F-4D97-AF65-F5344CB8AC3E}">
-        <p14:creationId xmlns:p14="http://schemas.microsoft.com/office/powerpoint/2010/main" val="1004385627"/>
+        <p14:creationId xmlns:p14="http://schemas.microsoft.com/office/powerpoint/2010/main" val="764188117"/>
       </p:ext>
     </p:extLst>
   </p:cSld>
@@ -6049,7 +6049,7 @@
           <p:cNvPr id="1" name="">
             <a:extLst xmlns:a="http://schemas.openxmlformats.org/drawingml/2006/main">
               <a:ext uri="{FF2B5EF4-FFF2-40B4-BE49-F238E27FC236}">
-                <a16:creationId xmlns:a16="http://schemas.microsoft.com/office/drawing/2014/main" id="{6C1B1665-904B-4C52-841A-C1DB58E28564}"/>
+                <a16:creationId xmlns:a16="http://schemas.microsoft.com/office/drawing/2014/main" id="{08E9B3DB-BADF-4DD3-9093-27DF98BA7965}"/>
               </a:ext>
             </a:extLst>
           </p:cNvPr>
@@ -6084,7 +6084,7 @@
           <p:cNvPr id="2" name="">
             <a:extLst xmlns:a="http://schemas.openxmlformats.org/drawingml/2006/main">
               <a:ext uri="{FF2B5EF4-FFF2-40B4-BE49-F238E27FC236}">
-                <a16:creationId xmlns:a16="http://schemas.microsoft.com/office/drawing/2014/main" id="{163D4BAA-CDE6-467C-9FE6-70F7AC85B8C6}"/>
+                <a16:creationId xmlns:a16="http://schemas.microsoft.com/office/drawing/2014/main" id="{71A89CD7-5009-4DDB-8123-EA48AFBAE67D}"/>
               </a:ext>
             </a:extLst>
           </p:cNvPr>
@@ -6148,7 +6148,7 @@
           <p:cNvPr id="3" name="">
             <a:extLst xmlns:a="http://schemas.openxmlformats.org/drawingml/2006/main">
               <a:ext uri="{FF2B5EF4-FFF2-40B4-BE49-F238E27FC236}">
-                <a16:creationId xmlns:a16="http://schemas.microsoft.com/office/drawing/2014/main" id="{5F5E2F33-3AD0-409B-AEEF-8BD3AC369352}"/>
+                <a16:creationId xmlns:a16="http://schemas.microsoft.com/office/drawing/2014/main" id="{05FB40CA-B727-4D67-BCE1-58E9F1E7CA98}"/>
               </a:ext>
             </a:extLst>
           </p:cNvPr>
@@ -6212,7 +6212,7 @@
           <p:cNvPr id="4" name="">
             <a:extLst xmlns:a="http://schemas.openxmlformats.org/drawingml/2006/main">
               <a:ext uri="{FF2B5EF4-FFF2-40B4-BE49-F238E27FC236}">
-                <a16:creationId xmlns:a16="http://schemas.microsoft.com/office/drawing/2014/main" id="{5D53A28E-3D34-4F4C-B73F-D182E681C663}"/>
+                <a16:creationId xmlns:a16="http://schemas.microsoft.com/office/drawing/2014/main" id="{3061D162-5E6D-4FCA-A5FE-29FB6DFD951B}"/>
               </a:ext>
             </a:extLst>
           </p:cNvPr>
@@ -6276,7 +6276,7 @@
           <p:cNvPr id="5" name="">
             <a:extLst xmlns:a="http://schemas.openxmlformats.org/drawingml/2006/main">
               <a:ext uri="{FF2B5EF4-FFF2-40B4-BE49-F238E27FC236}">
-                <a16:creationId xmlns:a16="http://schemas.microsoft.com/office/drawing/2014/main" id="{FB86235D-8D38-4748-92D4-22CD1AE55BA7}"/>
+                <a16:creationId xmlns:a16="http://schemas.microsoft.com/office/drawing/2014/main" id="{AD8851D4-540B-4074-BE67-30182B50339E}"/>
               </a:ext>
             </a:extLst>
           </p:cNvPr>
@@ -6309,7 +6309,7 @@
           <p:cNvPr id="6" name="">
             <a:extLst xmlns:a="http://schemas.openxmlformats.org/drawingml/2006/main">
               <a:ext uri="{FF2B5EF4-FFF2-40B4-BE49-F238E27FC236}">
-                <a16:creationId xmlns:a16="http://schemas.microsoft.com/office/drawing/2014/main" id="{E2C487EB-A30E-4B76-8EC4-36B184A040B1}"/>
+                <a16:creationId xmlns:a16="http://schemas.microsoft.com/office/drawing/2014/main" id="{80A3DF90-4CE3-4966-91BF-D1FBA2A08366}"/>
               </a:ext>
             </a:extLst>
           </p:cNvPr>
@@ -6373,7 +6373,7 @@
           <p:cNvPr id="7" name="">
             <a:extLst xmlns:a="http://schemas.openxmlformats.org/drawingml/2006/main">
               <a:ext uri="{FF2B5EF4-FFF2-40B4-BE49-F238E27FC236}">
-                <a16:creationId xmlns:a16="http://schemas.microsoft.com/office/drawing/2014/main" id="{A205B589-607A-4CBD-8B92-FE3B12C84B8C}"/>
+                <a16:creationId xmlns:a16="http://schemas.microsoft.com/office/drawing/2014/main" id="{B6D0F364-DC39-4D81-8B52-01BDB5BE5721}"/>
               </a:ext>
             </a:extLst>
           </p:cNvPr>
@@ -6437,7 +6437,7 @@
           <p:cNvPr id="8" name="">
             <a:extLst xmlns:a="http://schemas.openxmlformats.org/drawingml/2006/main">
               <a:ext uri="{FF2B5EF4-FFF2-40B4-BE49-F238E27FC236}">
-                <a16:creationId xmlns:a16="http://schemas.microsoft.com/office/drawing/2014/main" id="{C2265CB0-26ED-4173-B77C-97B4EC6547ED}"/>
+                <a16:creationId xmlns:a16="http://schemas.microsoft.com/office/drawing/2014/main" id="{12DB34A2-AB52-43E0-9CE4-37ADE1B06C3D}"/>
               </a:ext>
             </a:extLst>
           </p:cNvPr>
@@ -6470,7 +6470,7 @@
           <p:cNvPr id="9" name="">
             <a:extLst xmlns:a="http://schemas.openxmlformats.org/drawingml/2006/main">
               <a:ext uri="{FF2B5EF4-FFF2-40B4-BE49-F238E27FC236}">
-                <a16:creationId xmlns:a16="http://schemas.microsoft.com/office/drawing/2014/main" id="{B852DFD2-A049-4C2D-9C7C-9D08D16AAD8C}"/>
+                <a16:creationId xmlns:a16="http://schemas.microsoft.com/office/drawing/2014/main" id="{04FDC087-641F-4672-AE29-D928F2E488A7}"/>
               </a:ext>
             </a:extLst>
           </p:cNvPr>
@@ -6534,7 +6534,7 @@
           <p:cNvPr id="10" name="">
             <a:extLst xmlns:a="http://schemas.openxmlformats.org/drawingml/2006/main">
               <a:ext uri="{FF2B5EF4-FFF2-40B4-BE49-F238E27FC236}">
-                <a16:creationId xmlns:a16="http://schemas.microsoft.com/office/drawing/2014/main" id="{052711CA-CCEB-45F3-9681-0D666F00748A}"/>
+                <a16:creationId xmlns:a16="http://schemas.microsoft.com/office/drawing/2014/main" id="{2A1C5677-846F-4D80-9475-240AA54BBA3A}"/>
               </a:ext>
             </a:extLst>
           </p:cNvPr>
@@ -6598,7 +6598,7 @@
           <p:cNvPr id="11" name="">
             <a:extLst xmlns:a="http://schemas.openxmlformats.org/drawingml/2006/main">
               <a:ext uri="{FF2B5EF4-FFF2-40B4-BE49-F238E27FC236}">
-                <a16:creationId xmlns:a16="http://schemas.microsoft.com/office/drawing/2014/main" id="{3A59B612-A219-4039-A0D0-066E58CD36F1}"/>
+                <a16:creationId xmlns:a16="http://schemas.microsoft.com/office/drawing/2014/main" id="{0CB5A3DE-2A11-4184-84D6-B008FEDA0AFD}"/>
               </a:ext>
             </a:extLst>
           </p:cNvPr>
@@ -6631,7 +6631,7 @@
           <p:cNvPr id="12" name="">
             <a:extLst xmlns:a="http://schemas.openxmlformats.org/drawingml/2006/main">
               <a:ext uri="{FF2B5EF4-FFF2-40B4-BE49-F238E27FC236}">
-                <a16:creationId xmlns:a16="http://schemas.microsoft.com/office/drawing/2014/main" id="{147CD249-57E1-49C7-BFCC-612EE76D0C3E}"/>
+                <a16:creationId xmlns:a16="http://schemas.microsoft.com/office/drawing/2014/main" id="{00B3F406-9870-4C9E-89EB-968F18CFCEFB}"/>
               </a:ext>
             </a:extLst>
           </p:cNvPr>
@@ -6695,7 +6695,7 @@
           <p:cNvPr id="13" name="">
             <a:extLst xmlns:a="http://schemas.openxmlformats.org/drawingml/2006/main">
               <a:ext uri="{FF2B5EF4-FFF2-40B4-BE49-F238E27FC236}">
-                <a16:creationId xmlns:a16="http://schemas.microsoft.com/office/drawing/2014/main" id="{C1EAFDE9-EC78-404B-BB27-43B8687B1ADD}"/>
+                <a16:creationId xmlns:a16="http://schemas.microsoft.com/office/drawing/2014/main" id="{22E6366B-7A59-47B5-9937-E17DB3B76E50}"/>
               </a:ext>
             </a:extLst>
           </p:cNvPr>
@@ -6759,7 +6759,7 @@
           <p:cNvPr id="14" name="">
             <a:extLst xmlns:a="http://schemas.openxmlformats.org/drawingml/2006/main">
               <a:ext uri="{FF2B5EF4-FFF2-40B4-BE49-F238E27FC236}">
-                <a16:creationId xmlns:a16="http://schemas.microsoft.com/office/drawing/2014/main" id="{97F0F06F-CF8E-4357-833E-426EDF0A0AC8}"/>
+                <a16:creationId xmlns:a16="http://schemas.microsoft.com/office/drawing/2014/main" id="{63AF4373-6727-4E4F-89B4-005155FCA407}"/>
               </a:ext>
             </a:extLst>
           </p:cNvPr>
@@ -6792,7 +6792,7 @@
           <p:cNvPr id="15" name="">
             <a:extLst xmlns:a="http://schemas.openxmlformats.org/drawingml/2006/main">
               <a:ext uri="{FF2B5EF4-FFF2-40B4-BE49-F238E27FC236}">
-                <a16:creationId xmlns:a16="http://schemas.microsoft.com/office/drawing/2014/main" id="{8195CFEC-B20E-4D63-A948-B6517A432170}"/>
+                <a16:creationId xmlns:a16="http://schemas.microsoft.com/office/drawing/2014/main" id="{1F5940DC-7614-4755-BC57-02C6D7804D63}"/>
               </a:ext>
             </a:extLst>
           </p:cNvPr>
@@ -6856,7 +6856,7 @@
           <p:cNvPr id="16" name="">
             <a:extLst xmlns:a="http://schemas.openxmlformats.org/drawingml/2006/main">
               <a:ext uri="{FF2B5EF4-FFF2-40B4-BE49-F238E27FC236}">
-                <a16:creationId xmlns:a16="http://schemas.microsoft.com/office/drawing/2014/main" id="{7F965B4D-F6BF-43EC-8E98-4163AE7E487A}"/>
+                <a16:creationId xmlns:a16="http://schemas.microsoft.com/office/drawing/2014/main" id="{5973EBB7-E0AC-405A-9795-5408E0CA2065}"/>
               </a:ext>
             </a:extLst>
           </p:cNvPr>
@@ -6920,7 +6920,7 @@
           <p:cNvPr id="17" name="">
             <a:extLst xmlns:a="http://schemas.openxmlformats.org/drawingml/2006/main">
               <a:ext uri="{FF2B5EF4-FFF2-40B4-BE49-F238E27FC236}">
-                <a16:creationId xmlns:a16="http://schemas.microsoft.com/office/drawing/2014/main" id="{AE0B282C-E3D4-4066-A43C-A5E4D32F399E}"/>
+                <a16:creationId xmlns:a16="http://schemas.microsoft.com/office/drawing/2014/main" id="{ECE192FE-5EBB-4426-9314-C6FEF17A335A}"/>
               </a:ext>
             </a:extLst>
           </p:cNvPr>
@@ -6953,7 +6953,7 @@
           <p:cNvPr id="18" name="">
             <a:extLst xmlns:a="http://schemas.openxmlformats.org/drawingml/2006/main">
               <a:ext uri="{FF2B5EF4-FFF2-40B4-BE49-F238E27FC236}">
-                <a16:creationId xmlns:a16="http://schemas.microsoft.com/office/drawing/2014/main" id="{64C5F058-3854-42B0-BAE2-B749BB6C7880}"/>
+                <a16:creationId xmlns:a16="http://schemas.microsoft.com/office/drawing/2014/main" id="{22476E09-C281-4AD5-9AD7-DC659E54E7DC}"/>
               </a:ext>
             </a:extLst>
           </p:cNvPr>
@@ -7017,7 +7017,7 @@
           <p:cNvPr id="19" name="">
             <a:extLst xmlns:a="http://schemas.openxmlformats.org/drawingml/2006/main">
               <a:ext uri="{FF2B5EF4-FFF2-40B4-BE49-F238E27FC236}">
-                <a16:creationId xmlns:a16="http://schemas.microsoft.com/office/drawing/2014/main" id="{2542C142-1D47-4B4E-AB1A-C33CD3638CAC}"/>
+                <a16:creationId xmlns:a16="http://schemas.microsoft.com/office/drawing/2014/main" id="{41D189EC-0D2C-4FAD-8945-C222E96B2A4D}"/>
               </a:ext>
             </a:extLst>
           </p:cNvPr>
@@ -7081,7 +7081,7 @@
           <p:cNvPr id="20" name="">
             <a:extLst xmlns:a="http://schemas.openxmlformats.org/drawingml/2006/main">
               <a:ext uri="{FF2B5EF4-FFF2-40B4-BE49-F238E27FC236}">
-                <a16:creationId xmlns:a16="http://schemas.microsoft.com/office/drawing/2014/main" id="{90BF982F-0305-4A0E-94F2-A0670F407A4B}"/>
+                <a16:creationId xmlns:a16="http://schemas.microsoft.com/office/drawing/2014/main" id="{161EE22A-2857-4A22-BE68-B179A943EC69}"/>
               </a:ext>
             </a:extLst>
           </p:cNvPr>
@@ -7114,7 +7114,7 @@
           <p:cNvPr id="21" name="">
             <a:extLst xmlns:a="http://schemas.openxmlformats.org/drawingml/2006/main">
               <a:ext uri="{FF2B5EF4-FFF2-40B4-BE49-F238E27FC236}">
-                <a16:creationId xmlns:a16="http://schemas.microsoft.com/office/drawing/2014/main" id="{E803C949-3A2B-40A5-BE44-18FCCF2AA3FA}"/>
+                <a16:creationId xmlns:a16="http://schemas.microsoft.com/office/drawing/2014/main" id="{AB935870-287F-44B0-9FBA-8A2901453010}"/>
               </a:ext>
             </a:extLst>
           </p:cNvPr>
@@ -7178,7 +7178,7 @@
           <p:cNvPr id="22" name="">
             <a:extLst xmlns:a="http://schemas.openxmlformats.org/drawingml/2006/main">
               <a:ext uri="{FF2B5EF4-FFF2-40B4-BE49-F238E27FC236}">
-                <a16:creationId xmlns:a16="http://schemas.microsoft.com/office/drawing/2014/main" id="{04F0AB17-75BB-42A3-8182-1C8A3B4D6013}"/>
+                <a16:creationId xmlns:a16="http://schemas.microsoft.com/office/drawing/2014/main" id="{B8D0419E-BCAB-43B4-9191-2FB56B1DD4B5}"/>
               </a:ext>
             </a:extLst>
           </p:cNvPr>
@@ -7242,7 +7242,7 @@
           <p:cNvPr id="23" name="">
             <a:extLst xmlns:a="http://schemas.openxmlformats.org/drawingml/2006/main">
               <a:ext uri="{FF2B5EF4-FFF2-40B4-BE49-F238E27FC236}">
-                <a16:creationId xmlns:a16="http://schemas.microsoft.com/office/drawing/2014/main" id="{A861B946-064D-4862-AAD6-F78BA312E2EB}"/>
+                <a16:creationId xmlns:a16="http://schemas.microsoft.com/office/drawing/2014/main" id="{7441359B-9230-4493-AA9D-571F0D38CDB8}"/>
               </a:ext>
             </a:extLst>
           </p:cNvPr>
@@ -7306,7 +7306,7 @@
           <p:cNvPr id="24" name="">
             <a:extLst xmlns:a="http://schemas.openxmlformats.org/drawingml/2006/main">
               <a:ext uri="{FF2B5EF4-FFF2-40B4-BE49-F238E27FC236}">
-                <a16:creationId xmlns:a16="http://schemas.microsoft.com/office/drawing/2014/main" id="{695BAB0A-4BF6-4BB2-B587-B089FE1F4AD1}"/>
+                <a16:creationId xmlns:a16="http://schemas.microsoft.com/office/drawing/2014/main" id="{F9C6B851-5A91-4672-B17C-138CDE16D0CD}"/>
               </a:ext>
             </a:extLst>
           </p:cNvPr>
@@ -7368,7 +7368,7 @@
     </p:spTree>
     <p:extLst>
       <p:ext uri="{BB962C8B-B14F-4D97-AF65-F5344CB8AC3E}">
-        <p14:creationId xmlns:p14="http://schemas.microsoft.com/office/powerpoint/2010/main" val="1420780870"/>
+        <p14:creationId xmlns:p14="http://schemas.microsoft.com/office/powerpoint/2010/main" val="1944177702"/>
       </p:ext>
     </p:extLst>
   </p:cSld>
@@ -7392,7 +7392,7 @@
           <p:cNvPr id="1" name="">
             <a:extLst xmlns:a="http://schemas.openxmlformats.org/drawingml/2006/main">
               <a:ext uri="{FF2B5EF4-FFF2-40B4-BE49-F238E27FC236}">
-                <a16:creationId xmlns:a16="http://schemas.microsoft.com/office/drawing/2014/main" id="{3A535203-7113-4843-A68A-A38C6E895F8B}"/>
+                <a16:creationId xmlns:a16="http://schemas.microsoft.com/office/drawing/2014/main" id="{03167B11-E39F-4970-AF6F-482D4E48D9B1}"/>
               </a:ext>
             </a:extLst>
           </p:cNvPr>
@@ -7427,7 +7427,7 @@
           <p:cNvPr id="2" name="">
             <a:extLst xmlns:a="http://schemas.openxmlformats.org/drawingml/2006/main">
               <a:ext uri="{FF2B5EF4-FFF2-40B4-BE49-F238E27FC236}">
-                <a16:creationId xmlns:a16="http://schemas.microsoft.com/office/drawing/2014/main" id="{295F00EC-FBFE-49F9-AF30-30B071C4098D}"/>
+                <a16:creationId xmlns:a16="http://schemas.microsoft.com/office/drawing/2014/main" id="{C3FACE44-83B4-4CFD-88CF-F2B477474522}"/>
               </a:ext>
             </a:extLst>
           </p:cNvPr>
@@ -7491,7 +7491,7 @@
           <p:cNvPr id="3" name="">
             <a:extLst xmlns:a="http://schemas.openxmlformats.org/drawingml/2006/main">
               <a:ext uri="{FF2B5EF4-FFF2-40B4-BE49-F238E27FC236}">
-                <a16:creationId xmlns:a16="http://schemas.microsoft.com/office/drawing/2014/main" id="{B0E2EF71-8509-4852-8333-6CF9BFF367CE}"/>
+                <a16:creationId xmlns:a16="http://schemas.microsoft.com/office/drawing/2014/main" id="{4F121D9F-465C-4A8C-AFD7-023FBBFBCEC5}"/>
               </a:ext>
             </a:extLst>
           </p:cNvPr>
@@ -7555,7 +7555,7 @@
           <p:cNvPr id="4" name="">
             <a:extLst xmlns:a="http://schemas.openxmlformats.org/drawingml/2006/main">
               <a:ext uri="{FF2B5EF4-FFF2-40B4-BE49-F238E27FC236}">
-                <a16:creationId xmlns:a16="http://schemas.microsoft.com/office/drawing/2014/main" id="{A7166039-F1C1-4C49-86D0-3E3ACB8D516D}"/>
+                <a16:creationId xmlns:a16="http://schemas.microsoft.com/office/drawing/2014/main" id="{BF902388-F13D-4F44-8BBB-6BC32E1A2A40}"/>
               </a:ext>
             </a:extLst>
           </p:cNvPr>
@@ -7619,7 +7619,7 @@
           <p:cNvPr id="5" name="">
             <a:extLst xmlns:a="http://schemas.openxmlformats.org/drawingml/2006/main">
               <a:ext uri="{FF2B5EF4-FFF2-40B4-BE49-F238E27FC236}">
-                <a16:creationId xmlns:a16="http://schemas.microsoft.com/office/drawing/2014/main" id="{FC446992-97A2-441A-8B16-45266DBEC704}"/>
+                <a16:creationId xmlns:a16="http://schemas.microsoft.com/office/drawing/2014/main" id="{3EA3AC01-AABD-42C8-8DA7-B47BB860F2B0}"/>
               </a:ext>
             </a:extLst>
           </p:cNvPr>
@@ -7652,7 +7652,7 @@
           <p:cNvPr id="6" name="">
             <a:extLst xmlns:a="http://schemas.openxmlformats.org/drawingml/2006/main">
               <a:ext uri="{FF2B5EF4-FFF2-40B4-BE49-F238E27FC236}">
-                <a16:creationId xmlns:a16="http://schemas.microsoft.com/office/drawing/2014/main" id="{BF742F00-2F54-41A3-A21B-3B3505580C6D}"/>
+                <a16:creationId xmlns:a16="http://schemas.microsoft.com/office/drawing/2014/main" id="{CF7469C7-2CC4-44B5-B328-499C4893A378}"/>
               </a:ext>
             </a:extLst>
           </p:cNvPr>
@@ -7716,7 +7716,7 @@
           <p:cNvPr id="7" name="">
             <a:extLst xmlns:a="http://schemas.openxmlformats.org/drawingml/2006/main">
               <a:ext uri="{FF2B5EF4-FFF2-40B4-BE49-F238E27FC236}">
-                <a16:creationId xmlns:a16="http://schemas.microsoft.com/office/drawing/2014/main" id="{1E22DA76-9A5F-40B5-9344-686E9B6C928B}"/>
+                <a16:creationId xmlns:a16="http://schemas.microsoft.com/office/drawing/2014/main" id="{4E4D8443-5213-4EC6-B4AD-E585513899DA}"/>
               </a:ext>
             </a:extLst>
           </p:cNvPr>
@@ -7780,7 +7780,7 @@
           <p:cNvPr id="8" name="">
             <a:extLst xmlns:a="http://schemas.openxmlformats.org/drawingml/2006/main">
               <a:ext uri="{FF2B5EF4-FFF2-40B4-BE49-F238E27FC236}">
-                <a16:creationId xmlns:a16="http://schemas.microsoft.com/office/drawing/2014/main" id="{EE63AD08-8F6D-4556-9E57-DD52C476D6B0}"/>
+                <a16:creationId xmlns:a16="http://schemas.microsoft.com/office/drawing/2014/main" id="{284C6A1A-B6FA-4030-AF3B-E6770F6A0A99}"/>
               </a:ext>
             </a:extLst>
           </p:cNvPr>
@@ -7813,7 +7813,7 @@
           <p:cNvPr id="9" name="">
             <a:extLst xmlns:a="http://schemas.openxmlformats.org/drawingml/2006/main">
               <a:ext uri="{FF2B5EF4-FFF2-40B4-BE49-F238E27FC236}">
-                <a16:creationId xmlns:a16="http://schemas.microsoft.com/office/drawing/2014/main" id="{FDF2B506-1860-4F78-8354-F8C459DF8128}"/>
+                <a16:creationId xmlns:a16="http://schemas.microsoft.com/office/drawing/2014/main" id="{3413D740-F04E-44D3-A4C6-66497980D7DD}"/>
               </a:ext>
             </a:extLst>
           </p:cNvPr>
@@ -7877,7 +7877,7 @@
           <p:cNvPr id="10" name="">
             <a:extLst xmlns:a="http://schemas.openxmlformats.org/drawingml/2006/main">
               <a:ext uri="{FF2B5EF4-FFF2-40B4-BE49-F238E27FC236}">
-                <a16:creationId xmlns:a16="http://schemas.microsoft.com/office/drawing/2014/main" id="{AD514D7B-3B8E-48EB-B728-6947875B1CE5}"/>
+                <a16:creationId xmlns:a16="http://schemas.microsoft.com/office/drawing/2014/main" id="{CC62C9D3-A87A-4490-B6FF-F4970FBEC64F}"/>
               </a:ext>
             </a:extLst>
           </p:cNvPr>
@@ -7941,7 +7941,7 @@
           <p:cNvPr id="11" name="">
             <a:extLst xmlns:a="http://schemas.openxmlformats.org/drawingml/2006/main">
               <a:ext uri="{FF2B5EF4-FFF2-40B4-BE49-F238E27FC236}">
-                <a16:creationId xmlns:a16="http://schemas.microsoft.com/office/drawing/2014/main" id="{4C3A0AE0-5CA2-414D-A42A-CF8D572884FC}"/>
+                <a16:creationId xmlns:a16="http://schemas.microsoft.com/office/drawing/2014/main" id="{83097936-53A3-41C0-8BC4-07BC7A6489B9}"/>
               </a:ext>
             </a:extLst>
           </p:cNvPr>
@@ -7974,7 +7974,7 @@
           <p:cNvPr id="12" name="">
             <a:extLst xmlns:a="http://schemas.openxmlformats.org/drawingml/2006/main">
               <a:ext uri="{FF2B5EF4-FFF2-40B4-BE49-F238E27FC236}">
-                <a16:creationId xmlns:a16="http://schemas.microsoft.com/office/drawing/2014/main" id="{C458620D-AAB5-4532-AE21-882E37B1FFDA}"/>
+                <a16:creationId xmlns:a16="http://schemas.microsoft.com/office/drawing/2014/main" id="{F53EF4F4-279D-4D3E-86F7-8CB555592FC0}"/>
               </a:ext>
             </a:extLst>
           </p:cNvPr>
@@ -8038,7 +8038,7 @@
           <p:cNvPr id="13" name="">
             <a:extLst xmlns:a="http://schemas.openxmlformats.org/drawingml/2006/main">
               <a:ext uri="{FF2B5EF4-FFF2-40B4-BE49-F238E27FC236}">
-                <a16:creationId xmlns:a16="http://schemas.microsoft.com/office/drawing/2014/main" id="{0A264B90-58C8-4773-B409-BE86D7761D16}"/>
+                <a16:creationId xmlns:a16="http://schemas.microsoft.com/office/drawing/2014/main" id="{4F6ECCCA-B32C-4937-9866-D26D1D45BE1F}"/>
               </a:ext>
             </a:extLst>
           </p:cNvPr>
@@ -8102,7 +8102,7 @@
           <p:cNvPr id="14" name="">
             <a:extLst xmlns:a="http://schemas.openxmlformats.org/drawingml/2006/main">
               <a:ext uri="{FF2B5EF4-FFF2-40B4-BE49-F238E27FC236}">
-                <a16:creationId xmlns:a16="http://schemas.microsoft.com/office/drawing/2014/main" id="{CA3AA1EF-CB88-4606-9D08-78CB4B0712A2}"/>
+                <a16:creationId xmlns:a16="http://schemas.microsoft.com/office/drawing/2014/main" id="{72CA4CB6-5389-4AAB-B847-590B3C282826}"/>
               </a:ext>
             </a:extLst>
           </p:cNvPr>
@@ -8135,7 +8135,7 @@
           <p:cNvPr id="15" name="">
             <a:extLst xmlns:a="http://schemas.openxmlformats.org/drawingml/2006/main">
               <a:ext uri="{FF2B5EF4-FFF2-40B4-BE49-F238E27FC236}">
-                <a16:creationId xmlns:a16="http://schemas.microsoft.com/office/drawing/2014/main" id="{5B2BD48A-9D8F-48B5-86C3-F2AA369DF7D4}"/>
+                <a16:creationId xmlns:a16="http://schemas.microsoft.com/office/drawing/2014/main" id="{CE1E2C6C-154B-4B36-86B5-D7D55A0DDDEA}"/>
               </a:ext>
             </a:extLst>
           </p:cNvPr>
@@ -8199,7 +8199,7 @@
           <p:cNvPr id="16" name="">
             <a:extLst xmlns:a="http://schemas.openxmlformats.org/drawingml/2006/main">
               <a:ext uri="{FF2B5EF4-FFF2-40B4-BE49-F238E27FC236}">
-                <a16:creationId xmlns:a16="http://schemas.microsoft.com/office/drawing/2014/main" id="{1E5C2B7B-88D7-4469-9206-D135D21C099C}"/>
+                <a16:creationId xmlns:a16="http://schemas.microsoft.com/office/drawing/2014/main" id="{B7ED44CE-D31A-426D-A740-D69EFE7B0421}"/>
               </a:ext>
             </a:extLst>
           </p:cNvPr>
@@ -8263,7 +8263,7 @@
           <p:cNvPr id="17" name="">
             <a:extLst xmlns:a="http://schemas.openxmlformats.org/drawingml/2006/main">
               <a:ext uri="{FF2B5EF4-FFF2-40B4-BE49-F238E27FC236}">
-                <a16:creationId xmlns:a16="http://schemas.microsoft.com/office/drawing/2014/main" id="{CBF19166-7E04-4735-A59B-315C3F4EF5C9}"/>
+                <a16:creationId xmlns:a16="http://schemas.microsoft.com/office/drawing/2014/main" id="{C1D71EFC-93DF-4494-AB6E-0C44512717C9}"/>
               </a:ext>
             </a:extLst>
           </p:cNvPr>
@@ -8296,7 +8296,7 @@
           <p:cNvPr id="18" name="">
             <a:extLst xmlns:a="http://schemas.openxmlformats.org/drawingml/2006/main">
               <a:ext uri="{FF2B5EF4-FFF2-40B4-BE49-F238E27FC236}">
-                <a16:creationId xmlns:a16="http://schemas.microsoft.com/office/drawing/2014/main" id="{84E91101-37E9-4614-9ACE-592DF9FE3831}"/>
+                <a16:creationId xmlns:a16="http://schemas.microsoft.com/office/drawing/2014/main" id="{B7B6D64F-2103-4CE1-ACD6-A6883524FE3F}"/>
               </a:ext>
             </a:extLst>
           </p:cNvPr>
@@ -8360,7 +8360,7 @@
           <p:cNvPr id="19" name="">
             <a:extLst xmlns:a="http://schemas.openxmlformats.org/drawingml/2006/main">
               <a:ext uri="{FF2B5EF4-FFF2-40B4-BE49-F238E27FC236}">
-                <a16:creationId xmlns:a16="http://schemas.microsoft.com/office/drawing/2014/main" id="{B4098635-EFB9-4744-9D90-B444980416AE}"/>
+                <a16:creationId xmlns:a16="http://schemas.microsoft.com/office/drawing/2014/main" id="{B6C04DCB-AF3D-40EF-8CF3-B0169FC2F33C}"/>
               </a:ext>
             </a:extLst>
           </p:cNvPr>
@@ -8424,7 +8424,7 @@
           <p:cNvPr id="20" name="">
             <a:extLst xmlns:a="http://schemas.openxmlformats.org/drawingml/2006/main">
               <a:ext uri="{FF2B5EF4-FFF2-40B4-BE49-F238E27FC236}">
-                <a16:creationId xmlns:a16="http://schemas.microsoft.com/office/drawing/2014/main" id="{A2C1D1A1-96D0-4324-B13B-B64BDAD61055}"/>
+                <a16:creationId xmlns:a16="http://schemas.microsoft.com/office/drawing/2014/main" id="{38D7CE38-2B9F-4AF8-9728-5009DF9C27DC}"/>
               </a:ext>
             </a:extLst>
           </p:cNvPr>
@@ -8457,7 +8457,7 @@
           <p:cNvPr id="21" name="">
             <a:extLst xmlns:a="http://schemas.openxmlformats.org/drawingml/2006/main">
               <a:ext uri="{FF2B5EF4-FFF2-40B4-BE49-F238E27FC236}">
-                <a16:creationId xmlns:a16="http://schemas.microsoft.com/office/drawing/2014/main" id="{80EF3400-9F8B-4052-8DB5-50FCB4428DB9}"/>
+                <a16:creationId xmlns:a16="http://schemas.microsoft.com/office/drawing/2014/main" id="{A8BC400E-629B-456B-8B9D-0227F4448F31}"/>
               </a:ext>
             </a:extLst>
           </p:cNvPr>
@@ -8521,7 +8521,7 @@
           <p:cNvPr id="22" name="">
             <a:extLst xmlns:a="http://schemas.openxmlformats.org/drawingml/2006/main">
               <a:ext uri="{FF2B5EF4-FFF2-40B4-BE49-F238E27FC236}">
-                <a16:creationId xmlns:a16="http://schemas.microsoft.com/office/drawing/2014/main" id="{FECB8AC9-6FFD-454E-9433-04C41C1BFC63}"/>
+                <a16:creationId xmlns:a16="http://schemas.microsoft.com/office/drawing/2014/main" id="{179A19B8-EB21-44BE-BBEA-BD20574BD470}"/>
               </a:ext>
             </a:extLst>
           </p:cNvPr>
@@ -8585,7 +8585,7 @@
           <p:cNvPr id="23" name="">
             <a:extLst xmlns:a="http://schemas.openxmlformats.org/drawingml/2006/main">
               <a:ext uri="{FF2B5EF4-FFF2-40B4-BE49-F238E27FC236}">
-                <a16:creationId xmlns:a16="http://schemas.microsoft.com/office/drawing/2014/main" id="{DC263F65-4CE3-44DC-A5F2-23676C0B5DDB}"/>
+                <a16:creationId xmlns:a16="http://schemas.microsoft.com/office/drawing/2014/main" id="{F933BC2F-A843-4CDA-8A52-2709C8F5FC7E}"/>
               </a:ext>
             </a:extLst>
           </p:cNvPr>
@@ -8618,7 +8618,7 @@
           <p:cNvPr id="24" name="">
             <a:extLst xmlns:a="http://schemas.openxmlformats.org/drawingml/2006/main">
               <a:ext uri="{FF2B5EF4-FFF2-40B4-BE49-F238E27FC236}">
-                <a16:creationId xmlns:a16="http://schemas.microsoft.com/office/drawing/2014/main" id="{6911530B-B730-4379-B904-E230BAE8DA45}"/>
+                <a16:creationId xmlns:a16="http://schemas.microsoft.com/office/drawing/2014/main" id="{D7DF1AD6-660E-4504-9245-40948FDCB6F2}"/>
               </a:ext>
             </a:extLst>
           </p:cNvPr>
@@ -8682,7 +8682,7 @@
           <p:cNvPr id="25" name="">
             <a:extLst xmlns:a="http://schemas.openxmlformats.org/drawingml/2006/main">
               <a:ext uri="{FF2B5EF4-FFF2-40B4-BE49-F238E27FC236}">
-                <a16:creationId xmlns:a16="http://schemas.microsoft.com/office/drawing/2014/main" id="{60C18868-0A84-4ADC-9694-BA833ECDE81C}"/>
+                <a16:creationId xmlns:a16="http://schemas.microsoft.com/office/drawing/2014/main" id="{CD992BC7-A708-42CD-8729-FE6517B2DA51}"/>
               </a:ext>
             </a:extLst>
           </p:cNvPr>
@@ -8746,7 +8746,7 @@
           <p:cNvPr id="26" name="">
             <a:extLst xmlns:a="http://schemas.openxmlformats.org/drawingml/2006/main">
               <a:ext uri="{FF2B5EF4-FFF2-40B4-BE49-F238E27FC236}">
-                <a16:creationId xmlns:a16="http://schemas.microsoft.com/office/drawing/2014/main" id="{6B8C6EEA-060B-4926-847E-1F0C4819EECB}"/>
+                <a16:creationId xmlns:a16="http://schemas.microsoft.com/office/drawing/2014/main" id="{8131626E-DA08-4465-9DA4-4F8B7EA0C1A4}"/>
               </a:ext>
             </a:extLst>
           </p:cNvPr>
@@ -8810,7 +8810,7 @@
           <p:cNvPr id="27" name="">
             <a:extLst xmlns:a="http://schemas.openxmlformats.org/drawingml/2006/main">
               <a:ext uri="{FF2B5EF4-FFF2-40B4-BE49-F238E27FC236}">
-                <a16:creationId xmlns:a16="http://schemas.microsoft.com/office/drawing/2014/main" id="{6A599D50-E11B-497A-9C36-170F8EAB9AB7}"/>
+                <a16:creationId xmlns:a16="http://schemas.microsoft.com/office/drawing/2014/main" id="{05C93460-6B47-4447-A628-230051ECAD61}"/>
               </a:ext>
             </a:extLst>
           </p:cNvPr>
@@ -8872,7 +8872,7 @@
     </p:spTree>
     <p:extLst>
       <p:ext uri="{BB962C8B-B14F-4D97-AF65-F5344CB8AC3E}">
-        <p14:creationId xmlns:p14="http://schemas.microsoft.com/office/powerpoint/2010/main" val="1390913658"/>
+        <p14:creationId xmlns:p14="http://schemas.microsoft.com/office/powerpoint/2010/main" val="2035880525"/>
       </p:ext>
     </p:extLst>
   </p:cSld>
@@ -8896,7 +8896,7 @@
           <p:cNvPr id="1" name="">
             <a:extLst xmlns:a="http://schemas.openxmlformats.org/drawingml/2006/main">
               <a:ext uri="{FF2B5EF4-FFF2-40B4-BE49-F238E27FC236}">
-                <a16:creationId xmlns:a16="http://schemas.microsoft.com/office/drawing/2014/main" id="{FE138756-073D-4A49-86F9-B4F974B11900}"/>
+                <a16:creationId xmlns:a16="http://schemas.microsoft.com/office/drawing/2014/main" id="{0F970EBE-7F84-4F40-B129-7D143765DDC2}"/>
               </a:ext>
             </a:extLst>
           </p:cNvPr>
@@ -8931,7 +8931,7 @@
           <p:cNvPr id="2" name="">
             <a:extLst xmlns:a="http://schemas.openxmlformats.org/drawingml/2006/main">
               <a:ext uri="{FF2B5EF4-FFF2-40B4-BE49-F238E27FC236}">
-                <a16:creationId xmlns:a16="http://schemas.microsoft.com/office/drawing/2014/main" id="{246AD9EA-8B9D-4C33-8863-696497E590C4}"/>
+                <a16:creationId xmlns:a16="http://schemas.microsoft.com/office/drawing/2014/main" id="{9D04D75C-9A19-411C-9496-DF1D580F6B9E}"/>
               </a:ext>
             </a:extLst>
           </p:cNvPr>
@@ -8995,7 +8995,7 @@
           <p:cNvPr id="3" name="">
             <a:extLst xmlns:a="http://schemas.openxmlformats.org/drawingml/2006/main">
               <a:ext uri="{FF2B5EF4-FFF2-40B4-BE49-F238E27FC236}">
-                <a16:creationId xmlns:a16="http://schemas.microsoft.com/office/drawing/2014/main" id="{6C5B95EF-132B-4B72-A1B9-2D8FED75BC47}"/>
+                <a16:creationId xmlns:a16="http://schemas.microsoft.com/office/drawing/2014/main" id="{006613E0-F329-4CF6-A0D1-256DF6E83BD9}"/>
               </a:ext>
             </a:extLst>
           </p:cNvPr>
@@ -9059,7 +9059,7 @@
           <p:cNvPr id="4" name="">
             <a:extLst xmlns:a="http://schemas.openxmlformats.org/drawingml/2006/main">
               <a:ext uri="{FF2B5EF4-FFF2-40B4-BE49-F238E27FC236}">
-                <a16:creationId xmlns:a16="http://schemas.microsoft.com/office/drawing/2014/main" id="{32668FAD-48E2-4960-AF22-056AB296F0FD}"/>
+                <a16:creationId xmlns:a16="http://schemas.microsoft.com/office/drawing/2014/main" id="{95F6B8F0-93E4-476E-9E27-7A35146C1DC0}"/>
               </a:ext>
             </a:extLst>
           </p:cNvPr>
@@ -9123,7 +9123,7 @@
           <p:cNvPr id="5" name="">
             <a:extLst xmlns:a="http://schemas.openxmlformats.org/drawingml/2006/main">
               <a:ext uri="{FF2B5EF4-FFF2-40B4-BE49-F238E27FC236}">
-                <a16:creationId xmlns:a16="http://schemas.microsoft.com/office/drawing/2014/main" id="{98CF7AA6-C36C-4200-9608-A055F6C9A296}"/>
+                <a16:creationId xmlns:a16="http://schemas.microsoft.com/office/drawing/2014/main" id="{B05FB43A-5282-4040-9E6C-5D0886140695}"/>
               </a:ext>
             </a:extLst>
           </p:cNvPr>
@@ -9156,7 +9156,7 @@
           <p:cNvPr id="6" name="">
             <a:extLst xmlns:a="http://schemas.openxmlformats.org/drawingml/2006/main">
               <a:ext uri="{FF2B5EF4-FFF2-40B4-BE49-F238E27FC236}">
-                <a16:creationId xmlns:a16="http://schemas.microsoft.com/office/drawing/2014/main" id="{5BA090F6-5ADA-4763-812F-EC73A1F55222}"/>
+                <a16:creationId xmlns:a16="http://schemas.microsoft.com/office/drawing/2014/main" id="{E2674065-3BA0-44A0-B496-B81E17938908}"/>
               </a:ext>
             </a:extLst>
           </p:cNvPr>
@@ -9220,7 +9220,7 @@
           <p:cNvPr id="7" name="">
             <a:extLst xmlns:a="http://schemas.openxmlformats.org/drawingml/2006/main">
               <a:ext uri="{FF2B5EF4-FFF2-40B4-BE49-F238E27FC236}">
-                <a16:creationId xmlns:a16="http://schemas.microsoft.com/office/drawing/2014/main" id="{F4AFB433-073F-4234-BFD2-BC693939294A}"/>
+                <a16:creationId xmlns:a16="http://schemas.microsoft.com/office/drawing/2014/main" id="{2A1C97FD-7E8F-4C61-AF87-A48A55D99338}"/>
               </a:ext>
             </a:extLst>
           </p:cNvPr>
@@ -9284,7 +9284,7 @@
           <p:cNvPr id="8" name="">
             <a:extLst xmlns:a="http://schemas.openxmlformats.org/drawingml/2006/main">
               <a:ext uri="{FF2B5EF4-FFF2-40B4-BE49-F238E27FC236}">
-                <a16:creationId xmlns:a16="http://schemas.microsoft.com/office/drawing/2014/main" id="{D6BE51DD-B1C3-4FF2-8CAE-298D5020D0DA}"/>
+                <a16:creationId xmlns:a16="http://schemas.microsoft.com/office/drawing/2014/main" id="{BF4A0FD5-F0D3-4119-B8B4-AA5D1BB4BA74}"/>
               </a:ext>
             </a:extLst>
           </p:cNvPr>
@@ -9317,7 +9317,7 @@
           <p:cNvPr id="9" name="">
             <a:extLst xmlns:a="http://schemas.openxmlformats.org/drawingml/2006/main">
               <a:ext uri="{FF2B5EF4-FFF2-40B4-BE49-F238E27FC236}">
-                <a16:creationId xmlns:a16="http://schemas.microsoft.com/office/drawing/2014/main" id="{CCD0C05D-493B-467F-8B88-554047BC4EB2}"/>
+                <a16:creationId xmlns:a16="http://schemas.microsoft.com/office/drawing/2014/main" id="{26C2F4D6-C5B3-4A9F-B743-DD44BC3B1912}"/>
               </a:ext>
             </a:extLst>
           </p:cNvPr>
@@ -9381,7 +9381,7 @@
           <p:cNvPr id="10" name="">
             <a:extLst xmlns:a="http://schemas.openxmlformats.org/drawingml/2006/main">
               <a:ext uri="{FF2B5EF4-FFF2-40B4-BE49-F238E27FC236}">
-                <a16:creationId xmlns:a16="http://schemas.microsoft.com/office/drawing/2014/main" id="{2F2BBCD6-974D-4A29-B885-9EBAA8EDD156}"/>
+                <a16:creationId xmlns:a16="http://schemas.microsoft.com/office/drawing/2014/main" id="{6D93131A-7D8A-49ED-984D-37AFD50B049F}"/>
               </a:ext>
             </a:extLst>
           </p:cNvPr>
@@ -9445,7 +9445,7 @@
           <p:cNvPr id="11" name="">
             <a:extLst xmlns:a="http://schemas.openxmlformats.org/drawingml/2006/main">
               <a:ext uri="{FF2B5EF4-FFF2-40B4-BE49-F238E27FC236}">
-                <a16:creationId xmlns:a16="http://schemas.microsoft.com/office/drawing/2014/main" id="{F07990C6-ABAB-4F5F-AA47-EA6BC1510662}"/>
+                <a16:creationId xmlns:a16="http://schemas.microsoft.com/office/drawing/2014/main" id="{A4DF2615-B572-49F6-B235-D8640207F612}"/>
               </a:ext>
             </a:extLst>
           </p:cNvPr>
@@ -9478,7 +9478,7 @@
           <p:cNvPr id="12" name="">
             <a:extLst xmlns:a="http://schemas.openxmlformats.org/drawingml/2006/main">
               <a:ext uri="{FF2B5EF4-FFF2-40B4-BE49-F238E27FC236}">
-                <a16:creationId xmlns:a16="http://schemas.microsoft.com/office/drawing/2014/main" id="{4C4471AF-17A6-4A1F-96EC-32DB6D7FC0B5}"/>
+                <a16:creationId xmlns:a16="http://schemas.microsoft.com/office/drawing/2014/main" id="{B3D9836B-6167-4E61-A6BA-AFF735C72EFA}"/>
               </a:ext>
             </a:extLst>
           </p:cNvPr>
@@ -9542,7 +9542,7 @@
           <p:cNvPr id="13" name="">
             <a:extLst xmlns:a="http://schemas.openxmlformats.org/drawingml/2006/main">
               <a:ext uri="{FF2B5EF4-FFF2-40B4-BE49-F238E27FC236}">
-                <a16:creationId xmlns:a16="http://schemas.microsoft.com/office/drawing/2014/main" id="{765DB173-6979-4997-A397-5ABFB9F8DFF9}"/>
+                <a16:creationId xmlns:a16="http://schemas.microsoft.com/office/drawing/2014/main" id="{2489C234-536E-4E3D-89BC-919D1C7AC5EF}"/>
               </a:ext>
             </a:extLst>
           </p:cNvPr>
@@ -9606,7 +9606,7 @@
           <p:cNvPr id="14" name="">
             <a:extLst xmlns:a="http://schemas.openxmlformats.org/drawingml/2006/main">
               <a:ext uri="{FF2B5EF4-FFF2-40B4-BE49-F238E27FC236}">
-                <a16:creationId xmlns:a16="http://schemas.microsoft.com/office/drawing/2014/main" id="{7DCA8027-22AB-4BD2-A112-5FBD92D00728}"/>
+                <a16:creationId xmlns:a16="http://schemas.microsoft.com/office/drawing/2014/main" id="{9408E668-AC3F-44DC-8AA7-A009D23DF095}"/>
               </a:ext>
             </a:extLst>
           </p:cNvPr>
@@ -9639,7 +9639,7 @@
           <p:cNvPr id="15" name="">
             <a:extLst xmlns:a="http://schemas.openxmlformats.org/drawingml/2006/main">
               <a:ext uri="{FF2B5EF4-FFF2-40B4-BE49-F238E27FC236}">
-                <a16:creationId xmlns:a16="http://schemas.microsoft.com/office/drawing/2014/main" id="{3E92A6EE-6481-42F3-BA83-3C94183C7362}"/>
+                <a16:creationId xmlns:a16="http://schemas.microsoft.com/office/drawing/2014/main" id="{4D90EEE9-FE4B-4C85-B56D-2BA6EA3DD313}"/>
               </a:ext>
             </a:extLst>
           </p:cNvPr>
@@ -9703,7 +9703,7 @@
           <p:cNvPr id="16" name="">
             <a:extLst xmlns:a="http://schemas.openxmlformats.org/drawingml/2006/main">
               <a:ext uri="{FF2B5EF4-FFF2-40B4-BE49-F238E27FC236}">
-                <a16:creationId xmlns:a16="http://schemas.microsoft.com/office/drawing/2014/main" id="{EE82C500-FE7D-41DA-ABBB-FE25FCC9A29E}"/>
+                <a16:creationId xmlns:a16="http://schemas.microsoft.com/office/drawing/2014/main" id="{79F148D3-5A30-4B10-B55F-75D8AC729078}"/>
               </a:ext>
             </a:extLst>
           </p:cNvPr>
@@ -9767,7 +9767,7 @@
           <p:cNvPr id="17" name="">
             <a:extLst xmlns:a="http://schemas.openxmlformats.org/drawingml/2006/main">
               <a:ext uri="{FF2B5EF4-FFF2-40B4-BE49-F238E27FC236}">
-                <a16:creationId xmlns:a16="http://schemas.microsoft.com/office/drawing/2014/main" id="{62D895BA-0A7D-49B3-BE7C-BD008917F153}"/>
+                <a16:creationId xmlns:a16="http://schemas.microsoft.com/office/drawing/2014/main" id="{783E892E-EC44-4771-8DC5-1EC65F0EF668}"/>
               </a:ext>
             </a:extLst>
           </p:cNvPr>
@@ -9800,7 +9800,7 @@
           <p:cNvPr id="18" name="">
             <a:extLst xmlns:a="http://schemas.openxmlformats.org/drawingml/2006/main">
               <a:ext uri="{FF2B5EF4-FFF2-40B4-BE49-F238E27FC236}">
-                <a16:creationId xmlns:a16="http://schemas.microsoft.com/office/drawing/2014/main" id="{F85EDBC4-C9DB-47F9-A15F-259309E11138}"/>
+                <a16:creationId xmlns:a16="http://schemas.microsoft.com/office/drawing/2014/main" id="{0B78E9C0-5FFC-4EA9-B7E3-BF21BA680C29}"/>
               </a:ext>
             </a:extLst>
           </p:cNvPr>
@@ -9864,7 +9864,7 @@
           <p:cNvPr id="19" name="">
             <a:extLst xmlns:a="http://schemas.openxmlformats.org/drawingml/2006/main">
               <a:ext uri="{FF2B5EF4-FFF2-40B4-BE49-F238E27FC236}">
-                <a16:creationId xmlns:a16="http://schemas.microsoft.com/office/drawing/2014/main" id="{0394B54B-FC13-4DC2-A313-F5AF6A2B6E9E}"/>
+                <a16:creationId xmlns:a16="http://schemas.microsoft.com/office/drawing/2014/main" id="{C56332D0-1970-41DD-AA4F-80B0D0A2524E}"/>
               </a:ext>
             </a:extLst>
           </p:cNvPr>
@@ -9928,7 +9928,7 @@
           <p:cNvPr id="20" name="">
             <a:extLst xmlns:a="http://schemas.openxmlformats.org/drawingml/2006/main">
               <a:ext uri="{FF2B5EF4-FFF2-40B4-BE49-F238E27FC236}">
-                <a16:creationId xmlns:a16="http://schemas.microsoft.com/office/drawing/2014/main" id="{C2F25F5F-5205-4437-BE4A-6EF62314D955}"/>
+                <a16:creationId xmlns:a16="http://schemas.microsoft.com/office/drawing/2014/main" id="{193E57FB-4DC5-4791-819E-3213F355B6C8}"/>
               </a:ext>
             </a:extLst>
           </p:cNvPr>
@@ -9992,7 +9992,7 @@
           <p:cNvPr id="21" name="">
             <a:extLst xmlns:a="http://schemas.openxmlformats.org/drawingml/2006/main">
               <a:ext uri="{FF2B5EF4-FFF2-40B4-BE49-F238E27FC236}">
-                <a16:creationId xmlns:a16="http://schemas.microsoft.com/office/drawing/2014/main" id="{97706AB5-15CC-4911-98E6-089CAB5F6830}"/>
+                <a16:creationId xmlns:a16="http://schemas.microsoft.com/office/drawing/2014/main" id="{33AD70CB-CB87-4A08-9F1A-4C44B3A8FDF5}"/>
               </a:ext>
             </a:extLst>
           </p:cNvPr>
@@ -10054,7 +10054,7 @@
     </p:spTree>
     <p:extLst>
       <p:ext uri="{BB962C8B-B14F-4D97-AF65-F5344CB8AC3E}">
-        <p14:creationId xmlns:p14="http://schemas.microsoft.com/office/powerpoint/2010/main" val="840809064"/>
+        <p14:creationId xmlns:p14="http://schemas.microsoft.com/office/powerpoint/2010/main" val="2097412590"/>
       </p:ext>
     </p:extLst>
   </p:cSld>

</xml_diff>